<commit_message>
feat: téléchargement du ppt avec le titre du projet
</commit_message>
<xml_diff>
--- a/public/templates/template_synthese_projet.pptx
+++ b/public/templates/template_synthese_projet.pptx
@@ -261,7 +261,7 @@
           <a:p>
             <a:fld id="{82E7F8B9-DFDB-4965-877D-C04A580740C9}" type="datetimeFigureOut">
               <a:rPr lang="fr-FR" smtClean="0"/>
-              <a:t>19/06/2026</a:t>
+              <a:t>28/08/2026</a:t>
             </a:fld>
             <a:endParaRPr lang="fr-FR"/>
           </a:p>
@@ -459,7 +459,7 @@
           <a:p>
             <a:fld id="{82E7F8B9-DFDB-4965-877D-C04A580740C9}" type="datetimeFigureOut">
               <a:rPr lang="fr-FR" smtClean="0"/>
-              <a:t>19/06/2026</a:t>
+              <a:t>28/08/2026</a:t>
             </a:fld>
             <a:endParaRPr lang="fr-FR"/>
           </a:p>
@@ -667,7 +667,7 @@
           <a:p>
             <a:fld id="{82E7F8B9-DFDB-4965-877D-C04A580740C9}" type="datetimeFigureOut">
               <a:rPr lang="fr-FR" smtClean="0"/>
-              <a:t>19/06/2026</a:t>
+              <a:t>28/08/2026</a:t>
             </a:fld>
             <a:endParaRPr lang="fr-FR"/>
           </a:p>
@@ -865,7 +865,7 @@
           <a:p>
             <a:fld id="{82E7F8B9-DFDB-4965-877D-C04A580740C9}" type="datetimeFigureOut">
               <a:rPr lang="fr-FR" smtClean="0"/>
-              <a:t>19/06/2026</a:t>
+              <a:t>28/08/2026</a:t>
             </a:fld>
             <a:endParaRPr lang="fr-FR"/>
           </a:p>
@@ -1140,7 +1140,7 @@
           <a:p>
             <a:fld id="{82E7F8B9-DFDB-4965-877D-C04A580740C9}" type="datetimeFigureOut">
               <a:rPr lang="fr-FR" smtClean="0"/>
-              <a:t>19/06/2026</a:t>
+              <a:t>28/08/2026</a:t>
             </a:fld>
             <a:endParaRPr lang="fr-FR"/>
           </a:p>
@@ -1405,7 +1405,7 @@
           <a:p>
             <a:fld id="{82E7F8B9-DFDB-4965-877D-C04A580740C9}" type="datetimeFigureOut">
               <a:rPr lang="fr-FR" smtClean="0"/>
-              <a:t>19/06/2026</a:t>
+              <a:t>28/08/2026</a:t>
             </a:fld>
             <a:endParaRPr lang="fr-FR"/>
           </a:p>
@@ -1817,7 +1817,7 @@
           <a:p>
             <a:fld id="{82E7F8B9-DFDB-4965-877D-C04A580740C9}" type="datetimeFigureOut">
               <a:rPr lang="fr-FR" smtClean="0"/>
-              <a:t>19/06/2026</a:t>
+              <a:t>28/08/2026</a:t>
             </a:fld>
             <a:endParaRPr lang="fr-FR"/>
           </a:p>
@@ -1958,7 +1958,7 @@
           <a:p>
             <a:fld id="{82E7F8B9-DFDB-4965-877D-C04A580740C9}" type="datetimeFigureOut">
               <a:rPr lang="fr-FR" smtClean="0"/>
-              <a:t>19/06/2026</a:t>
+              <a:t>28/08/2026</a:t>
             </a:fld>
             <a:endParaRPr lang="fr-FR"/>
           </a:p>
@@ -2071,7 +2071,7 @@
           <a:p>
             <a:fld id="{82E7F8B9-DFDB-4965-877D-C04A580740C9}" type="datetimeFigureOut">
               <a:rPr lang="fr-FR" smtClean="0"/>
-              <a:t>19/06/2026</a:t>
+              <a:t>28/08/2026</a:t>
             </a:fld>
             <a:endParaRPr lang="fr-FR"/>
           </a:p>
@@ -2382,7 +2382,7 @@
           <a:p>
             <a:fld id="{82E7F8B9-DFDB-4965-877D-C04A580740C9}" type="datetimeFigureOut">
               <a:rPr lang="fr-FR" smtClean="0"/>
-              <a:t>19/06/2026</a:t>
+              <a:t>28/08/2026</a:t>
             </a:fld>
             <a:endParaRPr lang="fr-FR"/>
           </a:p>
@@ -2670,7 +2670,7 @@
           <a:p>
             <a:fld id="{82E7F8B9-DFDB-4965-877D-C04A580740C9}" type="datetimeFigureOut">
               <a:rPr lang="fr-FR" smtClean="0"/>
-              <a:t>19/06/2026</a:t>
+              <a:t>28/08/2026</a:t>
             </a:fld>
             <a:endParaRPr lang="fr-FR"/>
           </a:p>
@@ -2911,7 +2911,7 @@
           <a:p>
             <a:fld id="{82E7F8B9-DFDB-4965-877D-C04A580740C9}" type="datetimeFigureOut">
               <a:rPr lang="fr-FR" smtClean="0"/>
-              <a:t>19/06/2026</a:t>
+              <a:t>28/08/2026</a:t>
             </a:fld>
             <a:endParaRPr lang="fr-FR"/>
           </a:p>

</xml_diff>

<commit_message>
feat: finalisation de la page de garde de la synthèse
</commit_message>
<xml_diff>
--- a/public/templates/template_synthese_projet.pptx
+++ b/public/templates/template_synthese_projet.pptx
@@ -261,7 +261,7 @@
           <a:p>
             <a:fld id="{82E7F8B9-DFDB-4965-877D-C04A580740C9}" type="datetimeFigureOut">
               <a:rPr lang="fr-FR" smtClean="0"/>
-              <a:t>28/08/2026</a:t>
+              <a:t>29/08/2026</a:t>
             </a:fld>
             <a:endParaRPr lang="fr-FR"/>
           </a:p>
@@ -459,7 +459,7 @@
           <a:p>
             <a:fld id="{82E7F8B9-DFDB-4965-877D-C04A580740C9}" type="datetimeFigureOut">
               <a:rPr lang="fr-FR" smtClean="0"/>
-              <a:t>28/08/2026</a:t>
+              <a:t>29/08/2026</a:t>
             </a:fld>
             <a:endParaRPr lang="fr-FR"/>
           </a:p>
@@ -667,7 +667,7 @@
           <a:p>
             <a:fld id="{82E7F8B9-DFDB-4965-877D-C04A580740C9}" type="datetimeFigureOut">
               <a:rPr lang="fr-FR" smtClean="0"/>
-              <a:t>28/08/2026</a:t>
+              <a:t>29/08/2026</a:t>
             </a:fld>
             <a:endParaRPr lang="fr-FR"/>
           </a:p>
@@ -865,7 +865,7 @@
           <a:p>
             <a:fld id="{82E7F8B9-DFDB-4965-877D-C04A580740C9}" type="datetimeFigureOut">
               <a:rPr lang="fr-FR" smtClean="0"/>
-              <a:t>28/08/2026</a:t>
+              <a:t>29/08/2026</a:t>
             </a:fld>
             <a:endParaRPr lang="fr-FR"/>
           </a:p>
@@ -1140,7 +1140,7 @@
           <a:p>
             <a:fld id="{82E7F8B9-DFDB-4965-877D-C04A580740C9}" type="datetimeFigureOut">
               <a:rPr lang="fr-FR" smtClean="0"/>
-              <a:t>28/08/2026</a:t>
+              <a:t>29/08/2026</a:t>
             </a:fld>
             <a:endParaRPr lang="fr-FR"/>
           </a:p>
@@ -1405,7 +1405,7 @@
           <a:p>
             <a:fld id="{82E7F8B9-DFDB-4965-877D-C04A580740C9}" type="datetimeFigureOut">
               <a:rPr lang="fr-FR" smtClean="0"/>
-              <a:t>28/08/2026</a:t>
+              <a:t>29/08/2026</a:t>
             </a:fld>
             <a:endParaRPr lang="fr-FR"/>
           </a:p>
@@ -1817,7 +1817,7 @@
           <a:p>
             <a:fld id="{82E7F8B9-DFDB-4965-877D-C04A580740C9}" type="datetimeFigureOut">
               <a:rPr lang="fr-FR" smtClean="0"/>
-              <a:t>28/08/2026</a:t>
+              <a:t>29/08/2026</a:t>
             </a:fld>
             <a:endParaRPr lang="fr-FR"/>
           </a:p>
@@ -1958,7 +1958,7 @@
           <a:p>
             <a:fld id="{82E7F8B9-DFDB-4965-877D-C04A580740C9}" type="datetimeFigureOut">
               <a:rPr lang="fr-FR" smtClean="0"/>
-              <a:t>28/08/2026</a:t>
+              <a:t>29/08/2026</a:t>
             </a:fld>
             <a:endParaRPr lang="fr-FR"/>
           </a:p>
@@ -2071,7 +2071,7 @@
           <a:p>
             <a:fld id="{82E7F8B9-DFDB-4965-877D-C04A580740C9}" type="datetimeFigureOut">
               <a:rPr lang="fr-FR" smtClean="0"/>
-              <a:t>28/08/2026</a:t>
+              <a:t>29/08/2026</a:t>
             </a:fld>
             <a:endParaRPr lang="fr-FR"/>
           </a:p>
@@ -2382,7 +2382,7 @@
           <a:p>
             <a:fld id="{82E7F8B9-DFDB-4965-877D-C04A580740C9}" type="datetimeFigureOut">
               <a:rPr lang="fr-FR" smtClean="0"/>
-              <a:t>28/08/2026</a:t>
+              <a:t>29/08/2026</a:t>
             </a:fld>
             <a:endParaRPr lang="fr-FR"/>
           </a:p>
@@ -2670,7 +2670,7 @@
           <a:p>
             <a:fld id="{82E7F8B9-DFDB-4965-877D-C04A580740C9}" type="datetimeFigureOut">
               <a:rPr lang="fr-FR" smtClean="0"/>
-              <a:t>28/08/2026</a:t>
+              <a:t>29/08/2026</a:t>
             </a:fld>
             <a:endParaRPr lang="fr-FR"/>
           </a:p>
@@ -2911,7 +2911,7 @@
           <a:p>
             <a:fld id="{82E7F8B9-DFDB-4965-877D-C04A580740C9}" type="datetimeFigureOut">
               <a:rPr lang="fr-FR" smtClean="0"/>
-              <a:t>28/08/2026</a:t>
+              <a:t>29/08/2026</a:t>
             </a:fld>
             <a:endParaRPr lang="fr-FR"/>
           </a:p>
@@ -3346,24 +3346,38 @@
         </p:nvSpPr>
         <p:spPr>
           <a:xfrm>
-            <a:off x="1524000" y="1122363"/>
-            <a:ext cx="9144000" cy="1071377"/>
+            <a:off x="1693485" y="1845202"/>
+            <a:ext cx="8805030" cy="1655762"/>
           </a:xfrm>
         </p:spPr>
         <p:txBody>
-          <a:bodyPr/>
-          <a:lstStyle/>
-          <a:p>
-            <a:r>
-              <a:rPr lang="fr-FR" dirty="0"/>
+          <a:bodyPr>
+            <a:normAutofit/>
+          </a:bodyPr>
+          <a:lstStyle/>
+          <a:p>
+            <a:r>
+              <a:rPr lang="fr-FR" sz="3800" dirty="0">
+                <a:latin typeface="Calibri" panose="020F0502020204030204" pitchFamily="34" charset="0"/>
+                <a:ea typeface="Calibri" panose="020F0502020204030204" pitchFamily="34" charset="0"/>
+                <a:cs typeface="Calibri" panose="020F0502020204030204" pitchFamily="34" charset="0"/>
+              </a:rPr>
               <a:t>{{</a:t>
             </a:r>
             <a:r>
-              <a:rPr lang="fr-FR" dirty="0" err="1"/>
+              <a:rPr lang="fr-FR" sz="3800" dirty="0" err="1">
+                <a:latin typeface="Calibri" panose="020F0502020204030204" pitchFamily="34" charset="0"/>
+                <a:ea typeface="Calibri" panose="020F0502020204030204" pitchFamily="34" charset="0"/>
+                <a:cs typeface="Calibri" panose="020F0502020204030204" pitchFamily="34" charset="0"/>
+              </a:rPr>
               <a:t>nom_projet</a:t>
             </a:r>
             <a:r>
-              <a:rPr lang="fr-FR" dirty="0"/>
+              <a:rPr lang="fr-FR" sz="3800" dirty="0">
+                <a:latin typeface="Calibri" panose="020F0502020204030204" pitchFamily="34" charset="0"/>
+                <a:ea typeface="Calibri" panose="020F0502020204030204" pitchFamily="34" charset="0"/>
+                <a:cs typeface="Calibri" panose="020F0502020204030204" pitchFamily="34" charset="0"/>
+              </a:rPr>
               <a:t>}}</a:t>
             </a:r>
           </a:p>
@@ -3385,43 +3399,288 @@
             <p:ph type="subTitle" idx="1"/>
           </p:nvPr>
         </p:nvSpPr>
-        <p:spPr/>
+        <p:spPr>
+          <a:xfrm>
+            <a:off x="1524000" y="4237607"/>
+            <a:ext cx="9144000" cy="1655762"/>
+          </a:xfrm>
+        </p:spPr>
         <p:txBody>
           <a:bodyPr>
-            <a:normAutofit lnSpcReduction="10000"/>
+            <a:normAutofit/>
           </a:bodyPr>
           <a:lstStyle/>
           <a:p>
             <a:r>
-              <a:rPr lang="fr-FR" dirty="0"/>
-              <a:t>{{commune}}</a:t>
-            </a:r>
-          </a:p>
-          <a:p>
-            <a:r>
-              <a:rPr lang="fr-FR" dirty="0"/>
-              <a:t>{{adresse}}</a:t>
-            </a:r>
-          </a:p>
-          <a:p>
-            <a:r>
-              <a:rPr lang="fr-FR" dirty="0"/>
-              <a:t>{{budget}}</a:t>
-            </a:r>
-          </a:p>
-          <a:p>
-            <a:r>
-              <a:rPr lang="fr-FR" dirty="0"/>
+              <a:rPr lang="fr-FR" sz="1600" dirty="0">
+                <a:latin typeface="Calibri" panose="020F0502020204030204" pitchFamily="34" charset="0"/>
+                <a:ea typeface="Calibri" panose="020F0502020204030204" pitchFamily="34" charset="0"/>
+                <a:cs typeface="Calibri" panose="020F0502020204030204" pitchFamily="34" charset="0"/>
+              </a:rPr>
               <a:t>{{</a:t>
             </a:r>
             <a:r>
-              <a:rPr lang="fr-FR" dirty="0" err="1"/>
-              <a:t>date_livraison</a:t>
-            </a:r>
-            <a:r>
-              <a:rPr lang="fr-FR" dirty="0"/>
+              <a:rPr lang="fr-FR" sz="1600" dirty="0" err="1">
+                <a:latin typeface="Calibri" panose="020F0502020204030204" pitchFamily="34" charset="0"/>
+                <a:ea typeface="Calibri" panose="020F0502020204030204" pitchFamily="34" charset="0"/>
+                <a:cs typeface="Calibri" panose="020F0502020204030204" pitchFamily="34" charset="0"/>
+              </a:rPr>
+              <a:t>commune_projet</a:t>
+            </a:r>
+            <a:r>
+              <a:rPr lang="fr-FR" sz="1600" dirty="0">
+                <a:latin typeface="Calibri" panose="020F0502020204030204" pitchFamily="34" charset="0"/>
+                <a:ea typeface="Calibri" panose="020F0502020204030204" pitchFamily="34" charset="0"/>
+                <a:cs typeface="Calibri" panose="020F0502020204030204" pitchFamily="34" charset="0"/>
+              </a:rPr>
+              <a:t>}} ({{</a:t>
+            </a:r>
+            <a:r>
+              <a:rPr lang="fr-FR" sz="1600" dirty="0" err="1">
+                <a:latin typeface="Calibri" panose="020F0502020204030204" pitchFamily="34" charset="0"/>
+                <a:ea typeface="Calibri" panose="020F0502020204030204" pitchFamily="34" charset="0"/>
+                <a:cs typeface="Calibri" panose="020F0502020204030204" pitchFamily="34" charset="0"/>
+              </a:rPr>
+              <a:t>code_postal_projet</a:t>
+            </a:r>
+            <a:r>
+              <a:rPr lang="fr-FR" sz="1600" dirty="0">
+                <a:latin typeface="Calibri" panose="020F0502020204030204" pitchFamily="34" charset="0"/>
+                <a:ea typeface="Calibri" panose="020F0502020204030204" pitchFamily="34" charset="0"/>
+                <a:cs typeface="Calibri" panose="020F0502020204030204" pitchFamily="34" charset="0"/>
+              </a:rPr>
+              <a:t>}})</a:t>
+            </a:r>
+          </a:p>
+          <a:p>
+            <a:r>
+              <a:rPr lang="fr-FR" sz="1600" dirty="0">
+                <a:latin typeface="Calibri" panose="020F0502020204030204" pitchFamily="34" charset="0"/>
+                <a:ea typeface="Calibri" panose="020F0502020204030204" pitchFamily="34" charset="0"/>
+                <a:cs typeface="Calibri" panose="020F0502020204030204" pitchFamily="34" charset="0"/>
+              </a:rPr>
+              <a:t>{{</a:t>
+            </a:r>
+            <a:r>
+              <a:rPr lang="fr-FR" sz="1600" dirty="0" err="1">
+                <a:latin typeface="Calibri" panose="020F0502020204030204" pitchFamily="34" charset="0"/>
+                <a:ea typeface="Calibri" panose="020F0502020204030204" pitchFamily="34" charset="0"/>
+                <a:cs typeface="Calibri" panose="020F0502020204030204" pitchFamily="34" charset="0"/>
+              </a:rPr>
+              <a:t>adresse_projet</a:t>
+            </a:r>
+            <a:r>
+              <a:rPr lang="fr-FR" sz="1600" dirty="0">
+                <a:latin typeface="Calibri" panose="020F0502020204030204" pitchFamily="34" charset="0"/>
+                <a:ea typeface="Calibri" panose="020F0502020204030204" pitchFamily="34" charset="0"/>
+                <a:cs typeface="Calibri" panose="020F0502020204030204" pitchFamily="34" charset="0"/>
+              </a:rPr>
               <a:t>}}</a:t>
             </a:r>
+          </a:p>
+        </p:txBody>
+      </p:sp>
+      <p:pic>
+        <p:nvPicPr>
+          <p:cNvPr id="4" name="Picture 2" descr="L'agence de la transition écologique - ADEME">
+            <a:extLst>
+              <a:ext uri="{FF2B5EF4-FFF2-40B4-BE49-F238E27FC236}">
+                <a16:creationId xmlns:a16="http://schemas.microsoft.com/office/drawing/2014/main" id="{B6E6D3F6-9BA9-58C1-F95E-456440679225}"/>
+              </a:ext>
+            </a:extLst>
+          </p:cNvPr>
+          <p:cNvPicPr>
+            <a:picLocks noChangeAspect="1"/>
+          </p:cNvPicPr>
+          <p:nvPr/>
+        </p:nvPicPr>
+        <p:blipFill>
+          <a:blip r:embed="rId2"/>
+          <a:stretch>
+            <a:fillRect/>
+          </a:stretch>
+        </p:blipFill>
+        <p:spPr>
+          <a:xfrm>
+            <a:off x="364435" y="199707"/>
+            <a:ext cx="949579" cy="1119802"/>
+          </a:xfrm>
+          <a:prstGeom prst="rect">
+            <a:avLst/>
+          </a:prstGeom>
+        </p:spPr>
+      </p:pic>
+      <p:pic>
+        <p:nvPicPr>
+          <p:cNvPr id="5" name="Picture 1">
+            <a:extLst>
+              <a:ext uri="{FF2B5EF4-FFF2-40B4-BE49-F238E27FC236}">
+                <a16:creationId xmlns:a16="http://schemas.microsoft.com/office/drawing/2014/main" id="{7E542749-53FE-0587-7981-2109CA078F11}"/>
+              </a:ext>
+            </a:extLst>
+          </p:cNvPr>
+          <p:cNvPicPr>
+            <a:picLocks noChangeAspect="1"/>
+          </p:cNvPicPr>
+          <p:nvPr/>
+        </p:nvPicPr>
+        <p:blipFill>
+          <a:blip r:embed="rId3"/>
+          <a:stretch>
+            <a:fillRect/>
+          </a:stretch>
+        </p:blipFill>
+        <p:spPr>
+          <a:xfrm>
+            <a:off x="10367627" y="257327"/>
+            <a:ext cx="1552051" cy="758533"/>
+          </a:xfrm>
+          <a:prstGeom prst="rect">
+            <a:avLst/>
+          </a:prstGeom>
+        </p:spPr>
+      </p:pic>
+      <p:sp>
+        <p:nvSpPr>
+          <p:cNvPr id="6" name="Text 10">
+            <a:extLst>
+              <a:ext uri="{FF2B5EF4-FFF2-40B4-BE49-F238E27FC236}">
+                <a16:creationId xmlns:a16="http://schemas.microsoft.com/office/drawing/2014/main" id="{8CD713CB-3BC6-C09D-7C54-788D2169DE28}"/>
+              </a:ext>
+            </a:extLst>
+          </p:cNvPr>
+          <p:cNvSpPr/>
+          <p:nvPr/>
+        </p:nvSpPr>
+        <p:spPr>
+          <a:xfrm>
+            <a:off x="2072640" y="6385100"/>
+            <a:ext cx="8046720" cy="201168"/>
+          </a:xfrm>
+          <a:prstGeom prst="rect">
+            <a:avLst/>
+          </a:prstGeom>
+          <a:noFill/>
+          <a:ln/>
+        </p:spPr>
+        <p:txBody>
+          <a:bodyPr wrap="square" lIns="0" tIns="0" rIns="0" bIns="0" rtlCol="0" anchor="ctr"/>
+          <a:lstStyle/>
+          <a:p>
+            <a:pPr marL="0" indent="0" algn="ctr">
+              <a:buNone/>
+            </a:pPr>
+            <a:r>
+              <a:rPr lang="en-US" sz="1000" i="1" dirty="0" err="1">
+                <a:solidFill>
+                  <a:srgbClr val="A0A0A0"/>
+                </a:solidFill>
+                <a:latin typeface="Calibri" pitchFamily="34" charset="0"/>
+                <a:ea typeface="Calibri" pitchFamily="34" charset="-122"/>
+                <a:cs typeface="Calibri" pitchFamily="34" charset="-120"/>
+              </a:rPr>
+              <a:t>Projet</a:t>
+            </a:r>
+            <a:r>
+              <a:rPr lang="en-US" sz="1000" i="1" dirty="0">
+                <a:solidFill>
+                  <a:srgbClr val="A0A0A0"/>
+                </a:solidFill>
+                <a:latin typeface="Calibri" pitchFamily="34" charset="0"/>
+                <a:ea typeface="Calibri" pitchFamily="34" charset="-122"/>
+                <a:cs typeface="Calibri" pitchFamily="34" charset="-120"/>
+              </a:rPr>
+              <a:t> </a:t>
+            </a:r>
+            <a:r>
+              <a:rPr lang="en-US" sz="1000" i="1" dirty="0" err="1">
+                <a:solidFill>
+                  <a:srgbClr val="A0A0A0"/>
+                </a:solidFill>
+                <a:latin typeface="Calibri" pitchFamily="34" charset="0"/>
+                <a:ea typeface="Calibri" pitchFamily="34" charset="-122"/>
+                <a:cs typeface="Calibri" pitchFamily="34" charset="-120"/>
+              </a:rPr>
+              <a:t>généré</a:t>
+            </a:r>
+            <a:r>
+              <a:rPr lang="en-US" sz="1000" i="1" dirty="0">
+                <a:solidFill>
+                  <a:srgbClr val="A0A0A0"/>
+                </a:solidFill>
+                <a:latin typeface="Calibri" pitchFamily="34" charset="0"/>
+                <a:ea typeface="Calibri" pitchFamily="34" charset="-122"/>
+                <a:cs typeface="Calibri" pitchFamily="34" charset="-120"/>
+              </a:rPr>
+              <a:t> le {{</a:t>
+            </a:r>
+            <a:r>
+              <a:rPr lang="en-US" sz="1000" i="1" dirty="0" err="1">
+                <a:solidFill>
+                  <a:srgbClr val="A0A0A0"/>
+                </a:solidFill>
+                <a:latin typeface="Calibri" pitchFamily="34" charset="0"/>
+                <a:ea typeface="Calibri" pitchFamily="34" charset="-122"/>
+                <a:cs typeface="Calibri" pitchFamily="34" charset="-120"/>
+              </a:rPr>
+              <a:t>date_generation_synthese</a:t>
+            </a:r>
+            <a:r>
+              <a:rPr lang="en-US" sz="1000" i="1" dirty="0">
+                <a:solidFill>
+                  <a:srgbClr val="A0A0A0"/>
+                </a:solidFill>
+                <a:latin typeface="Calibri" pitchFamily="34" charset="0"/>
+                <a:ea typeface="Calibri" pitchFamily="34" charset="-122"/>
+                <a:cs typeface="Calibri" pitchFamily="34" charset="-120"/>
+              </a:rPr>
+              <a:t>}} via Plus </a:t>
+            </a:r>
+            <a:r>
+              <a:rPr lang="en-US" sz="1000" i="1" dirty="0" err="1">
+                <a:solidFill>
+                  <a:srgbClr val="A0A0A0"/>
+                </a:solidFill>
+                <a:latin typeface="Calibri" pitchFamily="34" charset="0"/>
+                <a:ea typeface="Calibri" pitchFamily="34" charset="-122"/>
+                <a:cs typeface="Calibri" pitchFamily="34" charset="-120"/>
+              </a:rPr>
+              <a:t>fraîche</a:t>
+            </a:r>
+            <a:r>
+              <a:rPr lang="en-US" sz="1000" i="1" dirty="0">
+                <a:solidFill>
+                  <a:srgbClr val="A0A0A0"/>
+                </a:solidFill>
+                <a:latin typeface="Calibri" pitchFamily="34" charset="0"/>
+                <a:ea typeface="Calibri" pitchFamily="34" charset="-122"/>
+                <a:cs typeface="Calibri" pitchFamily="34" charset="-120"/>
+              </a:rPr>
+              <a:t> ma </a:t>
+            </a:r>
+            <a:r>
+              <a:rPr lang="en-US" sz="1000" i="1" dirty="0" err="1">
+                <a:solidFill>
+                  <a:srgbClr val="A0A0A0"/>
+                </a:solidFill>
+                <a:latin typeface="Calibri" pitchFamily="34" charset="0"/>
+                <a:ea typeface="Calibri" pitchFamily="34" charset="-122"/>
+                <a:cs typeface="Calibri" pitchFamily="34" charset="-120"/>
+              </a:rPr>
+              <a:t>ville</a:t>
+            </a:r>
+            <a:r>
+              <a:rPr lang="en-US" sz="1000" i="1" dirty="0">
+                <a:solidFill>
+                  <a:srgbClr val="A0A0A0"/>
+                </a:solidFill>
+                <a:latin typeface="Calibri" pitchFamily="34" charset="0"/>
+                <a:ea typeface="Calibri" pitchFamily="34" charset="-122"/>
+                <a:cs typeface="Calibri" pitchFamily="34" charset="-120"/>
+              </a:rPr>
+              <a:t> (ADEME)</a:t>
+            </a:r>
+            <a:endParaRPr lang="en-US" sz="1000" dirty="0"/>
           </a:p>
         </p:txBody>
       </p:sp>

</xml_diff>

<commit_message>
feat: page d'intro des fiches solution
</commit_message>
<xml_diff>
--- a/public/templates/template_synthese_projet.pptx
+++ b/public/templates/template_synthese_projet.pptx
@@ -4,10 +4,15 @@
   <p:sldMasterIdLst>
     <p:sldMasterId id="2147483648" r:id="rId1"/>
   </p:sldMasterIdLst>
+  <p:notesMasterIdLst>
+    <p:notesMasterId r:id="rId7"/>
+  </p:notesMasterIdLst>
   <p:sldIdLst>
     <p:sldId id="256" r:id="rId2"/>
-    <p:sldId id="257" r:id="rId3"/>
-    <p:sldId id="258" r:id="rId4"/>
+    <p:sldId id="264" r:id="rId3"/>
+    <p:sldId id="266" r:id="rId4"/>
+    <p:sldId id="257" r:id="rId5"/>
+    <p:sldId id="258" r:id="rId6"/>
   </p:sldIdLst>
   <p:sldSz cx="12192000" cy="6858000"/>
   <p:notesSz cx="6858000" cy="9144000"/>
@@ -114,6 +119,463 @@
 </p:presentation>
 </file>
 
+<file path=ppt/notesMasters/notesMaster1.xml><?xml version="1.0" encoding="utf-8"?>
+<p:notesMaster xmlns:a="http://schemas.openxmlformats.org/drawingml/2006/main" xmlns:r="http://schemas.openxmlformats.org/officeDocument/2006/relationships" xmlns:p="http://schemas.openxmlformats.org/presentationml/2006/main">
+  <p:cSld>
+    <p:bg>
+      <p:bgRef idx="1001">
+        <a:schemeClr val="bg1"/>
+      </p:bgRef>
+    </p:bg>
+    <p:spTree>
+      <p:nvGrpSpPr>
+        <p:cNvPr id="1" name=""/>
+        <p:cNvGrpSpPr/>
+        <p:nvPr/>
+      </p:nvGrpSpPr>
+      <p:grpSpPr>
+        <a:xfrm>
+          <a:off x="0" y="0"/>
+          <a:ext cx="0" cy="0"/>
+          <a:chOff x="0" y="0"/>
+          <a:chExt cx="0" cy="0"/>
+        </a:xfrm>
+      </p:grpSpPr>
+      <p:sp>
+        <p:nvSpPr>
+          <p:cNvPr id="2" name="Espace réservé de l'en-tête 1"/>
+          <p:cNvSpPr>
+            <a:spLocks noGrp="1"/>
+          </p:cNvSpPr>
+          <p:nvPr>
+            <p:ph type="hdr" sz="quarter"/>
+          </p:nvPr>
+        </p:nvSpPr>
+        <p:spPr>
+          <a:xfrm>
+            <a:off x="0" y="0"/>
+            <a:ext cx="2971800" cy="458788"/>
+          </a:xfrm>
+          <a:prstGeom prst="rect">
+            <a:avLst/>
+          </a:prstGeom>
+        </p:spPr>
+        <p:txBody>
+          <a:bodyPr vert="horz" lIns="91440" tIns="45720" rIns="91440" bIns="45720" rtlCol="0"/>
+          <a:lstStyle>
+            <a:lvl1pPr algn="l">
+              <a:defRPr sz="1200"/>
+            </a:lvl1pPr>
+          </a:lstStyle>
+          <a:p>
+            <a:endParaRPr lang="fr-FR"/>
+          </a:p>
+        </p:txBody>
+      </p:sp>
+      <p:sp>
+        <p:nvSpPr>
+          <p:cNvPr id="3" name="Espace réservé de la date 2"/>
+          <p:cNvSpPr>
+            <a:spLocks noGrp="1"/>
+          </p:cNvSpPr>
+          <p:nvPr>
+            <p:ph type="dt" idx="1"/>
+          </p:nvPr>
+        </p:nvSpPr>
+        <p:spPr>
+          <a:xfrm>
+            <a:off x="3884613" y="0"/>
+            <a:ext cx="2971800" cy="458788"/>
+          </a:xfrm>
+          <a:prstGeom prst="rect">
+            <a:avLst/>
+          </a:prstGeom>
+        </p:spPr>
+        <p:txBody>
+          <a:bodyPr vert="horz" lIns="91440" tIns="45720" rIns="91440" bIns="45720" rtlCol="0"/>
+          <a:lstStyle>
+            <a:lvl1pPr algn="r">
+              <a:defRPr sz="1200"/>
+            </a:lvl1pPr>
+          </a:lstStyle>
+          <a:p>
+            <a:fld id="{4C638A9C-6ED0-4718-B5E7-9D405962C144}" type="datetimeFigureOut">
+              <a:rPr lang="fr-FR" smtClean="0"/>
+              <a:t>29/08/2026</a:t>
+            </a:fld>
+            <a:endParaRPr lang="fr-FR"/>
+          </a:p>
+        </p:txBody>
+      </p:sp>
+      <p:sp>
+        <p:nvSpPr>
+          <p:cNvPr id="4" name="Espace réservé de l'image des diapositives 3"/>
+          <p:cNvSpPr>
+            <a:spLocks noGrp="1" noRot="1" noChangeAspect="1"/>
+          </p:cNvSpPr>
+          <p:nvPr>
+            <p:ph type="sldImg" idx="2"/>
+          </p:nvPr>
+        </p:nvSpPr>
+        <p:spPr>
+          <a:xfrm>
+            <a:off x="685800" y="1143000"/>
+            <a:ext cx="5486400" cy="3086100"/>
+          </a:xfrm>
+          <a:prstGeom prst="rect">
+            <a:avLst/>
+          </a:prstGeom>
+          <a:noFill/>
+          <a:ln w="12700">
+            <a:solidFill>
+              <a:prstClr val="black"/>
+            </a:solidFill>
+          </a:ln>
+        </p:spPr>
+        <p:txBody>
+          <a:bodyPr vert="horz" lIns="91440" tIns="45720" rIns="91440" bIns="45720" rtlCol="0" anchor="ctr"/>
+          <a:lstStyle/>
+          <a:p>
+            <a:endParaRPr lang="fr-FR"/>
+          </a:p>
+        </p:txBody>
+      </p:sp>
+      <p:sp>
+        <p:nvSpPr>
+          <p:cNvPr id="5" name="Espace réservé des notes 4"/>
+          <p:cNvSpPr>
+            <a:spLocks noGrp="1"/>
+          </p:cNvSpPr>
+          <p:nvPr>
+            <p:ph type="body" sz="quarter" idx="3"/>
+          </p:nvPr>
+        </p:nvSpPr>
+        <p:spPr>
+          <a:xfrm>
+            <a:off x="685800" y="4400550"/>
+            <a:ext cx="5486400" cy="3600450"/>
+          </a:xfrm>
+          <a:prstGeom prst="rect">
+            <a:avLst/>
+          </a:prstGeom>
+        </p:spPr>
+        <p:txBody>
+          <a:bodyPr vert="horz" lIns="91440" tIns="45720" rIns="91440" bIns="45720" rtlCol="0"/>
+          <a:lstStyle/>
+          <a:p>
+            <a:pPr lvl="0"/>
+            <a:r>
+              <a:rPr lang="fr-FR"/>
+              <a:t>Cliquez pour modifier les styles du texte du masque</a:t>
+            </a:r>
+          </a:p>
+          <a:p>
+            <a:pPr lvl="1"/>
+            <a:r>
+              <a:rPr lang="fr-FR"/>
+              <a:t>Deuxième niveau</a:t>
+            </a:r>
+          </a:p>
+          <a:p>
+            <a:pPr lvl="2"/>
+            <a:r>
+              <a:rPr lang="fr-FR"/>
+              <a:t>Troisième niveau</a:t>
+            </a:r>
+          </a:p>
+          <a:p>
+            <a:pPr lvl="3"/>
+            <a:r>
+              <a:rPr lang="fr-FR"/>
+              <a:t>Quatrième niveau</a:t>
+            </a:r>
+          </a:p>
+          <a:p>
+            <a:pPr lvl="4"/>
+            <a:r>
+              <a:rPr lang="fr-FR"/>
+              <a:t>Cinquième niveau</a:t>
+            </a:r>
+          </a:p>
+        </p:txBody>
+      </p:sp>
+      <p:sp>
+        <p:nvSpPr>
+          <p:cNvPr id="6" name="Espace réservé du pied de page 5"/>
+          <p:cNvSpPr>
+            <a:spLocks noGrp="1"/>
+          </p:cNvSpPr>
+          <p:nvPr>
+            <p:ph type="ftr" sz="quarter" idx="4"/>
+          </p:nvPr>
+        </p:nvSpPr>
+        <p:spPr>
+          <a:xfrm>
+            <a:off x="0" y="8685213"/>
+            <a:ext cx="2971800" cy="458787"/>
+          </a:xfrm>
+          <a:prstGeom prst="rect">
+            <a:avLst/>
+          </a:prstGeom>
+        </p:spPr>
+        <p:txBody>
+          <a:bodyPr vert="horz" lIns="91440" tIns="45720" rIns="91440" bIns="45720" rtlCol="0" anchor="b"/>
+          <a:lstStyle>
+            <a:lvl1pPr algn="l">
+              <a:defRPr sz="1200"/>
+            </a:lvl1pPr>
+          </a:lstStyle>
+          <a:p>
+            <a:endParaRPr lang="fr-FR"/>
+          </a:p>
+        </p:txBody>
+      </p:sp>
+      <p:sp>
+        <p:nvSpPr>
+          <p:cNvPr id="7" name="Espace réservé du numéro de diapositive 6"/>
+          <p:cNvSpPr>
+            <a:spLocks noGrp="1"/>
+          </p:cNvSpPr>
+          <p:nvPr>
+            <p:ph type="sldNum" sz="quarter" idx="5"/>
+          </p:nvPr>
+        </p:nvSpPr>
+        <p:spPr>
+          <a:xfrm>
+            <a:off x="3884613" y="8685213"/>
+            <a:ext cx="2971800" cy="458787"/>
+          </a:xfrm>
+          <a:prstGeom prst="rect">
+            <a:avLst/>
+          </a:prstGeom>
+        </p:spPr>
+        <p:txBody>
+          <a:bodyPr vert="horz" lIns="91440" tIns="45720" rIns="91440" bIns="45720" rtlCol="0" anchor="b"/>
+          <a:lstStyle>
+            <a:lvl1pPr algn="r">
+              <a:defRPr sz="1200"/>
+            </a:lvl1pPr>
+          </a:lstStyle>
+          <a:p>
+            <a:fld id="{FD68AD46-B04C-426F-AD53-1ADC867E0120}" type="slidenum">
+              <a:rPr lang="fr-FR" smtClean="0"/>
+              <a:t>‹N°›</a:t>
+            </a:fld>
+            <a:endParaRPr lang="fr-FR"/>
+          </a:p>
+        </p:txBody>
+      </p:sp>
+    </p:spTree>
+    <p:extLst>
+      <p:ext uri="{BB962C8B-B14F-4D97-AF65-F5344CB8AC3E}">
+        <p14:creationId xmlns:p14="http://schemas.microsoft.com/office/powerpoint/2010/main" val="4011162835"/>
+      </p:ext>
+    </p:extLst>
+  </p:cSld>
+  <p:clrMap bg1="lt1" tx1="dk1" bg2="lt2" tx2="dk2" accent1="accent1" accent2="accent2" accent3="accent3" accent4="accent4" accent5="accent5" accent6="accent6" hlink="hlink" folHlink="folHlink"/>
+  <p:notesStyle>
+    <a:lvl1pPr marL="0" algn="l" defTabSz="914400" rtl="0" eaLnBrk="1" latinLnBrk="0" hangingPunct="1">
+      <a:defRPr sz="1200" kern="1200">
+        <a:solidFill>
+          <a:schemeClr val="tx1"/>
+        </a:solidFill>
+        <a:latin typeface="+mn-lt"/>
+        <a:ea typeface="+mn-ea"/>
+        <a:cs typeface="+mn-cs"/>
+      </a:defRPr>
+    </a:lvl1pPr>
+    <a:lvl2pPr marL="457200" algn="l" defTabSz="914400" rtl="0" eaLnBrk="1" latinLnBrk="0" hangingPunct="1">
+      <a:defRPr sz="1200" kern="1200">
+        <a:solidFill>
+          <a:schemeClr val="tx1"/>
+        </a:solidFill>
+        <a:latin typeface="+mn-lt"/>
+        <a:ea typeface="+mn-ea"/>
+        <a:cs typeface="+mn-cs"/>
+      </a:defRPr>
+    </a:lvl2pPr>
+    <a:lvl3pPr marL="914400" algn="l" defTabSz="914400" rtl="0" eaLnBrk="1" latinLnBrk="0" hangingPunct="1">
+      <a:defRPr sz="1200" kern="1200">
+        <a:solidFill>
+          <a:schemeClr val="tx1"/>
+        </a:solidFill>
+        <a:latin typeface="+mn-lt"/>
+        <a:ea typeface="+mn-ea"/>
+        <a:cs typeface="+mn-cs"/>
+      </a:defRPr>
+    </a:lvl3pPr>
+    <a:lvl4pPr marL="1371600" algn="l" defTabSz="914400" rtl="0" eaLnBrk="1" latinLnBrk="0" hangingPunct="1">
+      <a:defRPr sz="1200" kern="1200">
+        <a:solidFill>
+          <a:schemeClr val="tx1"/>
+        </a:solidFill>
+        <a:latin typeface="+mn-lt"/>
+        <a:ea typeface="+mn-ea"/>
+        <a:cs typeface="+mn-cs"/>
+      </a:defRPr>
+    </a:lvl4pPr>
+    <a:lvl5pPr marL="1828800" algn="l" defTabSz="914400" rtl="0" eaLnBrk="1" latinLnBrk="0" hangingPunct="1">
+      <a:defRPr sz="1200" kern="1200">
+        <a:solidFill>
+          <a:schemeClr val="tx1"/>
+        </a:solidFill>
+        <a:latin typeface="+mn-lt"/>
+        <a:ea typeface="+mn-ea"/>
+        <a:cs typeface="+mn-cs"/>
+      </a:defRPr>
+    </a:lvl5pPr>
+    <a:lvl6pPr marL="2286000" algn="l" defTabSz="914400" rtl="0" eaLnBrk="1" latinLnBrk="0" hangingPunct="1">
+      <a:defRPr sz="1200" kern="1200">
+        <a:solidFill>
+          <a:schemeClr val="tx1"/>
+        </a:solidFill>
+        <a:latin typeface="+mn-lt"/>
+        <a:ea typeface="+mn-ea"/>
+        <a:cs typeface="+mn-cs"/>
+      </a:defRPr>
+    </a:lvl6pPr>
+    <a:lvl7pPr marL="2743200" algn="l" defTabSz="914400" rtl="0" eaLnBrk="1" latinLnBrk="0" hangingPunct="1">
+      <a:defRPr sz="1200" kern="1200">
+        <a:solidFill>
+          <a:schemeClr val="tx1"/>
+        </a:solidFill>
+        <a:latin typeface="+mn-lt"/>
+        <a:ea typeface="+mn-ea"/>
+        <a:cs typeface="+mn-cs"/>
+      </a:defRPr>
+    </a:lvl7pPr>
+    <a:lvl8pPr marL="3200400" algn="l" defTabSz="914400" rtl="0" eaLnBrk="1" latinLnBrk="0" hangingPunct="1">
+      <a:defRPr sz="1200" kern="1200">
+        <a:solidFill>
+          <a:schemeClr val="tx1"/>
+        </a:solidFill>
+        <a:latin typeface="+mn-lt"/>
+        <a:ea typeface="+mn-ea"/>
+        <a:cs typeface="+mn-cs"/>
+      </a:defRPr>
+    </a:lvl8pPr>
+    <a:lvl9pPr marL="3657600" algn="l" defTabSz="914400" rtl="0" eaLnBrk="1" latinLnBrk="0" hangingPunct="1">
+      <a:defRPr sz="1200" kern="1200">
+        <a:solidFill>
+          <a:schemeClr val="tx1"/>
+        </a:solidFill>
+        <a:latin typeface="+mn-lt"/>
+        <a:ea typeface="+mn-ea"/>
+        <a:cs typeface="+mn-cs"/>
+      </a:defRPr>
+    </a:lvl9pPr>
+  </p:notesStyle>
+</p:notesMaster>
+</file>
+
+<file path=ppt/notesSlides/notesSlide1.xml><?xml version="1.0" encoding="utf-8"?>
+<p:notes xmlns:a="http://schemas.openxmlformats.org/drawingml/2006/main" xmlns:r="http://schemas.openxmlformats.org/officeDocument/2006/relationships" xmlns:p="http://schemas.openxmlformats.org/presentationml/2006/main">
+  <p:cSld>
+    <p:spTree>
+      <p:nvGrpSpPr>
+        <p:cNvPr id="1" name="">
+          <a:extLst>
+            <a:ext uri="{FF2B5EF4-FFF2-40B4-BE49-F238E27FC236}">
+              <a16:creationId xmlns:a16="http://schemas.microsoft.com/office/drawing/2014/main" id="{048D1F06-EBEC-48E7-718E-679E9C7AB652}"/>
+            </a:ext>
+          </a:extLst>
+        </p:cNvPr>
+        <p:cNvGrpSpPr/>
+        <p:nvPr/>
+      </p:nvGrpSpPr>
+      <p:grpSpPr>
+        <a:xfrm>
+          <a:off x="0" y="0"/>
+          <a:ext cx="0" cy="0"/>
+          <a:chOff x="0" y="0"/>
+          <a:chExt cx="0" cy="0"/>
+        </a:xfrm>
+      </p:grpSpPr>
+      <p:sp>
+        <p:nvSpPr>
+          <p:cNvPr id="2" name="Slide Image Placeholder 1">
+            <a:extLst>
+              <a:ext uri="{FF2B5EF4-FFF2-40B4-BE49-F238E27FC236}">
+                <a16:creationId xmlns:a16="http://schemas.microsoft.com/office/drawing/2014/main" id="{15188976-03C7-BDC5-F35A-502E38D967CC}"/>
+              </a:ext>
+            </a:extLst>
+          </p:cNvPr>
+          <p:cNvSpPr>
+            <a:spLocks noGrp="1" noRot="1" noChangeAspect="1"/>
+          </p:cNvSpPr>
+          <p:nvPr>
+            <p:ph type="sldImg"/>
+          </p:nvPr>
+        </p:nvSpPr>
+        <p:spPr/>
+      </p:sp>
+      <p:sp>
+        <p:nvSpPr>
+          <p:cNvPr id="3" name="Notes Placeholder 2">
+            <a:extLst>
+              <a:ext uri="{FF2B5EF4-FFF2-40B4-BE49-F238E27FC236}">
+                <a16:creationId xmlns:a16="http://schemas.microsoft.com/office/drawing/2014/main" id="{32392900-84C4-792B-45B3-9A38832A4769}"/>
+              </a:ext>
+            </a:extLst>
+          </p:cNvPr>
+          <p:cNvSpPr>
+            <a:spLocks noGrp="1"/>
+          </p:cNvSpPr>
+          <p:nvPr>
+            <p:ph type="body" idx="1"/>
+          </p:nvPr>
+        </p:nvSpPr>
+        <p:spPr/>
+        <p:txBody>
+          <a:bodyPr/>
+          <a:lstStyle/>
+          <a:p>
+            <a:endParaRPr lang="en-US"/>
+          </a:p>
+        </p:txBody>
+      </p:sp>
+      <p:sp>
+        <p:nvSpPr>
+          <p:cNvPr id="4" name="Slide Number Placeholder 3">
+            <a:extLst>
+              <a:ext uri="{FF2B5EF4-FFF2-40B4-BE49-F238E27FC236}">
+                <a16:creationId xmlns:a16="http://schemas.microsoft.com/office/drawing/2014/main" id="{FD3A749C-0CD8-8944-6CB6-BFC00D52AF73}"/>
+              </a:ext>
+            </a:extLst>
+          </p:cNvPr>
+          <p:cNvSpPr>
+            <a:spLocks noGrp="1"/>
+          </p:cNvSpPr>
+          <p:nvPr>
+            <p:ph type="sldNum" sz="quarter" idx="10"/>
+          </p:nvPr>
+        </p:nvSpPr>
+        <p:spPr/>
+        <p:txBody>
+          <a:bodyPr/>
+          <a:lstStyle/>
+          <a:p>
+            <a:fld id="{F7021451-1387-4CA6-816F-3879F97B5CBC}" type="slidenum">
+              <a:rPr lang="en-US"/>
+              <a:t>2</a:t>
+            </a:fld>
+            <a:endParaRPr lang="en-US"/>
+          </a:p>
+        </p:txBody>
+      </p:sp>
+    </p:spTree>
+    <p:extLst>
+      <p:ext uri="{BB962C8B-B14F-4D97-AF65-F5344CB8AC3E}">
+        <p14:creationId xmlns:p14="http://schemas.microsoft.com/office/powerpoint/2010/main" val="2663349773"/>
+      </p:ext>
+    </p:extLst>
+  </p:cSld>
+  <p:clrMapOvr>
+    <a:masterClrMapping/>
+  </p:clrMapOvr>
+</p:notes>
+</file>
+
 <file path=ppt/slideLayouts/slideLayout1.xml><?xml version="1.0" encoding="utf-8"?>
 <p:sldLayout xmlns:a="http://schemas.openxmlformats.org/drawingml/2006/main" xmlns:r="http://schemas.openxmlformats.org/officeDocument/2006/relationships" xmlns:p="http://schemas.openxmlformats.org/presentationml/2006/main" type="title" preserve="1">
   <p:cSld name="Diapositive de titre">
@@ -731,6 +1193,41 @@
     <p:extLst>
       <p:ext uri="{BB962C8B-B14F-4D97-AF65-F5344CB8AC3E}">
         <p14:creationId xmlns:p14="http://schemas.microsoft.com/office/powerpoint/2010/main" val="2785711696"/>
+      </p:ext>
+    </p:extLst>
+  </p:cSld>
+  <p:clrMapOvr>
+    <a:masterClrMapping/>
+  </p:clrMapOvr>
+</p:sldLayout>
+</file>
+
+<file path=ppt/slideLayouts/slideLayout12.xml><?xml version="1.0" encoding="utf-8"?>
+<p:sldLayout xmlns:a="http://schemas.openxmlformats.org/drawingml/2006/main" xmlns:r="http://schemas.openxmlformats.org/officeDocument/2006/relationships" xmlns:p="http://schemas.openxmlformats.org/presentationml/2006/main">
+  <p:cSld name="DEFAULT">
+    <p:bg>
+      <p:bgRef idx="1001">
+        <a:schemeClr val="bg1"/>
+      </p:bgRef>
+    </p:bg>
+    <p:spTree>
+      <p:nvGrpSpPr>
+        <p:cNvPr id="1" name=""/>
+        <p:cNvGrpSpPr/>
+        <p:nvPr/>
+      </p:nvGrpSpPr>
+      <p:grpSpPr>
+        <a:xfrm>
+          <a:off x="0" y="0"/>
+          <a:ext cx="0" cy="0"/>
+          <a:chOff x="0" y="0"/>
+          <a:chExt cx="0" cy="0"/>
+        </a:xfrm>
+      </p:grpSpPr>
+    </p:spTree>
+    <p:extLst>
+      <p:ext uri="{BB962C8B-B14F-4D97-AF65-F5344CB8AC3E}">
+        <p14:creationId xmlns:p14="http://schemas.microsoft.com/office/powerpoint/2010/main" val="3567628158"/>
       </p:ext>
     </p:extLst>
   </p:cSld>
@@ -3027,6 +3524,7 @@
     <p:sldLayoutId id="2147483657" r:id="rId9"/>
     <p:sldLayoutId id="2147483658" r:id="rId10"/>
     <p:sldLayoutId id="2147483659" r:id="rId11"/>
+    <p:sldLayoutId id="2147483660" r:id="rId12"/>
   </p:sldLayoutIdLst>
   <p:txStyles>
     <p:titleStyle>
@@ -3346,12 +3844,12 @@
         </p:nvSpPr>
         <p:spPr>
           <a:xfrm>
-            <a:off x="1693485" y="1845202"/>
+            <a:off x="1693485" y="2581845"/>
             <a:ext cx="8805030" cy="1655762"/>
           </a:xfrm>
         </p:spPr>
         <p:txBody>
-          <a:bodyPr>
+          <a:bodyPr anchor="t">
             <a:normAutofit/>
           </a:bodyPr>
           <a:lstStyle/>
@@ -3401,7 +3899,7 @@
         </p:nvSpPr>
         <p:spPr>
           <a:xfrm>
-            <a:off x="1524000" y="4237607"/>
+            <a:off x="1524000" y="4528737"/>
             <a:ext cx="9144000" cy="1655762"/>
           </a:xfrm>
         </p:spPr>
@@ -3702,6 +4200,1116 @@
   <p:cSld>
     <p:spTree>
       <p:nvGrpSpPr>
+        <p:cNvPr id="1" name="">
+          <a:extLst>
+            <a:ext uri="{FF2B5EF4-FFF2-40B4-BE49-F238E27FC236}">
+              <a16:creationId xmlns:a16="http://schemas.microsoft.com/office/drawing/2014/main" id="{955CEECE-80BD-24F5-29ED-51D02A8DC5DD}"/>
+            </a:ext>
+          </a:extLst>
+        </p:cNvPr>
+        <p:cNvGrpSpPr/>
+        <p:nvPr/>
+      </p:nvGrpSpPr>
+      <p:grpSpPr>
+        <a:xfrm>
+          <a:off x="0" y="0"/>
+          <a:ext cx="0" cy="0"/>
+          <a:chOff x="0" y="0"/>
+          <a:chExt cx="0" cy="0"/>
+        </a:xfrm>
+      </p:grpSpPr>
+      <p:sp>
+        <p:nvSpPr>
+          <p:cNvPr id="3" name="Text 1">
+            <a:extLst>
+              <a:ext uri="{FF2B5EF4-FFF2-40B4-BE49-F238E27FC236}">
+                <a16:creationId xmlns:a16="http://schemas.microsoft.com/office/drawing/2014/main" id="{2CE7C914-9BAE-BFF2-E2E6-8DFEAA338D00}"/>
+              </a:ext>
+            </a:extLst>
+          </p:cNvPr>
+          <p:cNvSpPr/>
+          <p:nvPr/>
+        </p:nvSpPr>
+        <p:spPr>
+          <a:xfrm>
+            <a:off x="609600" y="975360"/>
+            <a:ext cx="10972800" cy="1950720"/>
+          </a:xfrm>
+          <a:prstGeom prst="rect">
+            <a:avLst/>
+          </a:prstGeom>
+          <a:noFill/>
+          <a:ln/>
+        </p:spPr>
+        <p:txBody>
+          <a:bodyPr wrap="square" lIns="0" tIns="0" rIns="0" bIns="0" rtlCol="0" anchor="ctr"/>
+          <a:lstStyle/>
+          <a:p>
+            <a:endParaRPr lang="en-US" sz="13333" dirty="0">
+              <a:latin typeface="Aptos" panose="020B0004020202020204" pitchFamily="34" charset="0"/>
+            </a:endParaRPr>
+          </a:p>
+        </p:txBody>
+      </p:sp>
+      <p:sp>
+        <p:nvSpPr>
+          <p:cNvPr id="4" name="Text 2">
+            <a:extLst>
+              <a:ext uri="{FF2B5EF4-FFF2-40B4-BE49-F238E27FC236}">
+                <a16:creationId xmlns:a16="http://schemas.microsoft.com/office/drawing/2014/main" id="{3AA7DA23-AC46-53C2-5481-F11CF1FF75EA}"/>
+              </a:ext>
+            </a:extLst>
+          </p:cNvPr>
+          <p:cNvSpPr/>
+          <p:nvPr/>
+        </p:nvSpPr>
+        <p:spPr>
+          <a:xfrm>
+            <a:off x="609600" y="2202220"/>
+            <a:ext cx="10972800" cy="792480"/>
+          </a:xfrm>
+          <a:prstGeom prst="rect">
+            <a:avLst/>
+          </a:prstGeom>
+          <a:noFill/>
+          <a:ln/>
+        </p:spPr>
+        <p:txBody>
+          <a:bodyPr wrap="square" lIns="0" tIns="0" rIns="0" bIns="0" rtlCol="0" anchor="ctr"/>
+          <a:lstStyle/>
+          <a:p>
+            <a:r>
+              <a:rPr lang="en-US" sz="3733" b="1" dirty="0">
+                <a:solidFill>
+                  <a:srgbClr val="1A1A1A"/>
+                </a:solidFill>
+                <a:latin typeface="Aptos" panose="020B0004020202020204" pitchFamily="34" charset="0"/>
+                <a:ea typeface="Calibri" pitchFamily="34" charset="-122"/>
+                <a:cs typeface="Calibri" pitchFamily="34" charset="-120"/>
+              </a:rPr>
+              <a:t>Solutions de </a:t>
+            </a:r>
+            <a:r>
+              <a:rPr lang="en-US" sz="3733" b="1" dirty="0" err="1">
+                <a:solidFill>
+                  <a:srgbClr val="1A1A1A"/>
+                </a:solidFill>
+                <a:latin typeface="Aptos" panose="020B0004020202020204" pitchFamily="34" charset="0"/>
+                <a:ea typeface="Calibri" pitchFamily="34" charset="-122"/>
+                <a:cs typeface="Calibri" pitchFamily="34" charset="-120"/>
+              </a:rPr>
+              <a:t>rafraîchissement</a:t>
+            </a:r>
+            <a:r>
+              <a:rPr lang="en-US" sz="3733" b="1" dirty="0">
+                <a:solidFill>
+                  <a:srgbClr val="1A1A1A"/>
+                </a:solidFill>
+                <a:latin typeface="Aptos" panose="020B0004020202020204" pitchFamily="34" charset="0"/>
+                <a:ea typeface="Calibri" pitchFamily="34" charset="-122"/>
+                <a:cs typeface="Calibri" pitchFamily="34" charset="-120"/>
+              </a:rPr>
+              <a:t> </a:t>
+            </a:r>
+            <a:r>
+              <a:rPr lang="en-US" sz="3733" b="1" dirty="0" err="1">
+                <a:solidFill>
+                  <a:srgbClr val="1A1A1A"/>
+                </a:solidFill>
+                <a:latin typeface="Aptos" panose="020B0004020202020204" pitchFamily="34" charset="0"/>
+                <a:ea typeface="Calibri" pitchFamily="34" charset="-122"/>
+                <a:cs typeface="Calibri" pitchFamily="34" charset="-120"/>
+              </a:rPr>
+              <a:t>retenues</a:t>
+            </a:r>
+            <a:endParaRPr lang="en-US" sz="3733" dirty="0">
+              <a:latin typeface="Aptos" panose="020B0004020202020204" pitchFamily="34" charset="0"/>
+            </a:endParaRPr>
+          </a:p>
+        </p:txBody>
+      </p:sp>
+      <p:sp>
+        <p:nvSpPr>
+          <p:cNvPr id="5" name="Shape 3">
+            <a:extLst>
+              <a:ext uri="{FF2B5EF4-FFF2-40B4-BE49-F238E27FC236}">
+                <a16:creationId xmlns:a16="http://schemas.microsoft.com/office/drawing/2014/main" id="{302F78CA-65FF-9043-6070-1584BC6D4D54}"/>
+              </a:ext>
+            </a:extLst>
+          </p:cNvPr>
+          <p:cNvSpPr/>
+          <p:nvPr/>
+        </p:nvSpPr>
+        <p:spPr>
+          <a:xfrm>
+            <a:off x="609600" y="3080044"/>
+            <a:ext cx="731520" cy="48768"/>
+          </a:xfrm>
+          <a:prstGeom prst="rect">
+            <a:avLst/>
+          </a:prstGeom>
+          <a:solidFill>
+            <a:srgbClr val="1A1A1A"/>
+          </a:solidFill>
+          <a:ln w="12700">
+            <a:solidFill>
+              <a:srgbClr val="1A1A1A"/>
+            </a:solidFill>
+            <a:prstDash val="solid"/>
+          </a:ln>
+        </p:spPr>
+        <p:txBody>
+          <a:bodyPr/>
+          <a:lstStyle/>
+          <a:p>
+            <a:endParaRPr lang="fr-FR" sz="2400"/>
+          </a:p>
+        </p:txBody>
+      </p:sp>
+      <p:sp>
+        <p:nvSpPr>
+          <p:cNvPr id="6" name="Text 4">
+            <a:extLst>
+              <a:ext uri="{FF2B5EF4-FFF2-40B4-BE49-F238E27FC236}">
+                <a16:creationId xmlns:a16="http://schemas.microsoft.com/office/drawing/2014/main" id="{9328B9A3-CC8F-11E9-FAB1-0824EF7E88D7}"/>
+              </a:ext>
+            </a:extLst>
+          </p:cNvPr>
+          <p:cNvSpPr/>
+          <p:nvPr/>
+        </p:nvSpPr>
+        <p:spPr>
+          <a:xfrm>
+            <a:off x="609600" y="3398401"/>
+            <a:ext cx="10972800" cy="2879386"/>
+          </a:xfrm>
+          <a:prstGeom prst="rect">
+            <a:avLst/>
+          </a:prstGeom>
+          <a:noFill/>
+          <a:ln/>
+        </p:spPr>
+        <p:txBody>
+          <a:bodyPr wrap="square" lIns="0" tIns="0" rIns="0" bIns="0" rtlCol="0" anchor="t"/>
+          <a:lstStyle/>
+          <a:p>
+            <a:pPr marL="285750" indent="-285750">
+              <a:buFont typeface="Arial" panose="020B0604020202020204" pitchFamily="34" charset="0"/>
+              <a:buChar char="•"/>
+            </a:pPr>
+            <a:r>
+              <a:rPr lang="fr-FR" sz="1600" dirty="0">
+                <a:solidFill>
+                  <a:srgbClr val="5C5C5C"/>
+                </a:solidFill>
+                <a:latin typeface="Aptos" panose="020B0004020202020204" pitchFamily="34" charset="0"/>
+                <a:cs typeface="Calibri" pitchFamily="34" charset="-120"/>
+              </a:rPr>
+              <a:t>{{</a:t>
+            </a:r>
+            <a:r>
+              <a:rPr lang="fr-FR" sz="1600" dirty="0" err="1">
+                <a:solidFill>
+                  <a:srgbClr val="5C5C5C"/>
+                </a:solidFill>
+                <a:latin typeface="Aptos" panose="020B0004020202020204" pitchFamily="34" charset="0"/>
+                <a:cs typeface="Calibri" pitchFamily="34" charset="-120"/>
+              </a:rPr>
+              <a:t>titre_fiches_solution</a:t>
+            </a:r>
+            <a:r>
+              <a:rPr lang="fr-FR" sz="1600" dirty="0">
+                <a:solidFill>
+                  <a:srgbClr val="5C5C5C"/>
+                </a:solidFill>
+                <a:latin typeface="Aptos" panose="020B0004020202020204" pitchFamily="34" charset="0"/>
+                <a:cs typeface="Calibri" pitchFamily="34" charset="-120"/>
+              </a:rPr>
+              <a:t>}}</a:t>
+            </a:r>
+          </a:p>
+        </p:txBody>
+      </p:sp>
+      <p:cxnSp>
+        <p:nvCxnSpPr>
+          <p:cNvPr id="2" name="Connecteur droit 1">
+            <a:extLst>
+              <a:ext uri="{FF2B5EF4-FFF2-40B4-BE49-F238E27FC236}">
+                <a16:creationId xmlns:a16="http://schemas.microsoft.com/office/drawing/2014/main" id="{A3CAC41A-66B0-361D-B372-62D87EE7A9F8}"/>
+              </a:ext>
+            </a:extLst>
+          </p:cNvPr>
+          <p:cNvCxnSpPr>
+            <a:cxnSpLocks/>
+          </p:cNvCxnSpPr>
+          <p:nvPr/>
+        </p:nvCxnSpPr>
+        <p:spPr>
+          <a:xfrm>
+            <a:off x="576263" y="6512991"/>
+            <a:ext cx="11615737" cy="0"/>
+          </a:xfrm>
+          <a:prstGeom prst="line">
+            <a:avLst/>
+          </a:prstGeom>
+          <a:ln>
+            <a:solidFill>
+              <a:schemeClr val="bg1">
+                <a:lumMod val="85000"/>
+              </a:schemeClr>
+            </a:solidFill>
+          </a:ln>
+        </p:spPr>
+        <p:style>
+          <a:lnRef idx="2">
+            <a:schemeClr val="accent1"/>
+          </a:lnRef>
+          <a:fillRef idx="0">
+            <a:schemeClr val="accent1"/>
+          </a:fillRef>
+          <a:effectRef idx="1">
+            <a:schemeClr val="accent1"/>
+          </a:effectRef>
+          <a:fontRef idx="minor">
+            <a:schemeClr val="tx1"/>
+          </a:fontRef>
+        </p:style>
+      </p:cxnSp>
+      <p:sp>
+        <p:nvSpPr>
+          <p:cNvPr id="8" name="Text 3">
+            <a:extLst>
+              <a:ext uri="{FF2B5EF4-FFF2-40B4-BE49-F238E27FC236}">
+                <a16:creationId xmlns:a16="http://schemas.microsoft.com/office/drawing/2014/main" id="{515558A7-65FA-3B23-4336-CA7CF66783E3}"/>
+              </a:ext>
+            </a:extLst>
+          </p:cNvPr>
+          <p:cNvSpPr/>
+          <p:nvPr/>
+        </p:nvSpPr>
+        <p:spPr>
+          <a:xfrm>
+            <a:off x="576263" y="6598217"/>
+            <a:ext cx="8229600" cy="182880"/>
+          </a:xfrm>
+          <a:prstGeom prst="rect">
+            <a:avLst/>
+          </a:prstGeom>
+          <a:noFill/>
+          <a:ln/>
+        </p:spPr>
+        <p:txBody>
+          <a:bodyPr wrap="square" lIns="0" tIns="0" rIns="0" bIns="0" rtlCol="0" anchor="ctr"/>
+          <a:lstStyle/>
+          <a:p>
+            <a:pPr marL="0" indent="0">
+              <a:buNone/>
+            </a:pPr>
+            <a:r>
+              <a:rPr lang="en-US" sz="1000" i="1">
+                <a:solidFill>
+                  <a:srgbClr val="A0A0A0"/>
+                </a:solidFill>
+                <a:latin typeface="Calibri" pitchFamily="34" charset="0"/>
+                <a:ea typeface="Calibri" pitchFamily="34" charset="-122"/>
+                <a:cs typeface="Calibri" pitchFamily="34" charset="-120"/>
+              </a:rPr>
+              <a:t>Données issues de Plus fraîche ma ville (ADEME)</a:t>
+            </a:r>
+            <a:endParaRPr lang="en-US" sz="1000"/>
+          </a:p>
+        </p:txBody>
+      </p:sp>
+      <p:pic>
+        <p:nvPicPr>
+          <p:cNvPr id="9" name="Image 8" descr="Une image contenant Police, Graphique, logo, graphisme&#10;&#10;Description générée automatiquement">
+            <a:extLst>
+              <a:ext uri="{FF2B5EF4-FFF2-40B4-BE49-F238E27FC236}">
+                <a16:creationId xmlns:a16="http://schemas.microsoft.com/office/drawing/2014/main" id="{5FA40CA5-18D5-ABCF-9EE1-BF9C0AE210FD}"/>
+              </a:ext>
+            </a:extLst>
+          </p:cNvPr>
+          <p:cNvPicPr>
+            <a:picLocks noChangeAspect="1"/>
+          </p:cNvPicPr>
+          <p:nvPr/>
+        </p:nvPicPr>
+        <p:blipFill>
+          <a:blip r:embed="rId3"/>
+          <a:srcRect t="19804" b="18118"/>
+          <a:stretch/>
+        </p:blipFill>
+        <p:spPr>
+          <a:xfrm>
+            <a:off x="10763987" y="98854"/>
+            <a:ext cx="1229053" cy="762977"/>
+          </a:xfrm>
+          <a:prstGeom prst="rect">
+            <a:avLst/>
+          </a:prstGeom>
+        </p:spPr>
+      </p:pic>
+      <p:pic>
+        <p:nvPicPr>
+          <p:cNvPr id="10" name="Picture 9">
+            <a:extLst>
+              <a:ext uri="{FF2B5EF4-FFF2-40B4-BE49-F238E27FC236}">
+                <a16:creationId xmlns:a16="http://schemas.microsoft.com/office/drawing/2014/main" id="{E922595D-B49E-4187-3566-440EF1D1B583}"/>
+              </a:ext>
+            </a:extLst>
+          </p:cNvPr>
+          <p:cNvPicPr>
+            <a:picLocks noChangeAspect="1"/>
+          </p:cNvPicPr>
+          <p:nvPr/>
+        </p:nvPicPr>
+        <p:blipFill>
+          <a:blip r:embed="rId4"/>
+          <a:stretch>
+            <a:fillRect/>
+          </a:stretch>
+        </p:blipFill>
+        <p:spPr>
+          <a:xfrm>
+            <a:off x="10546452" y="104580"/>
+            <a:ext cx="1552051" cy="758533"/>
+          </a:xfrm>
+          <a:prstGeom prst="rect">
+            <a:avLst/>
+          </a:prstGeom>
+        </p:spPr>
+      </p:pic>
+    </p:spTree>
+    <p:extLst>
+      <p:ext uri="{BB962C8B-B14F-4D97-AF65-F5344CB8AC3E}">
+        <p14:creationId xmlns:p14="http://schemas.microsoft.com/office/powerpoint/2010/main" val="1825708116"/>
+      </p:ext>
+    </p:extLst>
+  </p:cSld>
+  <p:clrMapOvr>
+    <a:masterClrMapping/>
+  </p:clrMapOvr>
+</p:sld>
+</file>
+
+<file path=ppt/slides/slide3.xml><?xml version="1.0" encoding="utf-8"?>
+<p:sld xmlns:a="http://schemas.openxmlformats.org/drawingml/2006/main" xmlns:r="http://schemas.openxmlformats.org/officeDocument/2006/relationships" xmlns:p="http://schemas.openxmlformats.org/presentationml/2006/main">
+  <p:cSld>
+    <p:spTree>
+      <p:nvGrpSpPr>
+        <p:cNvPr id="1" name="">
+          <a:extLst>
+            <a:ext uri="{FF2B5EF4-FFF2-40B4-BE49-F238E27FC236}">
+              <a16:creationId xmlns:a16="http://schemas.microsoft.com/office/drawing/2014/main" id="{1917CAA9-6ECD-8F49-8289-13579AAE1FB7}"/>
+            </a:ext>
+          </a:extLst>
+        </p:cNvPr>
+        <p:cNvGrpSpPr/>
+        <p:nvPr/>
+      </p:nvGrpSpPr>
+      <p:grpSpPr>
+        <a:xfrm>
+          <a:off x="0" y="0"/>
+          <a:ext cx="0" cy="0"/>
+          <a:chOff x="0" y="0"/>
+          <a:chExt cx="0" cy="0"/>
+        </a:xfrm>
+      </p:grpSpPr>
+      <p:sp>
+        <p:nvSpPr>
+          <p:cNvPr id="2" name="Titre 1">
+            <a:extLst>
+              <a:ext uri="{FF2B5EF4-FFF2-40B4-BE49-F238E27FC236}">
+                <a16:creationId xmlns:a16="http://schemas.microsoft.com/office/drawing/2014/main" id="{474A7BA3-D950-9097-DDDD-F688CBFCCB67}"/>
+              </a:ext>
+            </a:extLst>
+          </p:cNvPr>
+          <p:cNvSpPr>
+            <a:spLocks noGrp="1"/>
+          </p:cNvSpPr>
+          <p:nvPr>
+            <p:ph type="title"/>
+          </p:nvPr>
+        </p:nvSpPr>
+        <p:spPr>
+          <a:xfrm>
+            <a:off x="576263" y="345395"/>
+            <a:ext cx="9706989" cy="615294"/>
+          </a:xfrm>
+        </p:spPr>
+        <p:txBody>
+          <a:bodyPr>
+            <a:normAutofit/>
+          </a:bodyPr>
+          <a:lstStyle/>
+          <a:p>
+            <a:pPr marL="0" indent="0">
+              <a:buNone/>
+            </a:pPr>
+            <a:r>
+              <a:rPr lang="en-US" sz="3200" dirty="0"/>
+              <a:t>Solution {{</a:t>
+            </a:r>
+            <a:r>
+              <a:rPr lang="en-US" sz="3200" dirty="0" err="1"/>
+              <a:t>n°_solution</a:t>
+            </a:r>
+            <a:r>
+              <a:rPr lang="en-US" sz="3200" dirty="0"/>
+              <a:t>}} : {{</a:t>
+            </a:r>
+            <a:r>
+              <a:rPr lang="en-US" sz="3200" dirty="0" err="1"/>
+              <a:t>titre_fiche_solution</a:t>
+            </a:r>
+            <a:r>
+              <a:rPr lang="en-US" sz="3200" dirty="0"/>
+              <a:t>}}</a:t>
+            </a:r>
+          </a:p>
+        </p:txBody>
+      </p:sp>
+      <p:sp>
+        <p:nvSpPr>
+          <p:cNvPr id="5" name="ZoneTexte 4">
+            <a:extLst>
+              <a:ext uri="{FF2B5EF4-FFF2-40B4-BE49-F238E27FC236}">
+                <a16:creationId xmlns:a16="http://schemas.microsoft.com/office/drawing/2014/main" id="{C76718D3-101C-1B45-FD71-3691F60DE7E5}"/>
+              </a:ext>
+            </a:extLst>
+          </p:cNvPr>
+          <p:cNvSpPr txBox="1"/>
+          <p:nvPr/>
+        </p:nvSpPr>
+        <p:spPr>
+          <a:xfrm>
+            <a:off x="576263" y="1093598"/>
+            <a:ext cx="9706988" cy="400110"/>
+          </a:xfrm>
+          <a:prstGeom prst="rect">
+            <a:avLst/>
+          </a:prstGeom>
+          <a:noFill/>
+        </p:spPr>
+        <p:txBody>
+          <a:bodyPr wrap="square">
+            <a:spAutoFit/>
+          </a:bodyPr>
+          <a:lstStyle/>
+          <a:p>
+            <a:r>
+              <a:rPr lang="fr-FR" sz="2000" b="1" dirty="0">
+                <a:solidFill>
+                  <a:srgbClr val="161616"/>
+                </a:solidFill>
+                <a:latin typeface="Aptos" panose="020B0004020202020204" pitchFamily="34" charset="0"/>
+              </a:rPr>
+              <a:t>{{</a:t>
+            </a:r>
+            <a:r>
+              <a:rPr lang="fr-FR" sz="2000" b="1" dirty="0" err="1">
+                <a:solidFill>
+                  <a:srgbClr val="161616"/>
+                </a:solidFill>
+                <a:latin typeface="Aptos" panose="020B0004020202020204" pitchFamily="34" charset="0"/>
+              </a:rPr>
+              <a:t>description_courte_fiche_solution</a:t>
+            </a:r>
+            <a:r>
+              <a:rPr lang="fr-FR" sz="2000" b="1" dirty="0">
+                <a:solidFill>
+                  <a:srgbClr val="161616"/>
+                </a:solidFill>
+                <a:latin typeface="Aptos" panose="020B0004020202020204" pitchFamily="34" charset="0"/>
+              </a:rPr>
+              <a:t>}}</a:t>
+            </a:r>
+            <a:endParaRPr lang="fr-FR" sz="2000" dirty="0">
+              <a:latin typeface="Aptos" panose="020B0004020202020204" pitchFamily="34" charset="0"/>
+            </a:endParaRPr>
+          </a:p>
+        </p:txBody>
+      </p:sp>
+      <p:cxnSp>
+        <p:nvCxnSpPr>
+          <p:cNvPr id="34" name="Connecteur droit 33">
+            <a:extLst>
+              <a:ext uri="{FF2B5EF4-FFF2-40B4-BE49-F238E27FC236}">
+                <a16:creationId xmlns:a16="http://schemas.microsoft.com/office/drawing/2014/main" id="{B62F42A1-9E9E-D546-190A-5C7D09368113}"/>
+              </a:ext>
+            </a:extLst>
+          </p:cNvPr>
+          <p:cNvCxnSpPr>
+            <a:cxnSpLocks/>
+          </p:cNvCxnSpPr>
+          <p:nvPr/>
+        </p:nvCxnSpPr>
+        <p:spPr>
+          <a:xfrm>
+            <a:off x="576263" y="960689"/>
+            <a:ext cx="11615737" cy="0"/>
+          </a:xfrm>
+          <a:prstGeom prst="line">
+            <a:avLst/>
+          </a:prstGeom>
+          <a:ln>
+            <a:solidFill>
+              <a:schemeClr val="bg1">
+                <a:lumMod val="85000"/>
+              </a:schemeClr>
+            </a:solidFill>
+          </a:ln>
+        </p:spPr>
+        <p:style>
+          <a:lnRef idx="2">
+            <a:schemeClr val="accent1"/>
+          </a:lnRef>
+          <a:fillRef idx="0">
+            <a:schemeClr val="accent1"/>
+          </a:fillRef>
+          <a:effectRef idx="1">
+            <a:schemeClr val="accent1"/>
+          </a:effectRef>
+          <a:fontRef idx="minor">
+            <a:schemeClr val="tx1"/>
+          </a:fontRef>
+        </p:style>
+      </p:cxnSp>
+      <p:pic>
+        <p:nvPicPr>
+          <p:cNvPr id="36" name="Image 35" descr="Une image contenant texte, Police, blanc, logo&#10;&#10;Description générée automatiquement">
+            <a:extLst>
+              <a:ext uri="{FF2B5EF4-FFF2-40B4-BE49-F238E27FC236}">
+                <a16:creationId xmlns:a16="http://schemas.microsoft.com/office/drawing/2014/main" id="{F798593A-5338-9D39-2E02-8827877BAC38}"/>
+              </a:ext>
+            </a:extLst>
+          </p:cNvPr>
+          <p:cNvPicPr>
+            <a:picLocks noChangeAspect="1"/>
+          </p:cNvPicPr>
+          <p:nvPr/>
+        </p:nvPicPr>
+        <p:blipFill>
+          <a:blip r:embed="rId2"/>
+          <a:stretch>
+            <a:fillRect/>
+          </a:stretch>
+        </p:blipFill>
+        <p:spPr>
+          <a:xfrm>
+            <a:off x="576263" y="2342710"/>
+            <a:ext cx="3733800" cy="1104900"/>
+          </a:xfrm>
+          <a:prstGeom prst="rect">
+            <a:avLst/>
+          </a:prstGeom>
+        </p:spPr>
+      </p:pic>
+      <p:pic>
+        <p:nvPicPr>
+          <p:cNvPr id="38" name="Image 37" descr="Une image contenant texte, Police, blanc, conception&#10;&#10;Description générée automatiquement">
+            <a:extLst>
+              <a:ext uri="{FF2B5EF4-FFF2-40B4-BE49-F238E27FC236}">
+                <a16:creationId xmlns:a16="http://schemas.microsoft.com/office/drawing/2014/main" id="{AC226DA6-1EF2-CFAB-8908-AEF5C4E4B84A}"/>
+              </a:ext>
+            </a:extLst>
+          </p:cNvPr>
+          <p:cNvPicPr>
+            <a:picLocks noChangeAspect="1"/>
+          </p:cNvPicPr>
+          <p:nvPr/>
+        </p:nvPicPr>
+        <p:blipFill>
+          <a:blip r:embed="rId3"/>
+          <a:stretch>
+            <a:fillRect/>
+          </a:stretch>
+        </p:blipFill>
+        <p:spPr>
+          <a:xfrm>
+            <a:off x="576263" y="5375317"/>
+            <a:ext cx="3975795" cy="830111"/>
+          </a:xfrm>
+          <a:prstGeom prst="rect">
+            <a:avLst/>
+          </a:prstGeom>
+        </p:spPr>
+      </p:pic>
+      <p:pic>
+        <p:nvPicPr>
+          <p:cNvPr id="40" name="Image 39" descr="Une image contenant texte, Police, blanc, capture d’écran&#10;&#10;Description générée automatiquement">
+            <a:extLst>
+              <a:ext uri="{FF2B5EF4-FFF2-40B4-BE49-F238E27FC236}">
+                <a16:creationId xmlns:a16="http://schemas.microsoft.com/office/drawing/2014/main" id="{A0B7D414-A672-70A2-E902-803986BD58AC}"/>
+              </a:ext>
+            </a:extLst>
+          </p:cNvPr>
+          <p:cNvPicPr>
+            <a:picLocks noChangeAspect="1"/>
+          </p:cNvPicPr>
+          <p:nvPr/>
+        </p:nvPicPr>
+        <p:blipFill>
+          <a:blip r:embed="rId4"/>
+          <a:stretch>
+            <a:fillRect/>
+          </a:stretch>
+        </p:blipFill>
+        <p:spPr>
+          <a:xfrm>
+            <a:off x="576263" y="4399297"/>
+            <a:ext cx="4296189" cy="830111"/>
+          </a:xfrm>
+          <a:prstGeom prst="rect">
+            <a:avLst/>
+          </a:prstGeom>
+        </p:spPr>
+      </p:pic>
+      <p:sp>
+        <p:nvSpPr>
+          <p:cNvPr id="43" name="Text 16">
+            <a:extLst>
+              <a:ext uri="{FF2B5EF4-FFF2-40B4-BE49-F238E27FC236}">
+                <a16:creationId xmlns:a16="http://schemas.microsoft.com/office/drawing/2014/main" id="{A300427D-EA15-7150-EA9C-A87450E6202D}"/>
+              </a:ext>
+            </a:extLst>
+          </p:cNvPr>
+          <p:cNvSpPr/>
+          <p:nvPr/>
+        </p:nvSpPr>
+        <p:spPr>
+          <a:xfrm>
+            <a:off x="712188" y="3920740"/>
+            <a:ext cx="2220756" cy="293597"/>
+          </a:xfrm>
+          <a:prstGeom prst="rect">
+            <a:avLst/>
+          </a:prstGeom>
+          <a:noFill/>
+          <a:ln/>
+        </p:spPr>
+        <p:txBody>
+          <a:bodyPr wrap="square" lIns="0" tIns="0" rIns="0" bIns="0" rtlCol="0" anchor="ctr"/>
+          <a:lstStyle/>
+          <a:p>
+            <a:pPr marL="0" indent="0">
+              <a:buNone/>
+            </a:pPr>
+            <a:r>
+              <a:rPr lang="en-US" b="1" kern="0" spc="150">
+                <a:latin typeface="Calibri" pitchFamily="34" charset="0"/>
+                <a:ea typeface="Calibri" pitchFamily="34" charset="-122"/>
+                <a:cs typeface="Calibri" pitchFamily="34" charset="-120"/>
+              </a:rPr>
+              <a:t>Mise </a:t>
+            </a:r>
+            <a:r>
+              <a:rPr lang="en-US" b="1" kern="0" spc="150" err="1">
+                <a:latin typeface="Calibri" pitchFamily="34" charset="0"/>
+                <a:ea typeface="Calibri" pitchFamily="34" charset="-122"/>
+                <a:cs typeface="Calibri" pitchFamily="34" charset="-120"/>
+              </a:rPr>
+              <a:t>en</a:t>
+            </a:r>
+            <a:r>
+              <a:rPr lang="en-US" b="1" kern="0" spc="150">
+                <a:latin typeface="Calibri" pitchFamily="34" charset="0"/>
+                <a:ea typeface="Calibri" pitchFamily="34" charset="-122"/>
+                <a:cs typeface="Calibri" pitchFamily="34" charset="-120"/>
+              </a:rPr>
+              <a:t> oeuvre</a:t>
+            </a:r>
+            <a:endParaRPr lang="en-US"/>
+          </a:p>
+        </p:txBody>
+      </p:sp>
+      <p:sp>
+        <p:nvSpPr>
+          <p:cNvPr id="44" name="Text 16">
+            <a:extLst>
+              <a:ext uri="{FF2B5EF4-FFF2-40B4-BE49-F238E27FC236}">
+                <a16:creationId xmlns:a16="http://schemas.microsoft.com/office/drawing/2014/main" id="{E91C9383-E765-31FC-91C1-919BA413B245}"/>
+              </a:ext>
+            </a:extLst>
+          </p:cNvPr>
+          <p:cNvSpPr/>
+          <p:nvPr/>
+        </p:nvSpPr>
+        <p:spPr>
+          <a:xfrm>
+            <a:off x="712188" y="1986268"/>
+            <a:ext cx="2220756" cy="293597"/>
+          </a:xfrm>
+          <a:prstGeom prst="rect">
+            <a:avLst/>
+          </a:prstGeom>
+          <a:noFill/>
+          <a:ln/>
+        </p:spPr>
+        <p:txBody>
+          <a:bodyPr wrap="square" lIns="0" tIns="0" rIns="0" bIns="0" rtlCol="0" anchor="ctr"/>
+          <a:lstStyle/>
+          <a:p>
+            <a:pPr marL="0" indent="0">
+              <a:buNone/>
+            </a:pPr>
+            <a:r>
+              <a:rPr lang="en-US" b="1" kern="0" spc="150" err="1">
+                <a:latin typeface="Calibri" pitchFamily="34" charset="0"/>
+                <a:ea typeface="Calibri" pitchFamily="34" charset="-122"/>
+                <a:cs typeface="Calibri" pitchFamily="34" charset="-120"/>
+              </a:rPr>
+              <a:t>Résultat</a:t>
+            </a:r>
+            <a:r>
+              <a:rPr lang="en-US" b="1" kern="0" spc="150">
+                <a:latin typeface="Calibri" pitchFamily="34" charset="0"/>
+                <a:ea typeface="Calibri" pitchFamily="34" charset="-122"/>
+                <a:cs typeface="Calibri" pitchFamily="34" charset="-120"/>
+              </a:rPr>
+              <a:t> </a:t>
+            </a:r>
+            <a:r>
+              <a:rPr lang="en-US" b="1" kern="0" spc="150" err="1">
+                <a:latin typeface="Calibri" pitchFamily="34" charset="0"/>
+                <a:ea typeface="Calibri" pitchFamily="34" charset="-122"/>
+                <a:cs typeface="Calibri" pitchFamily="34" charset="-120"/>
+              </a:rPr>
+              <a:t>attendu</a:t>
+            </a:r>
+            <a:endParaRPr lang="en-US"/>
+          </a:p>
+        </p:txBody>
+      </p:sp>
+      <p:sp>
+        <p:nvSpPr>
+          <p:cNvPr id="45" name="Text 16">
+            <a:extLst>
+              <a:ext uri="{FF2B5EF4-FFF2-40B4-BE49-F238E27FC236}">
+                <a16:creationId xmlns:a16="http://schemas.microsoft.com/office/drawing/2014/main" id="{4F281405-7CF6-3385-6A40-21850D059F03}"/>
+              </a:ext>
+            </a:extLst>
+          </p:cNvPr>
+          <p:cNvSpPr/>
+          <p:nvPr/>
+        </p:nvSpPr>
+        <p:spPr>
+          <a:xfrm>
+            <a:off x="7660805" y="2133066"/>
+            <a:ext cx="2220756" cy="293597"/>
+          </a:xfrm>
+          <a:prstGeom prst="rect">
+            <a:avLst/>
+          </a:prstGeom>
+          <a:noFill/>
+          <a:ln/>
+        </p:spPr>
+        <p:txBody>
+          <a:bodyPr wrap="square" lIns="0" tIns="0" rIns="0" bIns="0" rtlCol="0" anchor="ctr"/>
+          <a:lstStyle/>
+          <a:p>
+            <a:pPr marL="0" indent="0">
+              <a:buNone/>
+            </a:pPr>
+            <a:r>
+              <a:rPr lang="en-US" b="1" kern="0" spc="150" err="1">
+                <a:latin typeface="Calibri" pitchFamily="34" charset="0"/>
+                <a:ea typeface="Calibri" pitchFamily="34" charset="-122"/>
+                <a:cs typeface="Calibri" pitchFamily="34" charset="-120"/>
+              </a:rPr>
+              <a:t>Cobénéfices</a:t>
+            </a:r>
+            <a:endParaRPr lang="en-US"/>
+          </a:p>
+        </p:txBody>
+      </p:sp>
+      <p:pic>
+        <p:nvPicPr>
+          <p:cNvPr id="47" name="Image 46" descr="Une image contenant Police, Graphique, logo, conception&#10;&#10;Description générée automatiquement">
+            <a:extLst>
+              <a:ext uri="{FF2B5EF4-FFF2-40B4-BE49-F238E27FC236}">
+                <a16:creationId xmlns:a16="http://schemas.microsoft.com/office/drawing/2014/main" id="{F8CDAE4D-2022-8DF2-D170-E9FBC5B08999}"/>
+              </a:ext>
+            </a:extLst>
+          </p:cNvPr>
+          <p:cNvPicPr>
+            <a:picLocks noChangeAspect="1"/>
+          </p:cNvPicPr>
+          <p:nvPr/>
+        </p:nvPicPr>
+        <p:blipFill>
+          <a:blip r:embed="rId5"/>
+          <a:stretch>
+            <a:fillRect/>
+          </a:stretch>
+        </p:blipFill>
+        <p:spPr>
+          <a:xfrm>
+            <a:off x="7563880" y="2669231"/>
+            <a:ext cx="3390900" cy="901700"/>
+          </a:xfrm>
+          <a:prstGeom prst="rect">
+            <a:avLst/>
+          </a:prstGeom>
+        </p:spPr>
+      </p:pic>
+      <p:pic>
+        <p:nvPicPr>
+          <p:cNvPr id="49" name="Image 48" descr="Une image contenant Police, texte, conception&#10;&#10;Description générée automatiquement">
+            <a:extLst>
+              <a:ext uri="{FF2B5EF4-FFF2-40B4-BE49-F238E27FC236}">
+                <a16:creationId xmlns:a16="http://schemas.microsoft.com/office/drawing/2014/main" id="{7CA4471C-C514-5126-AA43-C7F2EA362344}"/>
+              </a:ext>
+            </a:extLst>
+          </p:cNvPr>
+          <p:cNvPicPr>
+            <a:picLocks noChangeAspect="1"/>
+          </p:cNvPicPr>
+          <p:nvPr/>
+        </p:nvPicPr>
+        <p:blipFill>
+          <a:blip r:embed="rId6"/>
+          <a:stretch>
+            <a:fillRect/>
+          </a:stretch>
+        </p:blipFill>
+        <p:spPr>
+          <a:xfrm>
+            <a:off x="7576580" y="3519911"/>
+            <a:ext cx="3378200" cy="1104900"/>
+          </a:xfrm>
+          <a:prstGeom prst="rect">
+            <a:avLst/>
+          </a:prstGeom>
+        </p:spPr>
+      </p:pic>
+      <p:pic>
+        <p:nvPicPr>
+          <p:cNvPr id="51" name="Image 50" descr="Une image contenant Police, texte, logo, Graphique&#10;&#10;Description générée automatiquement">
+            <a:extLst>
+              <a:ext uri="{FF2B5EF4-FFF2-40B4-BE49-F238E27FC236}">
+                <a16:creationId xmlns:a16="http://schemas.microsoft.com/office/drawing/2014/main" id="{4572FDB4-7972-6868-307C-A0E198A435E2}"/>
+              </a:ext>
+            </a:extLst>
+          </p:cNvPr>
+          <p:cNvPicPr>
+            <a:picLocks noChangeAspect="1"/>
+          </p:cNvPicPr>
+          <p:nvPr/>
+        </p:nvPicPr>
+        <p:blipFill>
+          <a:blip r:embed="rId7"/>
+          <a:stretch>
+            <a:fillRect/>
+          </a:stretch>
+        </p:blipFill>
+        <p:spPr>
+          <a:xfrm>
+            <a:off x="7628066" y="4619988"/>
+            <a:ext cx="3302000" cy="787400"/>
+          </a:xfrm>
+          <a:prstGeom prst="rect">
+            <a:avLst/>
+          </a:prstGeom>
+        </p:spPr>
+      </p:pic>
+      <p:pic>
+        <p:nvPicPr>
+          <p:cNvPr id="53" name="Image 52" descr="Une image contenant Police, Graphique, logo, blanc&#10;&#10;Description générée automatiquement">
+            <a:extLst>
+              <a:ext uri="{FF2B5EF4-FFF2-40B4-BE49-F238E27FC236}">
+                <a16:creationId xmlns:a16="http://schemas.microsoft.com/office/drawing/2014/main" id="{553CA788-F957-E39E-15A9-D1876EB52CC1}"/>
+              </a:ext>
+            </a:extLst>
+          </p:cNvPr>
+          <p:cNvPicPr>
+            <a:picLocks noChangeAspect="1"/>
+          </p:cNvPicPr>
+          <p:nvPr/>
+        </p:nvPicPr>
+        <p:blipFill>
+          <a:blip r:embed="rId8"/>
+          <a:stretch>
+            <a:fillRect/>
+          </a:stretch>
+        </p:blipFill>
+        <p:spPr>
+          <a:xfrm>
+            <a:off x="7648448" y="5407388"/>
+            <a:ext cx="3302000" cy="838200"/>
+          </a:xfrm>
+          <a:prstGeom prst="rect">
+            <a:avLst/>
+          </a:prstGeom>
+        </p:spPr>
+      </p:pic>
+      <p:cxnSp>
+        <p:nvCxnSpPr>
+          <p:cNvPr id="55" name="Connecteur droit 54">
+            <a:extLst>
+              <a:ext uri="{FF2B5EF4-FFF2-40B4-BE49-F238E27FC236}">
+                <a16:creationId xmlns:a16="http://schemas.microsoft.com/office/drawing/2014/main" id="{BFBD2EB6-34B6-54D8-319B-95BBA847CB21}"/>
+              </a:ext>
+            </a:extLst>
+          </p:cNvPr>
+          <p:cNvCxnSpPr>
+            <a:cxnSpLocks/>
+          </p:cNvCxnSpPr>
+          <p:nvPr/>
+        </p:nvCxnSpPr>
+        <p:spPr>
+          <a:xfrm>
+            <a:off x="576263" y="6512991"/>
+            <a:ext cx="11615737" cy="0"/>
+          </a:xfrm>
+          <a:prstGeom prst="line">
+            <a:avLst/>
+          </a:prstGeom>
+          <a:ln>
+            <a:solidFill>
+              <a:schemeClr val="bg1">
+                <a:lumMod val="85000"/>
+              </a:schemeClr>
+            </a:solidFill>
+          </a:ln>
+        </p:spPr>
+        <p:style>
+          <a:lnRef idx="2">
+            <a:schemeClr val="accent1"/>
+          </a:lnRef>
+          <a:fillRef idx="0">
+            <a:schemeClr val="accent1"/>
+          </a:fillRef>
+          <a:effectRef idx="1">
+            <a:schemeClr val="accent1"/>
+          </a:effectRef>
+          <a:fontRef idx="minor">
+            <a:schemeClr val="tx1"/>
+          </a:fontRef>
+        </p:style>
+      </p:cxnSp>
+      <p:sp>
+        <p:nvSpPr>
+          <p:cNvPr id="56" name="Text 3">
+            <a:extLst>
+              <a:ext uri="{FF2B5EF4-FFF2-40B4-BE49-F238E27FC236}">
+                <a16:creationId xmlns:a16="http://schemas.microsoft.com/office/drawing/2014/main" id="{8B657D20-7F9C-8851-0BA6-B35DF1DB8D17}"/>
+              </a:ext>
+            </a:extLst>
+          </p:cNvPr>
+          <p:cNvSpPr/>
+          <p:nvPr/>
+        </p:nvSpPr>
+        <p:spPr>
+          <a:xfrm>
+            <a:off x="576263" y="6598217"/>
+            <a:ext cx="8229600" cy="182880"/>
+          </a:xfrm>
+          <a:prstGeom prst="rect">
+            <a:avLst/>
+          </a:prstGeom>
+          <a:noFill/>
+          <a:ln/>
+        </p:spPr>
+        <p:txBody>
+          <a:bodyPr wrap="square" lIns="0" tIns="0" rIns="0" bIns="0" rtlCol="0" anchor="ctr"/>
+          <a:lstStyle/>
+          <a:p>
+            <a:pPr marL="0" indent="0">
+              <a:buNone/>
+            </a:pPr>
+            <a:r>
+              <a:rPr lang="en-US" sz="1000" i="1">
+                <a:solidFill>
+                  <a:srgbClr val="A0A0A0"/>
+                </a:solidFill>
+                <a:latin typeface="Calibri" pitchFamily="34" charset="0"/>
+                <a:ea typeface="Calibri" pitchFamily="34" charset="-122"/>
+                <a:cs typeface="Calibri" pitchFamily="34" charset="-120"/>
+              </a:rPr>
+              <a:t>Données issues de Plus fraîche ma ville (ADEME)</a:t>
+            </a:r>
+            <a:endParaRPr lang="en-US" sz="1000"/>
+          </a:p>
+        </p:txBody>
+      </p:sp>
+      <p:pic>
+        <p:nvPicPr>
+          <p:cNvPr id="57" name="Image 56" descr="Une image contenant Police, Graphique, logo, graphisme&#10;&#10;Description générée automatiquement">
+            <a:extLst>
+              <a:ext uri="{FF2B5EF4-FFF2-40B4-BE49-F238E27FC236}">
+                <a16:creationId xmlns:a16="http://schemas.microsoft.com/office/drawing/2014/main" id="{830EBC68-A5C6-15CA-95C1-839F0A7C9BA7}"/>
+              </a:ext>
+            </a:extLst>
+          </p:cNvPr>
+          <p:cNvPicPr>
+            <a:picLocks noChangeAspect="1"/>
+          </p:cNvPicPr>
+          <p:nvPr/>
+        </p:nvPicPr>
+        <p:blipFill>
+          <a:blip r:embed="rId9"/>
+          <a:srcRect t="19804" b="18118"/>
+          <a:stretch/>
+        </p:blipFill>
+        <p:spPr>
+          <a:xfrm>
+            <a:off x="10763987" y="98854"/>
+            <a:ext cx="1229053" cy="762977"/>
+          </a:xfrm>
+          <a:prstGeom prst="rect">
+            <a:avLst/>
+          </a:prstGeom>
+        </p:spPr>
+      </p:pic>
+      <p:pic>
+        <p:nvPicPr>
+          <p:cNvPr id="4" name="Picture 3">
+            <a:extLst>
+              <a:ext uri="{FF2B5EF4-FFF2-40B4-BE49-F238E27FC236}">
+                <a16:creationId xmlns:a16="http://schemas.microsoft.com/office/drawing/2014/main" id="{7D131FE9-968A-7934-D330-1035AA73A364}"/>
+              </a:ext>
+            </a:extLst>
+          </p:cNvPr>
+          <p:cNvPicPr>
+            <a:picLocks noChangeAspect="1"/>
+          </p:cNvPicPr>
+          <p:nvPr/>
+        </p:nvPicPr>
+        <p:blipFill>
+          <a:blip r:embed="rId10"/>
+          <a:stretch>
+            <a:fillRect/>
+          </a:stretch>
+        </p:blipFill>
+        <p:spPr>
+          <a:xfrm>
+            <a:off x="10546452" y="104580"/>
+            <a:ext cx="1552051" cy="758533"/>
+          </a:xfrm>
+          <a:prstGeom prst="rect">
+            <a:avLst/>
+          </a:prstGeom>
+        </p:spPr>
+      </p:pic>
+    </p:spTree>
+    <p:extLst>
+      <p:ext uri="{BB962C8B-B14F-4D97-AF65-F5344CB8AC3E}">
+        <p14:creationId xmlns:p14="http://schemas.microsoft.com/office/powerpoint/2010/main" val="452405676"/>
+      </p:ext>
+    </p:extLst>
+  </p:cSld>
+  <p:clrMapOvr>
+    <a:masterClrMapping/>
+  </p:clrMapOvr>
+</p:sld>
+</file>
+
+<file path=ppt/slides/slide4.xml><?xml version="1.0" encoding="utf-8"?>
+<p:sld xmlns:a="http://schemas.openxmlformats.org/drawingml/2006/main" xmlns:r="http://schemas.openxmlformats.org/officeDocument/2006/relationships" xmlns:p="http://schemas.openxmlformats.org/presentationml/2006/main">
+  <p:cSld>
+    <p:spTree>
+      <p:nvGrpSpPr>
         <p:cNvPr id="1" name=""/>
         <p:cNvGrpSpPr/>
         <p:nvPr/>
@@ -4123,7 +5731,7 @@
 </p:sld>
 </file>
 
-<file path=ppt/slides/slide3.xml><?xml version="1.0" encoding="utf-8"?>
+<file path=ppt/slides/slide5.xml><?xml version="1.0" encoding="utf-8"?>
 <p:sld xmlns:a="http://schemas.openxmlformats.org/drawingml/2006/main" xmlns:r="http://schemas.openxmlformats.org/officeDocument/2006/relationships" xmlns:p="http://schemas.openxmlformats.org/presentationml/2006/main">
   <p:cSld>
     <p:spTree>
@@ -4499,4 +6107,319 @@
     </a:ext>
   </a:extLst>
 </a:theme>
+</file>
+
+<file path=ppt/theme/theme2.xml><?xml version="1.0" encoding="utf-8"?>
+<a:theme xmlns:a="http://schemas.openxmlformats.org/drawingml/2006/main" name="Thème Office">
+  <a:themeElements>
+    <a:clrScheme name="Office">
+      <a:dk1>
+        <a:sysClr val="windowText" lastClr="000000"/>
+      </a:dk1>
+      <a:lt1>
+        <a:sysClr val="window" lastClr="FFFFFF"/>
+      </a:lt1>
+      <a:dk2>
+        <a:srgbClr val="0E2841"/>
+      </a:dk2>
+      <a:lt2>
+        <a:srgbClr val="E8E8E8"/>
+      </a:lt2>
+      <a:accent1>
+        <a:srgbClr val="156082"/>
+      </a:accent1>
+      <a:accent2>
+        <a:srgbClr val="E97132"/>
+      </a:accent2>
+      <a:accent3>
+        <a:srgbClr val="196B24"/>
+      </a:accent3>
+      <a:accent4>
+        <a:srgbClr val="0F9ED5"/>
+      </a:accent4>
+      <a:accent5>
+        <a:srgbClr val="A02B93"/>
+      </a:accent5>
+      <a:accent6>
+        <a:srgbClr val="4EA72E"/>
+      </a:accent6>
+      <a:hlink>
+        <a:srgbClr val="467886"/>
+      </a:hlink>
+      <a:folHlink>
+        <a:srgbClr val="96607D"/>
+      </a:folHlink>
+    </a:clrScheme>
+    <a:fontScheme name="Office">
+      <a:majorFont>
+        <a:latin typeface="Aptos Display" panose="02110004020202020204"/>
+        <a:ea typeface=""/>
+        <a:cs typeface=""/>
+        <a:font script="Jpan" typeface="游ゴシック Light"/>
+        <a:font script="Hang" typeface="맑은 고딕"/>
+        <a:font script="Hans" typeface="等线 Light"/>
+        <a:font script="Hant" typeface="新細明體"/>
+        <a:font script="Arab" typeface="Times New Roman"/>
+        <a:font script="Hebr" typeface="Times New Roman"/>
+        <a:font script="Thai" typeface="Angsana New"/>
+        <a:font script="Ethi" typeface="Nyala"/>
+        <a:font script="Beng" typeface="Vrinda"/>
+        <a:font script="Gujr" typeface="Shruti"/>
+        <a:font script="Khmr" typeface="MoolBoran"/>
+        <a:font script="Knda" typeface="Tunga"/>
+        <a:font script="Guru" typeface="Raavi"/>
+        <a:font script="Cans" typeface="Euphemia"/>
+        <a:font script="Cher" typeface="Plantagenet Cherokee"/>
+        <a:font script="Yiii" typeface="Microsoft Yi Baiti"/>
+        <a:font script="Tibt" typeface="Microsoft Himalaya"/>
+        <a:font script="Thaa" typeface="MV Boli"/>
+        <a:font script="Deva" typeface="Mangal"/>
+        <a:font script="Telu" typeface="Gautami"/>
+        <a:font script="Taml" typeface="Latha"/>
+        <a:font script="Syrc" typeface="Estrangelo Edessa"/>
+        <a:font script="Orya" typeface="Kalinga"/>
+        <a:font script="Mlym" typeface="Kartika"/>
+        <a:font script="Laoo" typeface="DokChampa"/>
+        <a:font script="Sinh" typeface="Iskoola Pota"/>
+        <a:font script="Mong" typeface="Mongolian Baiti"/>
+        <a:font script="Viet" typeface="Times New Roman"/>
+        <a:font script="Uigh" typeface="Microsoft Uighur"/>
+        <a:font script="Geor" typeface="Sylfaen"/>
+        <a:font script="Armn" typeface="Arial"/>
+        <a:font script="Bugi" typeface="Leelawadee UI"/>
+        <a:font script="Bopo" typeface="Microsoft JhengHei"/>
+        <a:font script="Java" typeface="Javanese Text"/>
+        <a:font script="Lisu" typeface="Segoe UI"/>
+        <a:font script="Mymr" typeface="Myanmar Text"/>
+        <a:font script="Nkoo" typeface="Ebrima"/>
+        <a:font script="Olck" typeface="Nirmala UI"/>
+        <a:font script="Osma" typeface="Ebrima"/>
+        <a:font script="Phag" typeface="Phagspa"/>
+        <a:font script="Syrn" typeface="Estrangelo Edessa"/>
+        <a:font script="Syrj" typeface="Estrangelo Edessa"/>
+        <a:font script="Syre" typeface="Estrangelo Edessa"/>
+        <a:font script="Sora" typeface="Nirmala UI"/>
+        <a:font script="Tale" typeface="Microsoft Tai Le"/>
+        <a:font script="Talu" typeface="Microsoft New Tai Lue"/>
+        <a:font script="Tfng" typeface="Ebrima"/>
+      </a:majorFont>
+      <a:minorFont>
+        <a:latin typeface="Aptos" panose="02110004020202020204"/>
+        <a:ea typeface=""/>
+        <a:cs typeface=""/>
+        <a:font script="Jpan" typeface="游ゴシック"/>
+        <a:font script="Hang" typeface="맑은 고딕"/>
+        <a:font script="Hans" typeface="等线"/>
+        <a:font script="Hant" typeface="新細明體"/>
+        <a:font script="Arab" typeface="Arial"/>
+        <a:font script="Hebr" typeface="Arial"/>
+        <a:font script="Thai" typeface="Cordia New"/>
+        <a:font script="Ethi" typeface="Nyala"/>
+        <a:font script="Beng" typeface="Vrinda"/>
+        <a:font script="Gujr" typeface="Shruti"/>
+        <a:font script="Khmr" typeface="DaunPenh"/>
+        <a:font script="Knda" typeface="Tunga"/>
+        <a:font script="Guru" typeface="Raavi"/>
+        <a:font script="Cans" typeface="Euphemia"/>
+        <a:font script="Cher" typeface="Plantagenet Cherokee"/>
+        <a:font script="Yiii" typeface="Microsoft Yi Baiti"/>
+        <a:font script="Tibt" typeface="Microsoft Himalaya"/>
+        <a:font script="Thaa" typeface="MV Boli"/>
+        <a:font script="Deva" typeface="Mangal"/>
+        <a:font script="Telu" typeface="Gautami"/>
+        <a:font script="Taml" typeface="Latha"/>
+        <a:font script="Syrc" typeface="Estrangelo Edessa"/>
+        <a:font script="Orya" typeface="Kalinga"/>
+        <a:font script="Mlym" typeface="Kartika"/>
+        <a:font script="Laoo" typeface="DokChampa"/>
+        <a:font script="Sinh" typeface="Iskoola Pota"/>
+        <a:font script="Mong" typeface="Mongolian Baiti"/>
+        <a:font script="Viet" typeface="Arial"/>
+        <a:font script="Uigh" typeface="Microsoft Uighur"/>
+        <a:font script="Geor" typeface="Sylfaen"/>
+        <a:font script="Armn" typeface="Arial"/>
+        <a:font script="Bugi" typeface="Leelawadee UI"/>
+        <a:font script="Bopo" typeface="Microsoft JhengHei"/>
+        <a:font script="Java" typeface="Javanese Text"/>
+        <a:font script="Lisu" typeface="Segoe UI"/>
+        <a:font script="Mymr" typeface="Myanmar Text"/>
+        <a:font script="Nkoo" typeface="Ebrima"/>
+        <a:font script="Olck" typeface="Nirmala UI"/>
+        <a:font script="Osma" typeface="Ebrima"/>
+        <a:font script="Phag" typeface="Phagspa"/>
+        <a:font script="Syrn" typeface="Estrangelo Edessa"/>
+        <a:font script="Syrj" typeface="Estrangelo Edessa"/>
+        <a:font script="Syre" typeface="Estrangelo Edessa"/>
+        <a:font script="Sora" typeface="Nirmala UI"/>
+        <a:font script="Tale" typeface="Microsoft Tai Le"/>
+        <a:font script="Talu" typeface="Microsoft New Tai Lue"/>
+        <a:font script="Tfng" typeface="Ebrima"/>
+      </a:minorFont>
+    </a:fontScheme>
+    <a:fmtScheme name="Office">
+      <a:fillStyleLst>
+        <a:solidFill>
+          <a:schemeClr val="phClr"/>
+        </a:solidFill>
+        <a:gradFill rotWithShape="1">
+          <a:gsLst>
+            <a:gs pos="0">
+              <a:schemeClr val="phClr">
+                <a:lumMod val="110000"/>
+                <a:satMod val="105000"/>
+                <a:tint val="67000"/>
+              </a:schemeClr>
+            </a:gs>
+            <a:gs pos="50000">
+              <a:schemeClr val="phClr">
+                <a:lumMod val="105000"/>
+                <a:satMod val="103000"/>
+                <a:tint val="73000"/>
+              </a:schemeClr>
+            </a:gs>
+            <a:gs pos="100000">
+              <a:schemeClr val="phClr">
+                <a:lumMod val="105000"/>
+                <a:satMod val="109000"/>
+                <a:tint val="81000"/>
+              </a:schemeClr>
+            </a:gs>
+          </a:gsLst>
+          <a:lin ang="5400000" scaled="0"/>
+        </a:gradFill>
+        <a:gradFill rotWithShape="1">
+          <a:gsLst>
+            <a:gs pos="0">
+              <a:schemeClr val="phClr">
+                <a:satMod val="103000"/>
+                <a:lumMod val="102000"/>
+                <a:tint val="94000"/>
+              </a:schemeClr>
+            </a:gs>
+            <a:gs pos="50000">
+              <a:schemeClr val="phClr">
+                <a:satMod val="110000"/>
+                <a:lumMod val="100000"/>
+                <a:shade val="100000"/>
+              </a:schemeClr>
+            </a:gs>
+            <a:gs pos="100000">
+              <a:schemeClr val="phClr">
+                <a:lumMod val="99000"/>
+                <a:satMod val="120000"/>
+                <a:shade val="78000"/>
+              </a:schemeClr>
+            </a:gs>
+          </a:gsLst>
+          <a:lin ang="5400000" scaled="0"/>
+        </a:gradFill>
+      </a:fillStyleLst>
+      <a:lnStyleLst>
+        <a:ln w="12700" cap="flat" cmpd="sng" algn="ctr">
+          <a:solidFill>
+            <a:schemeClr val="phClr"/>
+          </a:solidFill>
+          <a:prstDash val="solid"/>
+          <a:miter lim="800000"/>
+        </a:ln>
+        <a:ln w="19050" cap="flat" cmpd="sng" algn="ctr">
+          <a:solidFill>
+            <a:schemeClr val="phClr"/>
+          </a:solidFill>
+          <a:prstDash val="solid"/>
+          <a:miter lim="800000"/>
+        </a:ln>
+        <a:ln w="25400" cap="flat" cmpd="sng" algn="ctr">
+          <a:solidFill>
+            <a:schemeClr val="phClr"/>
+          </a:solidFill>
+          <a:prstDash val="solid"/>
+          <a:miter lim="800000"/>
+        </a:ln>
+      </a:lnStyleLst>
+      <a:effectStyleLst>
+        <a:effectStyle>
+          <a:effectLst/>
+        </a:effectStyle>
+        <a:effectStyle>
+          <a:effectLst/>
+        </a:effectStyle>
+        <a:effectStyle>
+          <a:effectLst>
+            <a:outerShdw blurRad="57150" dist="19050" dir="5400000" algn="ctr" rotWithShape="0">
+              <a:srgbClr val="000000">
+                <a:alpha val="63000"/>
+              </a:srgbClr>
+            </a:outerShdw>
+          </a:effectLst>
+        </a:effectStyle>
+      </a:effectStyleLst>
+      <a:bgFillStyleLst>
+        <a:solidFill>
+          <a:schemeClr val="phClr"/>
+        </a:solidFill>
+        <a:solidFill>
+          <a:schemeClr val="phClr">
+            <a:tint val="95000"/>
+            <a:satMod val="170000"/>
+          </a:schemeClr>
+        </a:solidFill>
+        <a:gradFill rotWithShape="1">
+          <a:gsLst>
+            <a:gs pos="0">
+              <a:schemeClr val="phClr">
+                <a:tint val="93000"/>
+                <a:satMod val="150000"/>
+                <a:shade val="98000"/>
+                <a:lumMod val="102000"/>
+              </a:schemeClr>
+            </a:gs>
+            <a:gs pos="50000">
+              <a:schemeClr val="phClr">
+                <a:tint val="98000"/>
+                <a:satMod val="130000"/>
+                <a:shade val="90000"/>
+                <a:lumMod val="103000"/>
+              </a:schemeClr>
+            </a:gs>
+            <a:gs pos="100000">
+              <a:schemeClr val="phClr">
+                <a:shade val="63000"/>
+                <a:satMod val="120000"/>
+              </a:schemeClr>
+            </a:gs>
+          </a:gsLst>
+          <a:lin ang="5400000" scaled="0"/>
+        </a:gradFill>
+      </a:bgFillStyleLst>
+    </a:fmtScheme>
+  </a:themeElements>
+  <a:objectDefaults>
+    <a:lnDef>
+      <a:spPr/>
+      <a:bodyPr/>
+      <a:lstStyle/>
+      <a:style>
+        <a:lnRef idx="2">
+          <a:schemeClr val="accent1"/>
+        </a:lnRef>
+        <a:fillRef idx="0">
+          <a:schemeClr val="accent1"/>
+        </a:fillRef>
+        <a:effectRef idx="1">
+          <a:schemeClr val="accent1"/>
+        </a:effectRef>
+        <a:fontRef idx="minor">
+          <a:schemeClr val="tx1"/>
+        </a:fontRef>
+      </a:style>
+    </a:lnDef>
+  </a:objectDefaults>
+  <a:extraClrSchemeLst/>
+  <a:extLst>
+    <a:ext uri="{05A4C25C-085E-4340-85A3-A5531E510DB2}">
+      <thm15:themeFamily xmlns:thm15="http://schemas.microsoft.com/office/thememl/2012/main" name="Office Theme" id="{2E142A2C-CD16-42D6-873A-C26D2A0506FA}" vid="{1BDDFF52-6CD6-40A5-AB3C-68EB2F1E4D0A}"/>
+    </a:ext>
+  </a:extLst>
+</a:theme>
 </file>
</xml_diff>

<commit_message>
feat: page des fiches solutions : premiers attributs
</commit_message>
<xml_diff>
--- a/public/templates/template_synthese_projet.pptx
+++ b/public/templates/template_synthese_projet.pptx
@@ -4008,12 +4008,156 @@
           </a:prstGeom>
         </p:spPr>
       </p:pic>
+      <p:sp>
+        <p:nvSpPr>
+          <p:cNvPr id="6" name="Text 10">
+            <a:extLst>
+              <a:ext uri="{FF2B5EF4-FFF2-40B4-BE49-F238E27FC236}">
+                <a16:creationId xmlns:a16="http://schemas.microsoft.com/office/drawing/2014/main" id="{8CD713CB-3BC6-C09D-7C54-788D2169DE28}"/>
+              </a:ext>
+            </a:extLst>
+          </p:cNvPr>
+          <p:cNvSpPr/>
+          <p:nvPr/>
+        </p:nvSpPr>
+        <p:spPr>
+          <a:xfrm>
+            <a:off x="2072640" y="6385100"/>
+            <a:ext cx="8046720" cy="201168"/>
+          </a:xfrm>
+          <a:prstGeom prst="rect">
+            <a:avLst/>
+          </a:prstGeom>
+          <a:noFill/>
+          <a:ln/>
+        </p:spPr>
+        <p:txBody>
+          <a:bodyPr wrap="square" lIns="0" tIns="0" rIns="0" bIns="0" rtlCol="0" anchor="ctr"/>
+          <a:lstStyle/>
+          <a:p>
+            <a:pPr marL="0" indent="0" algn="ctr">
+              <a:buNone/>
+            </a:pPr>
+            <a:r>
+              <a:rPr lang="en-US" sz="1000" i="1" dirty="0" err="1">
+                <a:solidFill>
+                  <a:srgbClr val="A0A0A0"/>
+                </a:solidFill>
+                <a:latin typeface="Calibri" pitchFamily="34" charset="0"/>
+                <a:ea typeface="Calibri" pitchFamily="34" charset="-122"/>
+                <a:cs typeface="Calibri" pitchFamily="34" charset="-120"/>
+              </a:rPr>
+              <a:t>Projet</a:t>
+            </a:r>
+            <a:r>
+              <a:rPr lang="en-US" sz="1000" i="1" dirty="0">
+                <a:solidFill>
+                  <a:srgbClr val="A0A0A0"/>
+                </a:solidFill>
+                <a:latin typeface="Calibri" pitchFamily="34" charset="0"/>
+                <a:ea typeface="Calibri" pitchFamily="34" charset="-122"/>
+                <a:cs typeface="Calibri" pitchFamily="34" charset="-120"/>
+              </a:rPr>
+              <a:t> </a:t>
+            </a:r>
+            <a:r>
+              <a:rPr lang="en-US" sz="1000" i="1" dirty="0" err="1">
+                <a:solidFill>
+                  <a:srgbClr val="A0A0A0"/>
+                </a:solidFill>
+                <a:latin typeface="Calibri" pitchFamily="34" charset="0"/>
+                <a:ea typeface="Calibri" pitchFamily="34" charset="-122"/>
+                <a:cs typeface="Calibri" pitchFamily="34" charset="-120"/>
+              </a:rPr>
+              <a:t>généré</a:t>
+            </a:r>
+            <a:r>
+              <a:rPr lang="en-US" sz="1000" i="1" dirty="0">
+                <a:solidFill>
+                  <a:srgbClr val="A0A0A0"/>
+                </a:solidFill>
+                <a:latin typeface="Calibri" pitchFamily="34" charset="0"/>
+                <a:ea typeface="Calibri" pitchFamily="34" charset="-122"/>
+                <a:cs typeface="Calibri" pitchFamily="34" charset="-120"/>
+              </a:rPr>
+              <a:t> le {{</a:t>
+            </a:r>
+            <a:r>
+              <a:rPr lang="en-US" sz="1000" i="1" dirty="0" err="1">
+                <a:solidFill>
+                  <a:srgbClr val="A0A0A0"/>
+                </a:solidFill>
+                <a:latin typeface="Calibri" pitchFamily="34" charset="0"/>
+                <a:ea typeface="Calibri" pitchFamily="34" charset="-122"/>
+                <a:cs typeface="Calibri" pitchFamily="34" charset="-120"/>
+              </a:rPr>
+              <a:t>date_generation_synthese</a:t>
+            </a:r>
+            <a:r>
+              <a:rPr lang="en-US" sz="1000" i="1" dirty="0">
+                <a:solidFill>
+                  <a:srgbClr val="A0A0A0"/>
+                </a:solidFill>
+                <a:latin typeface="Calibri" pitchFamily="34" charset="0"/>
+                <a:ea typeface="Calibri" pitchFamily="34" charset="-122"/>
+                <a:cs typeface="Calibri" pitchFamily="34" charset="-120"/>
+              </a:rPr>
+              <a:t>}} via Plus </a:t>
+            </a:r>
+            <a:r>
+              <a:rPr lang="en-US" sz="1000" i="1" dirty="0" err="1">
+                <a:solidFill>
+                  <a:srgbClr val="A0A0A0"/>
+                </a:solidFill>
+                <a:latin typeface="Calibri" pitchFamily="34" charset="0"/>
+                <a:ea typeface="Calibri" pitchFamily="34" charset="-122"/>
+                <a:cs typeface="Calibri" pitchFamily="34" charset="-120"/>
+              </a:rPr>
+              <a:t>fraîche</a:t>
+            </a:r>
+            <a:r>
+              <a:rPr lang="en-US" sz="1000" i="1" dirty="0">
+                <a:solidFill>
+                  <a:srgbClr val="A0A0A0"/>
+                </a:solidFill>
+                <a:latin typeface="Calibri" pitchFamily="34" charset="0"/>
+                <a:ea typeface="Calibri" pitchFamily="34" charset="-122"/>
+                <a:cs typeface="Calibri" pitchFamily="34" charset="-120"/>
+              </a:rPr>
+              <a:t> ma </a:t>
+            </a:r>
+            <a:r>
+              <a:rPr lang="en-US" sz="1000" i="1" dirty="0" err="1">
+                <a:solidFill>
+                  <a:srgbClr val="A0A0A0"/>
+                </a:solidFill>
+                <a:latin typeface="Calibri" pitchFamily="34" charset="0"/>
+                <a:ea typeface="Calibri" pitchFamily="34" charset="-122"/>
+                <a:cs typeface="Calibri" pitchFamily="34" charset="-120"/>
+              </a:rPr>
+              <a:t>ville</a:t>
+            </a:r>
+            <a:r>
+              <a:rPr lang="en-US" sz="1000" i="1" dirty="0">
+                <a:solidFill>
+                  <a:srgbClr val="A0A0A0"/>
+                </a:solidFill>
+                <a:latin typeface="Calibri" pitchFamily="34" charset="0"/>
+                <a:ea typeface="Calibri" pitchFamily="34" charset="-122"/>
+                <a:cs typeface="Calibri" pitchFamily="34" charset="-120"/>
+              </a:rPr>
+              <a:t> (ADEME)</a:t>
+            </a:r>
+            <a:endParaRPr lang="en-US" sz="1000" dirty="0"/>
+          </a:p>
+        </p:txBody>
+      </p:sp>
       <p:pic>
         <p:nvPicPr>
-          <p:cNvPr id="5" name="Picture 1">
-            <a:extLst>
-              <a:ext uri="{FF2B5EF4-FFF2-40B4-BE49-F238E27FC236}">
-                <a16:creationId xmlns:a16="http://schemas.microsoft.com/office/drawing/2014/main" id="{7E542749-53FE-0587-7981-2109CA078F11}"/>
+          <p:cNvPr id="7" name="Picture 3">
+            <a:extLst>
+              <a:ext uri="{FF2B5EF4-FFF2-40B4-BE49-F238E27FC236}">
+                <a16:creationId xmlns:a16="http://schemas.microsoft.com/office/drawing/2014/main" id="{76322E58-8C9F-63C6-0CAF-9FBB07903158}"/>
               </a:ext>
             </a:extLst>
           </p:cNvPr>
@@ -4030,7 +4174,7 @@
         </p:blipFill>
         <p:spPr>
           <a:xfrm>
-            <a:off x="10367627" y="257327"/>
+            <a:off x="10546452" y="104580"/>
             <a:ext cx="1552051" cy="758533"/>
           </a:xfrm>
           <a:prstGeom prst="rect">
@@ -4038,150 +4182,6 @@
           </a:prstGeom>
         </p:spPr>
       </p:pic>
-      <p:sp>
-        <p:nvSpPr>
-          <p:cNvPr id="6" name="Text 10">
-            <a:extLst>
-              <a:ext uri="{FF2B5EF4-FFF2-40B4-BE49-F238E27FC236}">
-                <a16:creationId xmlns:a16="http://schemas.microsoft.com/office/drawing/2014/main" id="{8CD713CB-3BC6-C09D-7C54-788D2169DE28}"/>
-              </a:ext>
-            </a:extLst>
-          </p:cNvPr>
-          <p:cNvSpPr/>
-          <p:nvPr/>
-        </p:nvSpPr>
-        <p:spPr>
-          <a:xfrm>
-            <a:off x="2072640" y="6385100"/>
-            <a:ext cx="8046720" cy="201168"/>
-          </a:xfrm>
-          <a:prstGeom prst="rect">
-            <a:avLst/>
-          </a:prstGeom>
-          <a:noFill/>
-          <a:ln/>
-        </p:spPr>
-        <p:txBody>
-          <a:bodyPr wrap="square" lIns="0" tIns="0" rIns="0" bIns="0" rtlCol="0" anchor="ctr"/>
-          <a:lstStyle/>
-          <a:p>
-            <a:pPr marL="0" indent="0" algn="ctr">
-              <a:buNone/>
-            </a:pPr>
-            <a:r>
-              <a:rPr lang="en-US" sz="1000" i="1" dirty="0" err="1">
-                <a:solidFill>
-                  <a:srgbClr val="A0A0A0"/>
-                </a:solidFill>
-                <a:latin typeface="Calibri" pitchFamily="34" charset="0"/>
-                <a:ea typeface="Calibri" pitchFamily="34" charset="-122"/>
-                <a:cs typeface="Calibri" pitchFamily="34" charset="-120"/>
-              </a:rPr>
-              <a:t>Projet</a:t>
-            </a:r>
-            <a:r>
-              <a:rPr lang="en-US" sz="1000" i="1" dirty="0">
-                <a:solidFill>
-                  <a:srgbClr val="A0A0A0"/>
-                </a:solidFill>
-                <a:latin typeface="Calibri" pitchFamily="34" charset="0"/>
-                <a:ea typeface="Calibri" pitchFamily="34" charset="-122"/>
-                <a:cs typeface="Calibri" pitchFamily="34" charset="-120"/>
-              </a:rPr>
-              <a:t> </a:t>
-            </a:r>
-            <a:r>
-              <a:rPr lang="en-US" sz="1000" i="1" dirty="0" err="1">
-                <a:solidFill>
-                  <a:srgbClr val="A0A0A0"/>
-                </a:solidFill>
-                <a:latin typeface="Calibri" pitchFamily="34" charset="0"/>
-                <a:ea typeface="Calibri" pitchFamily="34" charset="-122"/>
-                <a:cs typeface="Calibri" pitchFamily="34" charset="-120"/>
-              </a:rPr>
-              <a:t>généré</a:t>
-            </a:r>
-            <a:r>
-              <a:rPr lang="en-US" sz="1000" i="1" dirty="0">
-                <a:solidFill>
-                  <a:srgbClr val="A0A0A0"/>
-                </a:solidFill>
-                <a:latin typeface="Calibri" pitchFamily="34" charset="0"/>
-                <a:ea typeface="Calibri" pitchFamily="34" charset="-122"/>
-                <a:cs typeface="Calibri" pitchFamily="34" charset="-120"/>
-              </a:rPr>
-              <a:t> le {{</a:t>
-            </a:r>
-            <a:r>
-              <a:rPr lang="en-US" sz="1000" i="1" dirty="0" err="1">
-                <a:solidFill>
-                  <a:srgbClr val="A0A0A0"/>
-                </a:solidFill>
-                <a:latin typeface="Calibri" pitchFamily="34" charset="0"/>
-                <a:ea typeface="Calibri" pitchFamily="34" charset="-122"/>
-                <a:cs typeface="Calibri" pitchFamily="34" charset="-120"/>
-              </a:rPr>
-              <a:t>date_generation_synthese</a:t>
-            </a:r>
-            <a:r>
-              <a:rPr lang="en-US" sz="1000" i="1" dirty="0">
-                <a:solidFill>
-                  <a:srgbClr val="A0A0A0"/>
-                </a:solidFill>
-                <a:latin typeface="Calibri" pitchFamily="34" charset="0"/>
-                <a:ea typeface="Calibri" pitchFamily="34" charset="-122"/>
-                <a:cs typeface="Calibri" pitchFamily="34" charset="-120"/>
-              </a:rPr>
-              <a:t>}} via Plus </a:t>
-            </a:r>
-            <a:r>
-              <a:rPr lang="en-US" sz="1000" i="1" dirty="0" err="1">
-                <a:solidFill>
-                  <a:srgbClr val="A0A0A0"/>
-                </a:solidFill>
-                <a:latin typeface="Calibri" pitchFamily="34" charset="0"/>
-                <a:ea typeface="Calibri" pitchFamily="34" charset="-122"/>
-                <a:cs typeface="Calibri" pitchFamily="34" charset="-120"/>
-              </a:rPr>
-              <a:t>fraîche</a:t>
-            </a:r>
-            <a:r>
-              <a:rPr lang="en-US" sz="1000" i="1" dirty="0">
-                <a:solidFill>
-                  <a:srgbClr val="A0A0A0"/>
-                </a:solidFill>
-                <a:latin typeface="Calibri" pitchFamily="34" charset="0"/>
-                <a:ea typeface="Calibri" pitchFamily="34" charset="-122"/>
-                <a:cs typeface="Calibri" pitchFamily="34" charset="-120"/>
-              </a:rPr>
-              <a:t> ma </a:t>
-            </a:r>
-            <a:r>
-              <a:rPr lang="en-US" sz="1000" i="1" dirty="0" err="1">
-                <a:solidFill>
-                  <a:srgbClr val="A0A0A0"/>
-                </a:solidFill>
-                <a:latin typeface="Calibri" pitchFamily="34" charset="0"/>
-                <a:ea typeface="Calibri" pitchFamily="34" charset="-122"/>
-                <a:cs typeface="Calibri" pitchFamily="34" charset="-120"/>
-              </a:rPr>
-              <a:t>ville</a:t>
-            </a:r>
-            <a:r>
-              <a:rPr lang="en-US" sz="1000" i="1" dirty="0">
-                <a:solidFill>
-                  <a:srgbClr val="A0A0A0"/>
-                </a:solidFill>
-                <a:latin typeface="Calibri" pitchFamily="34" charset="0"/>
-                <a:ea typeface="Calibri" pitchFamily="34" charset="-122"/>
-                <a:cs typeface="Calibri" pitchFamily="34" charset="-120"/>
-              </a:rPr>
-              <a:t> (ADEME)</a:t>
-            </a:r>
-            <a:endParaRPr lang="en-US" sz="1000" dirty="0"/>
-          </a:p>
-        </p:txBody>
-      </p:sp>
     </p:spTree>
     <p:extLst>
       <p:ext uri="{BB962C8B-B14F-4D97-AF65-F5344CB8AC3E}">
@@ -4246,7 +4246,9 @@
           <a:lstStyle/>
           <a:p>
             <a:endParaRPr lang="en-US" sz="13333" dirty="0">
-              <a:latin typeface="Aptos" panose="020B0004020202020204" pitchFamily="34" charset="0"/>
+              <a:latin typeface="Calibri" panose="020F0502020204030204" pitchFamily="34" charset="0"/>
+              <a:ea typeface="Calibri" panose="020F0502020204030204" pitchFamily="34" charset="0"/>
+              <a:cs typeface="Calibri" panose="020F0502020204030204" pitchFamily="34" charset="0"/>
             </a:endParaRPr>
           </a:p>
         </p:txBody>
@@ -4283,9 +4285,9 @@
                 <a:solidFill>
                   <a:srgbClr val="1A1A1A"/>
                 </a:solidFill>
-                <a:latin typeface="Aptos" panose="020B0004020202020204" pitchFamily="34" charset="0"/>
-                <a:ea typeface="Calibri" pitchFamily="34" charset="-122"/>
-                <a:cs typeface="Calibri" pitchFamily="34" charset="-120"/>
+                <a:latin typeface="Calibri" panose="020F0502020204030204" pitchFamily="34" charset="0"/>
+                <a:ea typeface="Calibri" panose="020F0502020204030204" pitchFamily="34" charset="0"/>
+                <a:cs typeface="Calibri" panose="020F0502020204030204" pitchFamily="34" charset="0"/>
               </a:rPr>
               <a:t>Solutions de </a:t>
             </a:r>
@@ -4294,9 +4296,9 @@
                 <a:solidFill>
                   <a:srgbClr val="1A1A1A"/>
                 </a:solidFill>
-                <a:latin typeface="Aptos" panose="020B0004020202020204" pitchFamily="34" charset="0"/>
-                <a:ea typeface="Calibri" pitchFamily="34" charset="-122"/>
-                <a:cs typeface="Calibri" pitchFamily="34" charset="-120"/>
+                <a:latin typeface="Calibri" panose="020F0502020204030204" pitchFamily="34" charset="0"/>
+                <a:ea typeface="Calibri" panose="020F0502020204030204" pitchFamily="34" charset="0"/>
+                <a:cs typeface="Calibri" panose="020F0502020204030204" pitchFamily="34" charset="0"/>
               </a:rPr>
               <a:t>rafraîchissement</a:t>
             </a:r>
@@ -4305,9 +4307,9 @@
                 <a:solidFill>
                   <a:srgbClr val="1A1A1A"/>
                 </a:solidFill>
-                <a:latin typeface="Aptos" panose="020B0004020202020204" pitchFamily="34" charset="0"/>
-                <a:ea typeface="Calibri" pitchFamily="34" charset="-122"/>
-                <a:cs typeface="Calibri" pitchFamily="34" charset="-120"/>
+                <a:latin typeface="Calibri" panose="020F0502020204030204" pitchFamily="34" charset="0"/>
+                <a:ea typeface="Calibri" panose="020F0502020204030204" pitchFamily="34" charset="0"/>
+                <a:cs typeface="Calibri" panose="020F0502020204030204" pitchFamily="34" charset="0"/>
               </a:rPr>
               <a:t> </a:t>
             </a:r>
@@ -4316,14 +4318,16 @@
                 <a:solidFill>
                   <a:srgbClr val="1A1A1A"/>
                 </a:solidFill>
-                <a:latin typeface="Aptos" panose="020B0004020202020204" pitchFamily="34" charset="0"/>
-                <a:ea typeface="Calibri" pitchFamily="34" charset="-122"/>
-                <a:cs typeface="Calibri" pitchFamily="34" charset="-120"/>
+                <a:latin typeface="Calibri" panose="020F0502020204030204" pitchFamily="34" charset="0"/>
+                <a:ea typeface="Calibri" panose="020F0502020204030204" pitchFamily="34" charset="0"/>
+                <a:cs typeface="Calibri" panose="020F0502020204030204" pitchFamily="34" charset="0"/>
               </a:rPr>
               <a:t>retenues</a:t>
             </a:r>
             <a:endParaRPr lang="en-US" sz="3733" dirty="0">
-              <a:latin typeface="Aptos" panose="020B0004020202020204" pitchFamily="34" charset="0"/>
+              <a:latin typeface="Calibri" panose="020F0502020204030204" pitchFamily="34" charset="0"/>
+              <a:ea typeface="Calibri" panose="020F0502020204030204" pitchFamily="34" charset="0"/>
+              <a:cs typeface="Calibri" panose="020F0502020204030204" pitchFamily="34" charset="0"/>
             </a:endParaRPr>
           </a:p>
         </p:txBody>
@@ -4362,7 +4366,11 @@
           <a:bodyPr/>
           <a:lstStyle/>
           <a:p>
-            <a:endParaRPr lang="fr-FR" sz="2400"/>
+            <a:endParaRPr lang="fr-FR" sz="2400">
+              <a:latin typeface="Calibri" panose="020F0502020204030204" pitchFamily="34" charset="0"/>
+              <a:ea typeface="Calibri" panose="020F0502020204030204" pitchFamily="34" charset="0"/>
+              <a:cs typeface="Calibri" panose="020F0502020204030204" pitchFamily="34" charset="0"/>
+            </a:endParaRPr>
           </a:p>
         </p:txBody>
       </p:sp>
@@ -4402,8 +4410,9 @@
                 <a:solidFill>
                   <a:srgbClr val="5C5C5C"/>
                 </a:solidFill>
-                <a:latin typeface="Aptos" panose="020B0004020202020204" pitchFamily="34" charset="0"/>
-                <a:cs typeface="Calibri" pitchFamily="34" charset="-120"/>
+                <a:latin typeface="Calibri" panose="020F0502020204030204" pitchFamily="34" charset="0"/>
+                <a:ea typeface="Calibri" panose="020F0502020204030204" pitchFamily="34" charset="0"/>
+                <a:cs typeface="Calibri" panose="020F0502020204030204" pitchFamily="34" charset="0"/>
               </a:rPr>
               <a:t>{{</a:t>
             </a:r>
@@ -4412,8 +4421,9 @@
                 <a:solidFill>
                   <a:srgbClr val="5C5C5C"/>
                 </a:solidFill>
-                <a:latin typeface="Aptos" panose="020B0004020202020204" pitchFamily="34" charset="0"/>
-                <a:cs typeface="Calibri" pitchFamily="34" charset="-120"/>
+                <a:latin typeface="Calibri" panose="020F0502020204030204" pitchFamily="34" charset="0"/>
+                <a:ea typeface="Calibri" panose="020F0502020204030204" pitchFamily="34" charset="0"/>
+                <a:cs typeface="Calibri" panose="020F0502020204030204" pitchFamily="34" charset="0"/>
               </a:rPr>
               <a:t>titre_fiches_solution</a:t>
             </a:r>
@@ -4422,8 +4432,9 @@
                 <a:solidFill>
                   <a:srgbClr val="5C5C5C"/>
                 </a:solidFill>
-                <a:latin typeface="Aptos" panose="020B0004020202020204" pitchFamily="34" charset="0"/>
-                <a:cs typeface="Calibri" pitchFamily="34" charset="-120"/>
+                <a:latin typeface="Calibri" panose="020F0502020204030204" pitchFamily="34" charset="0"/>
+                <a:ea typeface="Calibri" panose="020F0502020204030204" pitchFamily="34" charset="0"/>
+                <a:cs typeface="Calibri" panose="020F0502020204030204" pitchFamily="34" charset="0"/>
               </a:rPr>
               <a:t>}}</a:t>
             </a:r>
@@ -4510,13 +4521,17 @@
                 <a:solidFill>
                   <a:srgbClr val="A0A0A0"/>
                 </a:solidFill>
-                <a:latin typeface="Calibri" pitchFamily="34" charset="0"/>
-                <a:ea typeface="Calibri" pitchFamily="34" charset="-122"/>
-                <a:cs typeface="Calibri" pitchFamily="34" charset="-120"/>
+                <a:latin typeface="Calibri" panose="020F0502020204030204" pitchFamily="34" charset="0"/>
+                <a:ea typeface="Calibri" panose="020F0502020204030204" pitchFamily="34" charset="0"/>
+                <a:cs typeface="Calibri" panose="020F0502020204030204" pitchFamily="34" charset="0"/>
               </a:rPr>
               <a:t>Données issues de Plus fraîche ma ville (ADEME)</a:t>
             </a:r>
-            <a:endParaRPr lang="en-US" sz="1000"/>
+            <a:endParaRPr lang="en-US" sz="1000">
+              <a:latin typeface="Calibri" panose="020F0502020204030204" pitchFamily="34" charset="0"/>
+              <a:ea typeface="Calibri" panose="020F0502020204030204" pitchFamily="34" charset="0"/>
+              <a:cs typeface="Calibri" panose="020F0502020204030204" pitchFamily="34" charset="0"/>
+            </a:endParaRPr>
           </a:p>
         </p:txBody>
       </p:sp>
@@ -4647,23 +4662,43 @@
               <a:buNone/>
             </a:pPr>
             <a:r>
-              <a:rPr lang="en-US" sz="3200" dirty="0"/>
+              <a:rPr lang="en-US" sz="3200" dirty="0">
+                <a:latin typeface="Calibri" panose="020F0502020204030204" pitchFamily="34" charset="0"/>
+                <a:ea typeface="Calibri" panose="020F0502020204030204" pitchFamily="34" charset="0"/>
+                <a:cs typeface="Calibri" panose="020F0502020204030204" pitchFamily="34" charset="0"/>
+              </a:rPr>
               <a:t>Solution {{</a:t>
             </a:r>
             <a:r>
-              <a:rPr lang="en-US" sz="3200" dirty="0" err="1"/>
+              <a:rPr lang="en-US" sz="3200" dirty="0" err="1">
+                <a:latin typeface="Calibri" panose="020F0502020204030204" pitchFamily="34" charset="0"/>
+                <a:ea typeface="Calibri" panose="020F0502020204030204" pitchFamily="34" charset="0"/>
+                <a:cs typeface="Calibri" panose="020F0502020204030204" pitchFamily="34" charset="0"/>
+              </a:rPr>
               <a:t>n°_solution</a:t>
             </a:r>
             <a:r>
-              <a:rPr lang="en-US" sz="3200" dirty="0"/>
+              <a:rPr lang="en-US" sz="3200" dirty="0">
+                <a:latin typeface="Calibri" panose="020F0502020204030204" pitchFamily="34" charset="0"/>
+                <a:ea typeface="Calibri" panose="020F0502020204030204" pitchFamily="34" charset="0"/>
+                <a:cs typeface="Calibri" panose="020F0502020204030204" pitchFamily="34" charset="0"/>
+              </a:rPr>
               <a:t>}} : {{</a:t>
             </a:r>
             <a:r>
-              <a:rPr lang="en-US" sz="3200" dirty="0" err="1"/>
+              <a:rPr lang="en-US" sz="3200" dirty="0" err="1">
+                <a:latin typeface="Calibri" panose="020F0502020204030204" pitchFamily="34" charset="0"/>
+                <a:ea typeface="Calibri" panose="020F0502020204030204" pitchFamily="34" charset="0"/>
+                <a:cs typeface="Calibri" panose="020F0502020204030204" pitchFamily="34" charset="0"/>
+              </a:rPr>
               <a:t>titre_fiche_solution</a:t>
             </a:r>
             <a:r>
-              <a:rPr lang="en-US" sz="3200" dirty="0"/>
+              <a:rPr lang="en-US" sz="3200" dirty="0">
+                <a:latin typeface="Calibri" panose="020F0502020204030204" pitchFamily="34" charset="0"/>
+                <a:ea typeface="Calibri" panose="020F0502020204030204" pitchFamily="34" charset="0"/>
+                <a:cs typeface="Calibri" panose="020F0502020204030204" pitchFamily="34" charset="0"/>
+              </a:rPr>
               <a:t>}}</a:t>
             </a:r>
           </a:p>
@@ -4702,7 +4737,9 @@
                 <a:solidFill>
                   <a:srgbClr val="161616"/>
                 </a:solidFill>
-                <a:latin typeface="Aptos" panose="020B0004020202020204" pitchFamily="34" charset="0"/>
+                <a:latin typeface="Calibri" panose="020F0502020204030204" pitchFamily="34" charset="0"/>
+                <a:ea typeface="Calibri" panose="020F0502020204030204" pitchFamily="34" charset="0"/>
+                <a:cs typeface="Calibri" panose="020F0502020204030204" pitchFamily="34" charset="0"/>
               </a:rPr>
               <a:t>{{</a:t>
             </a:r>
@@ -4711,7 +4748,9 @@
                 <a:solidFill>
                   <a:srgbClr val="161616"/>
                 </a:solidFill>
-                <a:latin typeface="Aptos" panose="020B0004020202020204" pitchFamily="34" charset="0"/>
+                <a:latin typeface="Calibri" panose="020F0502020204030204" pitchFamily="34" charset="0"/>
+                <a:ea typeface="Calibri" panose="020F0502020204030204" pitchFamily="34" charset="0"/>
+                <a:cs typeface="Calibri" panose="020F0502020204030204" pitchFamily="34" charset="0"/>
               </a:rPr>
               <a:t>description_courte_fiche_solution</a:t>
             </a:r>
@@ -4720,12 +4759,16 @@
                 <a:solidFill>
                   <a:srgbClr val="161616"/>
                 </a:solidFill>
-                <a:latin typeface="Aptos" panose="020B0004020202020204" pitchFamily="34" charset="0"/>
+                <a:latin typeface="Calibri" panose="020F0502020204030204" pitchFamily="34" charset="0"/>
+                <a:ea typeface="Calibri" panose="020F0502020204030204" pitchFamily="34" charset="0"/>
+                <a:cs typeface="Calibri" panose="020F0502020204030204" pitchFamily="34" charset="0"/>
               </a:rPr>
               <a:t>}}</a:t>
             </a:r>
             <a:endParaRPr lang="fr-FR" sz="2000" dirty="0">
-              <a:latin typeface="Aptos" panose="020B0004020202020204" pitchFamily="34" charset="0"/>
+              <a:latin typeface="Calibri" panose="020F0502020204030204" pitchFamily="34" charset="0"/>
+              <a:ea typeface="Calibri" panose="020F0502020204030204" pitchFamily="34" charset="0"/>
+              <a:cs typeface="Calibri" panose="020F0502020204030204" pitchFamily="34" charset="0"/>
             </a:endParaRPr>
           </a:p>
         </p:txBody>
@@ -4777,10 +4820,10 @@
       </p:cxnSp>
       <p:pic>
         <p:nvPicPr>
-          <p:cNvPr id="36" name="Image 35" descr="Une image contenant texte, Police, blanc, logo&#10;&#10;Description générée automatiquement">
-            <a:extLst>
-              <a:ext uri="{FF2B5EF4-FFF2-40B4-BE49-F238E27FC236}">
-                <a16:creationId xmlns:a16="http://schemas.microsoft.com/office/drawing/2014/main" id="{F798593A-5338-9D39-2E02-8827877BAC38}"/>
+          <p:cNvPr id="38" name="Image 37" descr="Une image contenant texte, Police, blanc, conception&#10;&#10;Description générée automatiquement">
+            <a:extLst>
+              <a:ext uri="{FF2B5EF4-FFF2-40B4-BE49-F238E27FC236}">
+                <a16:creationId xmlns:a16="http://schemas.microsoft.com/office/drawing/2014/main" id="{AC226DA6-1EF2-CFAB-8908-AEF5C4E4B84A}"/>
               </a:ext>
             </a:extLst>
           </p:cNvPr>
@@ -4797,8 +4840,8 @@
         </p:blipFill>
         <p:spPr>
           <a:xfrm>
-            <a:off x="576263" y="2342710"/>
-            <a:ext cx="3733800" cy="1104900"/>
+            <a:off x="576263" y="5375317"/>
+            <a:ext cx="3975795" cy="830111"/>
           </a:xfrm>
           <a:prstGeom prst="rect">
             <a:avLst/>
@@ -4807,10 +4850,10 @@
       </p:pic>
       <p:pic>
         <p:nvPicPr>
-          <p:cNvPr id="38" name="Image 37" descr="Une image contenant texte, Police, blanc, conception&#10;&#10;Description générée automatiquement">
-            <a:extLst>
-              <a:ext uri="{FF2B5EF4-FFF2-40B4-BE49-F238E27FC236}">
-                <a16:creationId xmlns:a16="http://schemas.microsoft.com/office/drawing/2014/main" id="{AC226DA6-1EF2-CFAB-8908-AEF5C4E4B84A}"/>
+          <p:cNvPr id="40" name="Image 39" descr="Une image contenant texte, Police, blanc, capture d’écran&#10;&#10;Description générée automatiquement">
+            <a:extLst>
+              <a:ext uri="{FF2B5EF4-FFF2-40B4-BE49-F238E27FC236}">
+                <a16:creationId xmlns:a16="http://schemas.microsoft.com/office/drawing/2014/main" id="{A0B7D414-A672-70A2-E902-803986BD58AC}"/>
               </a:ext>
             </a:extLst>
           </p:cNvPr>
@@ -4827,20 +4870,190 @@
         </p:blipFill>
         <p:spPr>
           <a:xfrm>
-            <a:off x="576263" y="5375317"/>
-            <a:ext cx="3975795" cy="830111"/>
+            <a:off x="576263" y="4399297"/>
+            <a:ext cx="4296189" cy="830111"/>
           </a:xfrm>
           <a:prstGeom prst="rect">
             <a:avLst/>
           </a:prstGeom>
         </p:spPr>
       </p:pic>
+      <p:sp>
+        <p:nvSpPr>
+          <p:cNvPr id="43" name="Text 16">
+            <a:extLst>
+              <a:ext uri="{FF2B5EF4-FFF2-40B4-BE49-F238E27FC236}">
+                <a16:creationId xmlns:a16="http://schemas.microsoft.com/office/drawing/2014/main" id="{A300427D-EA15-7150-EA9C-A87450E6202D}"/>
+              </a:ext>
+            </a:extLst>
+          </p:cNvPr>
+          <p:cNvSpPr/>
+          <p:nvPr/>
+        </p:nvSpPr>
+        <p:spPr>
+          <a:xfrm>
+            <a:off x="712188" y="3920740"/>
+            <a:ext cx="2220756" cy="293597"/>
+          </a:xfrm>
+          <a:prstGeom prst="rect">
+            <a:avLst/>
+          </a:prstGeom>
+          <a:noFill/>
+          <a:ln/>
+        </p:spPr>
+        <p:txBody>
+          <a:bodyPr wrap="square" lIns="0" tIns="0" rIns="0" bIns="0" rtlCol="0" anchor="ctr"/>
+          <a:lstStyle/>
+          <a:p>
+            <a:pPr marL="0" indent="0">
+              <a:buNone/>
+            </a:pPr>
+            <a:r>
+              <a:rPr lang="en-US" b="1" kern="0" spc="150">
+                <a:latin typeface="Calibri" panose="020F0502020204030204" pitchFamily="34" charset="0"/>
+                <a:ea typeface="Calibri" panose="020F0502020204030204" pitchFamily="34" charset="0"/>
+                <a:cs typeface="Calibri" panose="020F0502020204030204" pitchFamily="34" charset="0"/>
+              </a:rPr>
+              <a:t>Mise </a:t>
+            </a:r>
+            <a:r>
+              <a:rPr lang="en-US" b="1" kern="0" spc="150" err="1">
+                <a:latin typeface="Calibri" panose="020F0502020204030204" pitchFamily="34" charset="0"/>
+                <a:ea typeface="Calibri" panose="020F0502020204030204" pitchFamily="34" charset="0"/>
+                <a:cs typeface="Calibri" panose="020F0502020204030204" pitchFamily="34" charset="0"/>
+              </a:rPr>
+              <a:t>en</a:t>
+            </a:r>
+            <a:r>
+              <a:rPr lang="en-US" b="1" kern="0" spc="150">
+                <a:latin typeface="Calibri" panose="020F0502020204030204" pitchFamily="34" charset="0"/>
+                <a:ea typeface="Calibri" panose="020F0502020204030204" pitchFamily="34" charset="0"/>
+                <a:cs typeface="Calibri" panose="020F0502020204030204" pitchFamily="34" charset="0"/>
+              </a:rPr>
+              <a:t> oeuvre</a:t>
+            </a:r>
+            <a:endParaRPr lang="en-US">
+              <a:latin typeface="Calibri" panose="020F0502020204030204" pitchFamily="34" charset="0"/>
+              <a:ea typeface="Calibri" panose="020F0502020204030204" pitchFamily="34" charset="0"/>
+              <a:cs typeface="Calibri" panose="020F0502020204030204" pitchFamily="34" charset="0"/>
+            </a:endParaRPr>
+          </a:p>
+        </p:txBody>
+      </p:sp>
+      <p:sp>
+        <p:nvSpPr>
+          <p:cNvPr id="44" name="Text 16">
+            <a:extLst>
+              <a:ext uri="{FF2B5EF4-FFF2-40B4-BE49-F238E27FC236}">
+                <a16:creationId xmlns:a16="http://schemas.microsoft.com/office/drawing/2014/main" id="{E91C9383-E765-31FC-91C1-919BA413B245}"/>
+              </a:ext>
+            </a:extLst>
+          </p:cNvPr>
+          <p:cNvSpPr/>
+          <p:nvPr/>
+        </p:nvSpPr>
+        <p:spPr>
+          <a:xfrm>
+            <a:off x="712188" y="1986268"/>
+            <a:ext cx="2220756" cy="293597"/>
+          </a:xfrm>
+          <a:prstGeom prst="rect">
+            <a:avLst/>
+          </a:prstGeom>
+          <a:noFill/>
+          <a:ln/>
+        </p:spPr>
+        <p:txBody>
+          <a:bodyPr wrap="square" lIns="0" tIns="0" rIns="0" bIns="0" rtlCol="0" anchor="ctr"/>
+          <a:lstStyle/>
+          <a:p>
+            <a:pPr marL="0" indent="0">
+              <a:buNone/>
+            </a:pPr>
+            <a:r>
+              <a:rPr lang="en-US" b="1" kern="0" spc="150" dirty="0" err="1">
+                <a:latin typeface="Calibri" panose="020F0502020204030204" pitchFamily="34" charset="0"/>
+                <a:ea typeface="Calibri" panose="020F0502020204030204" pitchFamily="34" charset="0"/>
+                <a:cs typeface="Calibri" panose="020F0502020204030204" pitchFamily="34" charset="0"/>
+              </a:rPr>
+              <a:t>Résultat</a:t>
+            </a:r>
+            <a:r>
+              <a:rPr lang="en-US" b="1" kern="0" spc="150" dirty="0">
+                <a:latin typeface="Calibri" panose="020F0502020204030204" pitchFamily="34" charset="0"/>
+                <a:ea typeface="Calibri" panose="020F0502020204030204" pitchFamily="34" charset="0"/>
+                <a:cs typeface="Calibri" panose="020F0502020204030204" pitchFamily="34" charset="0"/>
+              </a:rPr>
+              <a:t> </a:t>
+            </a:r>
+            <a:r>
+              <a:rPr lang="en-US" b="1" kern="0" spc="150" dirty="0" err="1">
+                <a:latin typeface="Calibri" panose="020F0502020204030204" pitchFamily="34" charset="0"/>
+                <a:ea typeface="Calibri" panose="020F0502020204030204" pitchFamily="34" charset="0"/>
+                <a:cs typeface="Calibri" panose="020F0502020204030204" pitchFamily="34" charset="0"/>
+              </a:rPr>
+              <a:t>attendu</a:t>
+            </a:r>
+            <a:endParaRPr lang="en-US" dirty="0">
+              <a:latin typeface="Calibri" panose="020F0502020204030204" pitchFamily="34" charset="0"/>
+              <a:ea typeface="Calibri" panose="020F0502020204030204" pitchFamily="34" charset="0"/>
+              <a:cs typeface="Calibri" panose="020F0502020204030204" pitchFamily="34" charset="0"/>
+            </a:endParaRPr>
+          </a:p>
+        </p:txBody>
+      </p:sp>
+      <p:sp>
+        <p:nvSpPr>
+          <p:cNvPr id="45" name="Text 16">
+            <a:extLst>
+              <a:ext uri="{FF2B5EF4-FFF2-40B4-BE49-F238E27FC236}">
+                <a16:creationId xmlns:a16="http://schemas.microsoft.com/office/drawing/2014/main" id="{4F281405-7CF6-3385-6A40-21850D059F03}"/>
+              </a:ext>
+            </a:extLst>
+          </p:cNvPr>
+          <p:cNvSpPr/>
+          <p:nvPr/>
+        </p:nvSpPr>
+        <p:spPr>
+          <a:xfrm>
+            <a:off x="7660805" y="2133066"/>
+            <a:ext cx="2220756" cy="293597"/>
+          </a:xfrm>
+          <a:prstGeom prst="rect">
+            <a:avLst/>
+          </a:prstGeom>
+          <a:noFill/>
+          <a:ln/>
+        </p:spPr>
+        <p:txBody>
+          <a:bodyPr wrap="square" lIns="0" tIns="0" rIns="0" bIns="0" rtlCol="0" anchor="ctr"/>
+          <a:lstStyle/>
+          <a:p>
+            <a:pPr marL="0" indent="0">
+              <a:buNone/>
+            </a:pPr>
+            <a:r>
+              <a:rPr lang="en-US" b="1" kern="0" spc="150" err="1">
+                <a:latin typeface="Calibri" panose="020F0502020204030204" pitchFamily="34" charset="0"/>
+                <a:ea typeface="Calibri" panose="020F0502020204030204" pitchFamily="34" charset="0"/>
+                <a:cs typeface="Calibri" panose="020F0502020204030204" pitchFamily="34" charset="0"/>
+              </a:rPr>
+              <a:t>Cobénéfices</a:t>
+            </a:r>
+            <a:endParaRPr lang="en-US">
+              <a:latin typeface="Calibri" panose="020F0502020204030204" pitchFamily="34" charset="0"/>
+              <a:ea typeface="Calibri" panose="020F0502020204030204" pitchFamily="34" charset="0"/>
+              <a:cs typeface="Calibri" panose="020F0502020204030204" pitchFamily="34" charset="0"/>
+            </a:endParaRPr>
+          </a:p>
+        </p:txBody>
+      </p:sp>
       <p:pic>
         <p:nvPicPr>
-          <p:cNvPr id="40" name="Image 39" descr="Une image contenant texte, Police, blanc, capture d’écran&#10;&#10;Description générée automatiquement">
-            <a:extLst>
-              <a:ext uri="{FF2B5EF4-FFF2-40B4-BE49-F238E27FC236}">
-                <a16:creationId xmlns:a16="http://schemas.microsoft.com/office/drawing/2014/main" id="{A0B7D414-A672-70A2-E902-803986BD58AC}"/>
+          <p:cNvPr id="47" name="Image 46" descr="Une image contenant Police, Graphique, logo, conception&#10;&#10;Description générée automatiquement">
+            <a:extLst>
+              <a:ext uri="{FF2B5EF4-FFF2-40B4-BE49-F238E27FC236}">
+                <a16:creationId xmlns:a16="http://schemas.microsoft.com/office/drawing/2014/main" id="{F8CDAE4D-2022-8DF2-D170-E9FBC5B08999}"/>
               </a:ext>
             </a:extLst>
           </p:cNvPr>
@@ -4857,178 +5070,20 @@
         </p:blipFill>
         <p:spPr>
           <a:xfrm>
-            <a:off x="576263" y="4399297"/>
-            <a:ext cx="4296189" cy="830111"/>
+            <a:off x="7563880" y="2669231"/>
+            <a:ext cx="3390900" cy="901700"/>
           </a:xfrm>
           <a:prstGeom prst="rect">
             <a:avLst/>
           </a:prstGeom>
         </p:spPr>
       </p:pic>
-      <p:sp>
-        <p:nvSpPr>
-          <p:cNvPr id="43" name="Text 16">
-            <a:extLst>
-              <a:ext uri="{FF2B5EF4-FFF2-40B4-BE49-F238E27FC236}">
-                <a16:creationId xmlns:a16="http://schemas.microsoft.com/office/drawing/2014/main" id="{A300427D-EA15-7150-EA9C-A87450E6202D}"/>
-              </a:ext>
-            </a:extLst>
-          </p:cNvPr>
-          <p:cNvSpPr/>
-          <p:nvPr/>
-        </p:nvSpPr>
-        <p:spPr>
-          <a:xfrm>
-            <a:off x="712188" y="3920740"/>
-            <a:ext cx="2220756" cy="293597"/>
-          </a:xfrm>
-          <a:prstGeom prst="rect">
-            <a:avLst/>
-          </a:prstGeom>
-          <a:noFill/>
-          <a:ln/>
-        </p:spPr>
-        <p:txBody>
-          <a:bodyPr wrap="square" lIns="0" tIns="0" rIns="0" bIns="0" rtlCol="0" anchor="ctr"/>
-          <a:lstStyle/>
-          <a:p>
-            <a:pPr marL="0" indent="0">
-              <a:buNone/>
-            </a:pPr>
-            <a:r>
-              <a:rPr lang="en-US" b="1" kern="0" spc="150">
-                <a:latin typeface="Calibri" pitchFamily="34" charset="0"/>
-                <a:ea typeface="Calibri" pitchFamily="34" charset="-122"/>
-                <a:cs typeface="Calibri" pitchFamily="34" charset="-120"/>
-              </a:rPr>
-              <a:t>Mise </a:t>
-            </a:r>
-            <a:r>
-              <a:rPr lang="en-US" b="1" kern="0" spc="150" err="1">
-                <a:latin typeface="Calibri" pitchFamily="34" charset="0"/>
-                <a:ea typeface="Calibri" pitchFamily="34" charset="-122"/>
-                <a:cs typeface="Calibri" pitchFamily="34" charset="-120"/>
-              </a:rPr>
-              <a:t>en</a:t>
-            </a:r>
-            <a:r>
-              <a:rPr lang="en-US" b="1" kern="0" spc="150">
-                <a:latin typeface="Calibri" pitchFamily="34" charset="0"/>
-                <a:ea typeface="Calibri" pitchFamily="34" charset="-122"/>
-                <a:cs typeface="Calibri" pitchFamily="34" charset="-120"/>
-              </a:rPr>
-              <a:t> oeuvre</a:t>
-            </a:r>
-            <a:endParaRPr lang="en-US"/>
-          </a:p>
-        </p:txBody>
-      </p:sp>
-      <p:sp>
-        <p:nvSpPr>
-          <p:cNvPr id="44" name="Text 16">
-            <a:extLst>
-              <a:ext uri="{FF2B5EF4-FFF2-40B4-BE49-F238E27FC236}">
-                <a16:creationId xmlns:a16="http://schemas.microsoft.com/office/drawing/2014/main" id="{E91C9383-E765-31FC-91C1-919BA413B245}"/>
-              </a:ext>
-            </a:extLst>
-          </p:cNvPr>
-          <p:cNvSpPr/>
-          <p:nvPr/>
-        </p:nvSpPr>
-        <p:spPr>
-          <a:xfrm>
-            <a:off x="712188" y="1986268"/>
-            <a:ext cx="2220756" cy="293597"/>
-          </a:xfrm>
-          <a:prstGeom prst="rect">
-            <a:avLst/>
-          </a:prstGeom>
-          <a:noFill/>
-          <a:ln/>
-        </p:spPr>
-        <p:txBody>
-          <a:bodyPr wrap="square" lIns="0" tIns="0" rIns="0" bIns="0" rtlCol="0" anchor="ctr"/>
-          <a:lstStyle/>
-          <a:p>
-            <a:pPr marL="0" indent="0">
-              <a:buNone/>
-            </a:pPr>
-            <a:r>
-              <a:rPr lang="en-US" b="1" kern="0" spc="150" err="1">
-                <a:latin typeface="Calibri" pitchFamily="34" charset="0"/>
-                <a:ea typeface="Calibri" pitchFamily="34" charset="-122"/>
-                <a:cs typeface="Calibri" pitchFamily="34" charset="-120"/>
-              </a:rPr>
-              <a:t>Résultat</a:t>
-            </a:r>
-            <a:r>
-              <a:rPr lang="en-US" b="1" kern="0" spc="150">
-                <a:latin typeface="Calibri" pitchFamily="34" charset="0"/>
-                <a:ea typeface="Calibri" pitchFamily="34" charset="-122"/>
-                <a:cs typeface="Calibri" pitchFamily="34" charset="-120"/>
-              </a:rPr>
-              <a:t> </a:t>
-            </a:r>
-            <a:r>
-              <a:rPr lang="en-US" b="1" kern="0" spc="150" err="1">
-                <a:latin typeface="Calibri" pitchFamily="34" charset="0"/>
-                <a:ea typeface="Calibri" pitchFamily="34" charset="-122"/>
-                <a:cs typeface="Calibri" pitchFamily="34" charset="-120"/>
-              </a:rPr>
-              <a:t>attendu</a:t>
-            </a:r>
-            <a:endParaRPr lang="en-US"/>
-          </a:p>
-        </p:txBody>
-      </p:sp>
-      <p:sp>
-        <p:nvSpPr>
-          <p:cNvPr id="45" name="Text 16">
-            <a:extLst>
-              <a:ext uri="{FF2B5EF4-FFF2-40B4-BE49-F238E27FC236}">
-                <a16:creationId xmlns:a16="http://schemas.microsoft.com/office/drawing/2014/main" id="{4F281405-7CF6-3385-6A40-21850D059F03}"/>
-              </a:ext>
-            </a:extLst>
-          </p:cNvPr>
-          <p:cNvSpPr/>
-          <p:nvPr/>
-        </p:nvSpPr>
-        <p:spPr>
-          <a:xfrm>
-            <a:off x="7660805" y="2133066"/>
-            <a:ext cx="2220756" cy="293597"/>
-          </a:xfrm>
-          <a:prstGeom prst="rect">
-            <a:avLst/>
-          </a:prstGeom>
-          <a:noFill/>
-          <a:ln/>
-        </p:spPr>
-        <p:txBody>
-          <a:bodyPr wrap="square" lIns="0" tIns="0" rIns="0" bIns="0" rtlCol="0" anchor="ctr"/>
-          <a:lstStyle/>
-          <a:p>
-            <a:pPr marL="0" indent="0">
-              <a:buNone/>
-            </a:pPr>
-            <a:r>
-              <a:rPr lang="en-US" b="1" kern="0" spc="150" err="1">
-                <a:latin typeface="Calibri" pitchFamily="34" charset="0"/>
-                <a:ea typeface="Calibri" pitchFamily="34" charset="-122"/>
-                <a:cs typeface="Calibri" pitchFamily="34" charset="-120"/>
-              </a:rPr>
-              <a:t>Cobénéfices</a:t>
-            </a:r>
-            <a:endParaRPr lang="en-US"/>
-          </a:p>
-        </p:txBody>
-      </p:sp>
       <p:pic>
         <p:nvPicPr>
-          <p:cNvPr id="47" name="Image 46" descr="Une image contenant Police, Graphique, logo, conception&#10;&#10;Description générée automatiquement">
-            <a:extLst>
-              <a:ext uri="{FF2B5EF4-FFF2-40B4-BE49-F238E27FC236}">
-                <a16:creationId xmlns:a16="http://schemas.microsoft.com/office/drawing/2014/main" id="{F8CDAE4D-2022-8DF2-D170-E9FBC5B08999}"/>
+          <p:cNvPr id="49" name="Image 48" descr="Une image contenant Police, texte, conception&#10;&#10;Description générée automatiquement">
+            <a:extLst>
+              <a:ext uri="{FF2B5EF4-FFF2-40B4-BE49-F238E27FC236}">
+                <a16:creationId xmlns:a16="http://schemas.microsoft.com/office/drawing/2014/main" id="{7CA4471C-C514-5126-AA43-C7F2EA362344}"/>
               </a:ext>
             </a:extLst>
           </p:cNvPr>
@@ -5045,8 +5100,8 @@
         </p:blipFill>
         <p:spPr>
           <a:xfrm>
-            <a:off x="7563880" y="2669231"/>
-            <a:ext cx="3390900" cy="901700"/>
+            <a:off x="7576580" y="3519911"/>
+            <a:ext cx="3378200" cy="1104900"/>
           </a:xfrm>
           <a:prstGeom prst="rect">
             <a:avLst/>
@@ -5055,10 +5110,10 @@
       </p:pic>
       <p:pic>
         <p:nvPicPr>
-          <p:cNvPr id="49" name="Image 48" descr="Une image contenant Police, texte, conception&#10;&#10;Description générée automatiquement">
-            <a:extLst>
-              <a:ext uri="{FF2B5EF4-FFF2-40B4-BE49-F238E27FC236}">
-                <a16:creationId xmlns:a16="http://schemas.microsoft.com/office/drawing/2014/main" id="{7CA4471C-C514-5126-AA43-C7F2EA362344}"/>
+          <p:cNvPr id="51" name="Image 50" descr="Une image contenant Police, texte, logo, Graphique&#10;&#10;Description générée automatiquement">
+            <a:extLst>
+              <a:ext uri="{FF2B5EF4-FFF2-40B4-BE49-F238E27FC236}">
+                <a16:creationId xmlns:a16="http://schemas.microsoft.com/office/drawing/2014/main" id="{4572FDB4-7972-6868-307C-A0E198A435E2}"/>
               </a:ext>
             </a:extLst>
           </p:cNvPr>
@@ -5075,8 +5130,8 @@
         </p:blipFill>
         <p:spPr>
           <a:xfrm>
-            <a:off x="7576580" y="3519911"/>
-            <a:ext cx="3378200" cy="1104900"/>
+            <a:off x="7628066" y="4619988"/>
+            <a:ext cx="3302000" cy="787400"/>
           </a:xfrm>
           <a:prstGeom prst="rect">
             <a:avLst/>
@@ -5085,10 +5140,10 @@
       </p:pic>
       <p:pic>
         <p:nvPicPr>
-          <p:cNvPr id="51" name="Image 50" descr="Une image contenant Police, texte, logo, Graphique&#10;&#10;Description générée automatiquement">
-            <a:extLst>
-              <a:ext uri="{FF2B5EF4-FFF2-40B4-BE49-F238E27FC236}">
-                <a16:creationId xmlns:a16="http://schemas.microsoft.com/office/drawing/2014/main" id="{4572FDB4-7972-6868-307C-A0E198A435E2}"/>
+          <p:cNvPr id="53" name="Image 52" descr="Une image contenant Police, Graphique, logo, blanc&#10;&#10;Description générée automatiquement">
+            <a:extLst>
+              <a:ext uri="{FF2B5EF4-FFF2-40B4-BE49-F238E27FC236}">
+                <a16:creationId xmlns:a16="http://schemas.microsoft.com/office/drawing/2014/main" id="{553CA788-F957-E39E-15A9-D1876EB52CC1}"/>
               </a:ext>
             </a:extLst>
           </p:cNvPr>
@@ -5099,36 +5154,6 @@
         </p:nvPicPr>
         <p:blipFill>
           <a:blip r:embed="rId7"/>
-          <a:stretch>
-            <a:fillRect/>
-          </a:stretch>
-        </p:blipFill>
-        <p:spPr>
-          <a:xfrm>
-            <a:off x="7628066" y="4619988"/>
-            <a:ext cx="3302000" cy="787400"/>
-          </a:xfrm>
-          <a:prstGeom prst="rect">
-            <a:avLst/>
-          </a:prstGeom>
-        </p:spPr>
-      </p:pic>
-      <p:pic>
-        <p:nvPicPr>
-          <p:cNvPr id="53" name="Image 52" descr="Une image contenant Police, Graphique, logo, blanc&#10;&#10;Description générée automatiquement">
-            <a:extLst>
-              <a:ext uri="{FF2B5EF4-FFF2-40B4-BE49-F238E27FC236}">
-                <a16:creationId xmlns:a16="http://schemas.microsoft.com/office/drawing/2014/main" id="{553CA788-F957-E39E-15A9-D1876EB52CC1}"/>
-              </a:ext>
-            </a:extLst>
-          </p:cNvPr>
-          <p:cNvPicPr>
-            <a:picLocks noChangeAspect="1"/>
-          </p:cNvPicPr>
-          <p:nvPr/>
-        </p:nvPicPr>
-        <p:blipFill>
-          <a:blip r:embed="rId8"/>
           <a:stretch>
             <a:fillRect/>
           </a:stretch>
@@ -5223,13 +5248,17 @@
                 <a:solidFill>
                   <a:srgbClr val="A0A0A0"/>
                 </a:solidFill>
-                <a:latin typeface="Calibri" pitchFamily="34" charset="0"/>
-                <a:ea typeface="Calibri" pitchFamily="34" charset="-122"/>
-                <a:cs typeface="Calibri" pitchFamily="34" charset="-120"/>
+                <a:latin typeface="Calibri" panose="020F0502020204030204" pitchFamily="34" charset="0"/>
+                <a:ea typeface="Calibri" panose="020F0502020204030204" pitchFamily="34" charset="0"/>
+                <a:cs typeface="Calibri" panose="020F0502020204030204" pitchFamily="34" charset="0"/>
               </a:rPr>
               <a:t>Données issues de Plus fraîche ma ville (ADEME)</a:t>
             </a:r>
-            <a:endParaRPr lang="en-US" sz="1000"/>
+            <a:endParaRPr lang="en-US" sz="1000">
+              <a:latin typeface="Calibri" panose="020F0502020204030204" pitchFamily="34" charset="0"/>
+              <a:ea typeface="Calibri" panose="020F0502020204030204" pitchFamily="34" charset="0"/>
+              <a:cs typeface="Calibri" panose="020F0502020204030204" pitchFamily="34" charset="0"/>
+            </a:endParaRPr>
           </a:p>
         </p:txBody>
       </p:sp>
@@ -5239,6 +5268,35 @@
             <a:extLst>
               <a:ext uri="{FF2B5EF4-FFF2-40B4-BE49-F238E27FC236}">
                 <a16:creationId xmlns:a16="http://schemas.microsoft.com/office/drawing/2014/main" id="{830EBC68-A5C6-15CA-95C1-839F0A7C9BA7}"/>
+              </a:ext>
+            </a:extLst>
+          </p:cNvPr>
+          <p:cNvPicPr>
+            <a:picLocks noChangeAspect="1"/>
+          </p:cNvPicPr>
+          <p:nvPr/>
+        </p:nvPicPr>
+        <p:blipFill>
+          <a:blip r:embed="rId8"/>
+          <a:srcRect t="19804" b="18118"/>
+          <a:stretch/>
+        </p:blipFill>
+        <p:spPr>
+          <a:xfrm>
+            <a:off x="10763987" y="98854"/>
+            <a:ext cx="1229053" cy="762977"/>
+          </a:xfrm>
+          <a:prstGeom prst="rect">
+            <a:avLst/>
+          </a:prstGeom>
+        </p:spPr>
+      </p:pic>
+      <p:pic>
+        <p:nvPicPr>
+          <p:cNvPr id="4" name="Picture 3">
+            <a:extLst>
+              <a:ext uri="{FF2B5EF4-FFF2-40B4-BE49-F238E27FC236}">
+                <a16:creationId xmlns:a16="http://schemas.microsoft.com/office/drawing/2014/main" id="{7D131FE9-968A-7934-D330-1035AA73A364}"/>
               </a:ext>
             </a:extLst>
           </p:cNvPr>
@@ -5249,25 +5307,172 @@
         </p:nvPicPr>
         <p:blipFill>
           <a:blip r:embed="rId9"/>
-          <a:srcRect t="19804" b="18118"/>
-          <a:stretch/>
+          <a:stretch>
+            <a:fillRect/>
+          </a:stretch>
         </p:blipFill>
         <p:spPr>
           <a:xfrm>
-            <a:off x="10763987" y="98854"/>
-            <a:ext cx="1229053" cy="762977"/>
+            <a:off x="10546452" y="104580"/>
+            <a:ext cx="1552051" cy="758533"/>
           </a:xfrm>
           <a:prstGeom prst="rect">
             <a:avLst/>
           </a:prstGeom>
         </p:spPr>
       </p:pic>
+      <p:sp>
+        <p:nvSpPr>
+          <p:cNvPr id="3" name="ZoneTexte 2">
+            <a:extLst>
+              <a:ext uri="{FF2B5EF4-FFF2-40B4-BE49-F238E27FC236}">
+                <a16:creationId xmlns:a16="http://schemas.microsoft.com/office/drawing/2014/main" id="{283396D7-68F3-FCA6-1DDE-493C9D9A712C}"/>
+              </a:ext>
+            </a:extLst>
+          </p:cNvPr>
+          <p:cNvSpPr txBox="1"/>
+          <p:nvPr/>
+        </p:nvSpPr>
+        <p:spPr>
+          <a:xfrm>
+            <a:off x="609751" y="2322378"/>
+            <a:ext cx="1994034" cy="784830"/>
+          </a:xfrm>
+          <a:prstGeom prst="rect">
+            <a:avLst/>
+          </a:prstGeom>
+          <a:noFill/>
+        </p:spPr>
+        <p:txBody>
+          <a:bodyPr wrap="square">
+            <a:spAutoFit/>
+          </a:bodyPr>
+          <a:lstStyle/>
+          <a:p>
+            <a:r>
+              <a:rPr lang="fr-FR" sz="1500" b="1" dirty="0">
+                <a:solidFill>
+                  <a:schemeClr val="bg1">
+                    <a:lumMod val="50000"/>
+                  </a:schemeClr>
+                </a:solidFill>
+                <a:latin typeface="Calibri" panose="020F0502020204030204" pitchFamily="34" charset="0"/>
+                <a:ea typeface="Calibri" panose="020F0502020204030204" pitchFamily="34" charset="0"/>
+                <a:cs typeface="Calibri" panose="020F0502020204030204" pitchFamily="34" charset="0"/>
+              </a:rPr>
+              <a:t>{{</a:t>
+            </a:r>
+            <a:r>
+              <a:rPr lang="fr-FR" sz="1500" b="1" dirty="0" err="1">
+                <a:solidFill>
+                  <a:schemeClr val="bg1">
+                    <a:lumMod val="50000"/>
+                  </a:schemeClr>
+                </a:solidFill>
+                <a:latin typeface="Calibri" panose="020F0502020204030204" pitchFamily="34" charset="0"/>
+                <a:ea typeface="Calibri" panose="020F0502020204030204" pitchFamily="34" charset="0"/>
+                <a:cs typeface="Calibri" panose="020F0502020204030204" pitchFamily="34" charset="0"/>
+              </a:rPr>
+              <a:t>portee_baisse_temperature</a:t>
+            </a:r>
+            <a:r>
+              <a:rPr lang="fr-FR" sz="1500" b="1" dirty="0">
+                <a:solidFill>
+                  <a:schemeClr val="bg1">
+                    <a:lumMod val="50000"/>
+                  </a:schemeClr>
+                </a:solidFill>
+                <a:latin typeface="Calibri" panose="020F0502020204030204" pitchFamily="34" charset="0"/>
+                <a:ea typeface="Calibri" panose="020F0502020204030204" pitchFamily="34" charset="0"/>
+                <a:cs typeface="Calibri" panose="020F0502020204030204" pitchFamily="34" charset="0"/>
+              </a:rPr>
+              <a:t>}}</a:t>
+            </a:r>
+          </a:p>
+          <a:p>
+            <a:endParaRPr lang="fr-FR" sz="1500" dirty="0">
+              <a:solidFill>
+                <a:schemeClr val="bg1">
+                  <a:lumMod val="50000"/>
+                </a:schemeClr>
+              </a:solidFill>
+              <a:latin typeface="Calibri" panose="020F0502020204030204" pitchFamily="34" charset="0"/>
+              <a:ea typeface="Calibri" panose="020F0502020204030204" pitchFamily="34" charset="0"/>
+              <a:cs typeface="Calibri" panose="020F0502020204030204" pitchFamily="34" charset="0"/>
+            </a:endParaRPr>
+          </a:p>
+        </p:txBody>
+      </p:sp>
+      <p:sp>
+        <p:nvSpPr>
+          <p:cNvPr id="6" name="ZoneTexte 5">
+            <a:extLst>
+              <a:ext uri="{FF2B5EF4-FFF2-40B4-BE49-F238E27FC236}">
+                <a16:creationId xmlns:a16="http://schemas.microsoft.com/office/drawing/2014/main" id="{3FECE4F3-532A-E644-8E92-8968D648D6B8}"/>
+              </a:ext>
+            </a:extLst>
+          </p:cNvPr>
+          <p:cNvSpPr txBox="1"/>
+          <p:nvPr/>
+        </p:nvSpPr>
+        <p:spPr>
+          <a:xfrm>
+            <a:off x="2908452" y="2243993"/>
+            <a:ext cx="1861606" cy="1938992"/>
+          </a:xfrm>
+          <a:prstGeom prst="rect">
+            <a:avLst/>
+          </a:prstGeom>
+          <a:noFill/>
+        </p:spPr>
+        <p:txBody>
+          <a:bodyPr wrap="square">
+            <a:spAutoFit/>
+          </a:bodyPr>
+          <a:lstStyle/>
+          <a:p>
+            <a:r>
+              <a:rPr lang="fr-FR" sz="4000" b="1" dirty="0">
+                <a:solidFill>
+                  <a:srgbClr val="002060"/>
+                </a:solidFill>
+                <a:latin typeface="Calibri" panose="020F0502020204030204" pitchFamily="34" charset="0"/>
+                <a:ea typeface="Calibri" panose="020F0502020204030204" pitchFamily="34" charset="0"/>
+                <a:cs typeface="Calibri" panose="020F0502020204030204" pitchFamily="34" charset="0"/>
+              </a:rPr>
+              <a:t>{{</a:t>
+            </a:r>
+            <a:r>
+              <a:rPr lang="fr-FR" sz="4000" b="1" dirty="0" err="1">
+                <a:solidFill>
+                  <a:srgbClr val="002060"/>
+                </a:solidFill>
+                <a:latin typeface="Calibri" panose="020F0502020204030204" pitchFamily="34" charset="0"/>
+                <a:ea typeface="Calibri" panose="020F0502020204030204" pitchFamily="34" charset="0"/>
+                <a:cs typeface="Calibri" panose="020F0502020204030204" pitchFamily="34" charset="0"/>
+              </a:rPr>
+              <a:t>baisse_temperature</a:t>
+            </a:r>
+            <a:r>
+              <a:rPr lang="fr-FR" sz="4000" b="1" dirty="0">
+                <a:solidFill>
+                  <a:srgbClr val="002060"/>
+                </a:solidFill>
+                <a:latin typeface="Calibri" panose="020F0502020204030204" pitchFamily="34" charset="0"/>
+                <a:ea typeface="Calibri" panose="020F0502020204030204" pitchFamily="34" charset="0"/>
+                <a:cs typeface="Calibri" panose="020F0502020204030204" pitchFamily="34" charset="0"/>
+              </a:rPr>
+              <a:t>}}</a:t>
+            </a:r>
+          </a:p>
+        </p:txBody>
+      </p:sp>
       <p:pic>
         <p:nvPicPr>
-          <p:cNvPr id="4" name="Picture 3">
-            <a:extLst>
-              <a:ext uri="{FF2B5EF4-FFF2-40B4-BE49-F238E27FC236}">
-                <a16:creationId xmlns:a16="http://schemas.microsoft.com/office/drawing/2014/main" id="{7D131FE9-968A-7934-D330-1035AA73A364}"/>
+          <p:cNvPr id="8" name="picto_thermometre_baisse_temperature">
+            <a:extLst>
+              <a:ext uri="{FF2B5EF4-FFF2-40B4-BE49-F238E27FC236}">
+                <a16:creationId xmlns:a16="http://schemas.microsoft.com/office/drawing/2014/main" id="{8C67CD90-FD6F-D29F-C16C-E1B92E89FA27}"/>
               </a:ext>
             </a:extLst>
           </p:cNvPr>
@@ -5277,15 +5482,21 @@
           <p:nvPr/>
         </p:nvPicPr>
         <p:blipFill>
-          <a:blip r:embed="rId10"/>
+          <a:blip r:embed="rId10">
+            <a:extLst>
+              <a:ext uri="{96DAC541-7B7A-43D3-8B79-37D633B846F1}">
+                <asvg:svgBlip xmlns:asvg="http://schemas.microsoft.com/office/drawing/2016/SVG/main" r:embed="rId11"/>
+              </a:ext>
+            </a:extLst>
+          </a:blip>
           <a:stretch>
             <a:fillRect/>
           </a:stretch>
         </p:blipFill>
         <p:spPr>
           <a:xfrm>
-            <a:off x="10546452" y="104580"/>
-            <a:ext cx="1552051" cy="758533"/>
+            <a:off x="2990772" y="2261585"/>
+            <a:ext cx="705591" cy="705591"/>
           </a:xfrm>
           <a:prstGeom prst="rect">
             <a:avLst/>

</xml_diff>

<commit_message>
feat: page des fiches solutions : cobenefices
</commit_message>
<xml_diff>
--- a/public/templates/template_synthese_projet.pptx
+++ b/public/templates/template_synthese_projet.pptx
@@ -5016,7 +5016,7 @@
         </p:nvSpPr>
         <p:spPr>
           <a:xfrm>
-            <a:off x="7660805" y="2133066"/>
+            <a:off x="7608819" y="1980325"/>
             <a:ext cx="2220756" cy="293597"/>
           </a:xfrm>
           <a:prstGeom prst="rect">
@@ -5033,14 +5033,14 @@
               <a:buNone/>
             </a:pPr>
             <a:r>
-              <a:rPr lang="en-US" b="1" kern="0" spc="150" err="1">
+              <a:rPr lang="en-US" b="1" kern="0" spc="150" dirty="0" err="1">
                 <a:latin typeface="Calibri" panose="020F0502020204030204" pitchFamily="34" charset="0"/>
                 <a:ea typeface="Calibri" panose="020F0502020204030204" pitchFamily="34" charset="0"/>
                 <a:cs typeface="Calibri" panose="020F0502020204030204" pitchFamily="34" charset="0"/>
               </a:rPr>
               <a:t>Cobénéfices</a:t>
             </a:r>
-            <a:endParaRPr lang="en-US">
+            <a:endParaRPr lang="en-US" dirty="0">
               <a:latin typeface="Calibri" panose="020F0502020204030204" pitchFamily="34" charset="0"/>
               <a:ea typeface="Calibri" panose="020F0502020204030204" pitchFamily="34" charset="0"/>
               <a:cs typeface="Calibri" panose="020F0502020204030204" pitchFamily="34" charset="0"/>
@@ -5048,126 +5048,6 @@
           </a:p>
         </p:txBody>
       </p:sp>
-      <p:pic>
-        <p:nvPicPr>
-          <p:cNvPr id="47" name="Image 46" descr="Une image contenant Police, Graphique, logo, conception&#10;&#10;Description générée automatiquement">
-            <a:extLst>
-              <a:ext uri="{FF2B5EF4-FFF2-40B4-BE49-F238E27FC236}">
-                <a16:creationId xmlns:a16="http://schemas.microsoft.com/office/drawing/2014/main" id="{F8CDAE4D-2022-8DF2-D170-E9FBC5B08999}"/>
-              </a:ext>
-            </a:extLst>
-          </p:cNvPr>
-          <p:cNvPicPr>
-            <a:picLocks noChangeAspect="1"/>
-          </p:cNvPicPr>
-          <p:nvPr/>
-        </p:nvPicPr>
-        <p:blipFill>
-          <a:blip r:embed="rId4"/>
-          <a:stretch>
-            <a:fillRect/>
-          </a:stretch>
-        </p:blipFill>
-        <p:spPr>
-          <a:xfrm>
-            <a:off x="7563880" y="2669231"/>
-            <a:ext cx="3390900" cy="901700"/>
-          </a:xfrm>
-          <a:prstGeom prst="rect">
-            <a:avLst/>
-          </a:prstGeom>
-        </p:spPr>
-      </p:pic>
-      <p:pic>
-        <p:nvPicPr>
-          <p:cNvPr id="49" name="Image 48" descr="Une image contenant Police, texte, conception&#10;&#10;Description générée automatiquement">
-            <a:extLst>
-              <a:ext uri="{FF2B5EF4-FFF2-40B4-BE49-F238E27FC236}">
-                <a16:creationId xmlns:a16="http://schemas.microsoft.com/office/drawing/2014/main" id="{7CA4471C-C514-5126-AA43-C7F2EA362344}"/>
-              </a:ext>
-            </a:extLst>
-          </p:cNvPr>
-          <p:cNvPicPr>
-            <a:picLocks noChangeAspect="1"/>
-          </p:cNvPicPr>
-          <p:nvPr/>
-        </p:nvPicPr>
-        <p:blipFill>
-          <a:blip r:embed="rId5"/>
-          <a:stretch>
-            <a:fillRect/>
-          </a:stretch>
-        </p:blipFill>
-        <p:spPr>
-          <a:xfrm>
-            <a:off x="7576580" y="3519911"/>
-            <a:ext cx="3378200" cy="1104900"/>
-          </a:xfrm>
-          <a:prstGeom prst="rect">
-            <a:avLst/>
-          </a:prstGeom>
-        </p:spPr>
-      </p:pic>
-      <p:pic>
-        <p:nvPicPr>
-          <p:cNvPr id="51" name="Image 50" descr="Une image contenant Police, texte, logo, Graphique&#10;&#10;Description générée automatiquement">
-            <a:extLst>
-              <a:ext uri="{FF2B5EF4-FFF2-40B4-BE49-F238E27FC236}">
-                <a16:creationId xmlns:a16="http://schemas.microsoft.com/office/drawing/2014/main" id="{4572FDB4-7972-6868-307C-A0E198A435E2}"/>
-              </a:ext>
-            </a:extLst>
-          </p:cNvPr>
-          <p:cNvPicPr>
-            <a:picLocks noChangeAspect="1"/>
-          </p:cNvPicPr>
-          <p:nvPr/>
-        </p:nvPicPr>
-        <p:blipFill>
-          <a:blip r:embed="rId6"/>
-          <a:stretch>
-            <a:fillRect/>
-          </a:stretch>
-        </p:blipFill>
-        <p:spPr>
-          <a:xfrm>
-            <a:off x="7628066" y="4619988"/>
-            <a:ext cx="3302000" cy="787400"/>
-          </a:xfrm>
-          <a:prstGeom prst="rect">
-            <a:avLst/>
-          </a:prstGeom>
-        </p:spPr>
-      </p:pic>
-      <p:pic>
-        <p:nvPicPr>
-          <p:cNvPr id="53" name="Image 52" descr="Une image contenant Police, Graphique, logo, blanc&#10;&#10;Description générée automatiquement">
-            <a:extLst>
-              <a:ext uri="{FF2B5EF4-FFF2-40B4-BE49-F238E27FC236}">
-                <a16:creationId xmlns:a16="http://schemas.microsoft.com/office/drawing/2014/main" id="{553CA788-F957-E39E-15A9-D1876EB52CC1}"/>
-              </a:ext>
-            </a:extLst>
-          </p:cNvPr>
-          <p:cNvPicPr>
-            <a:picLocks noChangeAspect="1"/>
-          </p:cNvPicPr>
-          <p:nvPr/>
-        </p:nvPicPr>
-        <p:blipFill>
-          <a:blip r:embed="rId7"/>
-          <a:stretch>
-            <a:fillRect/>
-          </a:stretch>
-        </p:blipFill>
-        <p:spPr>
-          <a:xfrm>
-            <a:off x="7648448" y="5407388"/>
-            <a:ext cx="3302000" cy="838200"/>
-          </a:xfrm>
-          <a:prstGeom prst="rect">
-            <a:avLst/>
-          </a:prstGeom>
-        </p:spPr>
-      </p:pic>
       <p:cxnSp>
         <p:nvCxnSpPr>
           <p:cNvPr id="55" name="Connecteur droit 54">
@@ -5277,7 +5157,7 @@
           <p:nvPr/>
         </p:nvPicPr>
         <p:blipFill>
-          <a:blip r:embed="rId8"/>
+          <a:blip r:embed="rId4"/>
           <a:srcRect t="19804" b="18118"/>
           <a:stretch/>
         </p:blipFill>
@@ -5306,7 +5186,7 @@
           <p:nvPr/>
         </p:nvPicPr>
         <p:blipFill>
-          <a:blip r:embed="rId9"/>
+          <a:blip r:embed="rId5"/>
           <a:stretch>
             <a:fillRect/>
           </a:stretch>
@@ -5350,7 +5230,7 @@
           <a:lstStyle/>
           <a:p>
             <a:r>
-              <a:rPr lang="fr-FR" sz="1500" b="1" dirty="0">
+              <a:rPr lang="fr-FR" sz="1500" dirty="0">
                 <a:solidFill>
                   <a:schemeClr val="bg1">
                     <a:lumMod val="50000"/>
@@ -5363,7 +5243,7 @@
               <a:t>{{</a:t>
             </a:r>
             <a:r>
-              <a:rPr lang="fr-FR" sz="1500" b="1" dirty="0" err="1">
+              <a:rPr lang="fr-FR" sz="1500" dirty="0" err="1">
                 <a:solidFill>
                   <a:schemeClr val="bg1">
                     <a:lumMod val="50000"/>
@@ -5376,7 +5256,7 @@
               <a:t>portee_baisse_temperature</a:t>
             </a:r>
             <a:r>
-              <a:rPr lang="fr-FR" sz="1500" b="1" dirty="0">
+              <a:rPr lang="fr-FR" sz="1500" dirty="0">
                 <a:solidFill>
                   <a:schemeClr val="bg1">
                     <a:lumMod val="50000"/>
@@ -5482,10 +5362,10 @@
           <p:nvPr/>
         </p:nvPicPr>
         <p:blipFill>
-          <a:blip r:embed="rId10">
+          <a:blip r:embed="rId6">
             <a:extLst>
               <a:ext uri="{96DAC541-7B7A-43D3-8B79-37D633B846F1}">
-                <asvg:svgBlip xmlns:asvg="http://schemas.microsoft.com/office/drawing/2016/SVG/main" r:embed="rId11"/>
+                <asvg:svgBlip xmlns:asvg="http://schemas.microsoft.com/office/drawing/2016/SVG/main" r:embed="rId7"/>
               </a:ext>
             </a:extLst>
           </a:blip>
@@ -5503,6 +5383,406 @@
           </a:prstGeom>
         </p:spPr>
       </p:pic>
+      <p:sp>
+        <p:nvSpPr>
+          <p:cNvPr id="9" name="ZoneTexte 8">
+            <a:extLst>
+              <a:ext uri="{FF2B5EF4-FFF2-40B4-BE49-F238E27FC236}">
+                <a16:creationId xmlns:a16="http://schemas.microsoft.com/office/drawing/2014/main" id="{AB5B274F-E9FF-9A65-B0B2-04647105098D}"/>
+              </a:ext>
+            </a:extLst>
+          </p:cNvPr>
+          <p:cNvSpPr txBox="1"/>
+          <p:nvPr/>
+        </p:nvSpPr>
+        <p:spPr>
+          <a:xfrm>
+            <a:off x="8085069" y="2634521"/>
+            <a:ext cx="3963324" cy="369332"/>
+          </a:xfrm>
+          <a:prstGeom prst="rect">
+            <a:avLst/>
+          </a:prstGeom>
+          <a:noFill/>
+        </p:spPr>
+        <p:txBody>
+          <a:bodyPr wrap="square">
+            <a:spAutoFit/>
+          </a:bodyPr>
+          <a:lstStyle/>
+          <a:p>
+            <a:r>
+              <a:rPr lang="fr-FR" dirty="0">
+                <a:solidFill>
+                  <a:schemeClr val="bg1">
+                    <a:lumMod val="50000"/>
+                  </a:schemeClr>
+                </a:solidFill>
+                <a:latin typeface="Calibri" panose="020F0502020204030204" pitchFamily="34" charset="0"/>
+                <a:ea typeface="Calibri" panose="020F0502020204030204" pitchFamily="34" charset="0"/>
+                <a:cs typeface="Calibri" panose="020F0502020204030204" pitchFamily="34" charset="0"/>
+              </a:rPr>
+              <a:t>{{cobenefice_1}}</a:t>
+            </a:r>
+          </a:p>
+        </p:txBody>
+      </p:sp>
+      <p:pic>
+        <p:nvPicPr>
+          <p:cNvPr id="14" name="picto_cobenefice_1">
+            <a:extLst>
+              <a:ext uri="{FF2B5EF4-FFF2-40B4-BE49-F238E27FC236}">
+                <a16:creationId xmlns:a16="http://schemas.microsoft.com/office/drawing/2014/main" id="{2FEA33B3-62EC-E03E-7518-CBD2AC6E8870}"/>
+              </a:ext>
+            </a:extLst>
+          </p:cNvPr>
+          <p:cNvPicPr>
+            <a:picLocks noChangeAspect="1"/>
+          </p:cNvPicPr>
+          <p:nvPr/>
+        </p:nvPicPr>
+        <p:blipFill>
+          <a:blip r:embed="rId8">
+            <a:extLst>
+              <a:ext uri="{96DAC541-7B7A-43D3-8B79-37D633B846F1}">
+                <asvg:svgBlip xmlns:asvg="http://schemas.microsoft.com/office/drawing/2016/SVG/main" r:embed="rId9"/>
+              </a:ext>
+            </a:extLst>
+          </a:blip>
+          <a:stretch>
+            <a:fillRect/>
+          </a:stretch>
+        </p:blipFill>
+        <p:spPr>
+          <a:xfrm>
+            <a:off x="7608819" y="2581828"/>
+            <a:ext cx="476250" cy="476250"/>
+          </a:xfrm>
+          <a:prstGeom prst="rect">
+            <a:avLst/>
+          </a:prstGeom>
+        </p:spPr>
+      </p:pic>
+      <p:pic>
+        <p:nvPicPr>
+          <p:cNvPr id="15" name="picto_cobenefice_2">
+            <a:extLst>
+              <a:ext uri="{FF2B5EF4-FFF2-40B4-BE49-F238E27FC236}">
+                <a16:creationId xmlns:a16="http://schemas.microsoft.com/office/drawing/2014/main" id="{5292CE92-124B-25A8-3225-A8AFFD52FA2C}"/>
+              </a:ext>
+            </a:extLst>
+          </p:cNvPr>
+          <p:cNvPicPr>
+            <a:picLocks noChangeAspect="1"/>
+          </p:cNvPicPr>
+          <p:nvPr/>
+        </p:nvPicPr>
+        <p:blipFill>
+          <a:blip r:embed="rId8">
+            <a:extLst>
+              <a:ext uri="{96DAC541-7B7A-43D3-8B79-37D633B846F1}">
+                <asvg:svgBlip xmlns:asvg="http://schemas.microsoft.com/office/drawing/2016/SVG/main" r:embed="rId9"/>
+              </a:ext>
+            </a:extLst>
+          </a:blip>
+          <a:stretch>
+            <a:fillRect/>
+          </a:stretch>
+        </p:blipFill>
+        <p:spPr>
+          <a:xfrm>
+            <a:off x="7608819" y="3167539"/>
+            <a:ext cx="476250" cy="476250"/>
+          </a:xfrm>
+          <a:prstGeom prst="rect">
+            <a:avLst/>
+          </a:prstGeom>
+        </p:spPr>
+      </p:pic>
+      <p:pic>
+        <p:nvPicPr>
+          <p:cNvPr id="16" name="picto_cobenefice_3">
+            <a:extLst>
+              <a:ext uri="{FF2B5EF4-FFF2-40B4-BE49-F238E27FC236}">
+                <a16:creationId xmlns:a16="http://schemas.microsoft.com/office/drawing/2014/main" id="{EB604EA7-19BC-0A29-A1C9-A41A8F70BBEB}"/>
+              </a:ext>
+            </a:extLst>
+          </p:cNvPr>
+          <p:cNvPicPr>
+            <a:picLocks noChangeAspect="1"/>
+          </p:cNvPicPr>
+          <p:nvPr/>
+        </p:nvPicPr>
+        <p:blipFill>
+          <a:blip r:embed="rId8">
+            <a:extLst>
+              <a:ext uri="{96DAC541-7B7A-43D3-8B79-37D633B846F1}">
+                <asvg:svgBlip xmlns:asvg="http://schemas.microsoft.com/office/drawing/2016/SVG/main" r:embed="rId9"/>
+              </a:ext>
+            </a:extLst>
+          </a:blip>
+          <a:stretch>
+            <a:fillRect/>
+          </a:stretch>
+        </p:blipFill>
+        <p:spPr>
+          <a:xfrm>
+            <a:off x="7608819" y="3751413"/>
+            <a:ext cx="476250" cy="476250"/>
+          </a:xfrm>
+          <a:prstGeom prst="rect">
+            <a:avLst/>
+          </a:prstGeom>
+        </p:spPr>
+      </p:pic>
+      <p:pic>
+        <p:nvPicPr>
+          <p:cNvPr id="17" name="picto_cobenefice_4">
+            <a:extLst>
+              <a:ext uri="{FF2B5EF4-FFF2-40B4-BE49-F238E27FC236}">
+                <a16:creationId xmlns:a16="http://schemas.microsoft.com/office/drawing/2014/main" id="{B955E77A-B575-62DE-0057-A6323AB34695}"/>
+              </a:ext>
+            </a:extLst>
+          </p:cNvPr>
+          <p:cNvPicPr>
+            <a:picLocks noChangeAspect="1"/>
+          </p:cNvPicPr>
+          <p:nvPr/>
+        </p:nvPicPr>
+        <p:blipFill>
+          <a:blip r:embed="rId8">
+            <a:extLst>
+              <a:ext uri="{96DAC541-7B7A-43D3-8B79-37D633B846F1}">
+                <asvg:svgBlip xmlns:asvg="http://schemas.microsoft.com/office/drawing/2016/SVG/main" r:embed="rId9"/>
+              </a:ext>
+            </a:extLst>
+          </a:blip>
+          <a:stretch>
+            <a:fillRect/>
+          </a:stretch>
+        </p:blipFill>
+        <p:spPr>
+          <a:xfrm>
+            <a:off x="7608819" y="4335287"/>
+            <a:ext cx="476250" cy="476250"/>
+          </a:xfrm>
+          <a:prstGeom prst="rect">
+            <a:avLst/>
+          </a:prstGeom>
+        </p:spPr>
+      </p:pic>
+      <p:pic>
+        <p:nvPicPr>
+          <p:cNvPr id="18" name="picto_cobenefice_5">
+            <a:extLst>
+              <a:ext uri="{FF2B5EF4-FFF2-40B4-BE49-F238E27FC236}">
+                <a16:creationId xmlns:a16="http://schemas.microsoft.com/office/drawing/2014/main" id="{ED99FFA0-EC34-5D0F-6353-D7419BAFD0DA}"/>
+              </a:ext>
+            </a:extLst>
+          </p:cNvPr>
+          <p:cNvPicPr>
+            <a:picLocks noChangeAspect="1"/>
+          </p:cNvPicPr>
+          <p:nvPr/>
+        </p:nvPicPr>
+        <p:blipFill>
+          <a:blip r:embed="rId8">
+            <a:extLst>
+              <a:ext uri="{96DAC541-7B7A-43D3-8B79-37D633B846F1}">
+                <asvg:svgBlip xmlns:asvg="http://schemas.microsoft.com/office/drawing/2016/SVG/main" r:embed="rId9"/>
+              </a:ext>
+            </a:extLst>
+          </a:blip>
+          <a:stretch>
+            <a:fillRect/>
+          </a:stretch>
+        </p:blipFill>
+        <p:spPr>
+          <a:xfrm>
+            <a:off x="7614109" y="4919161"/>
+            <a:ext cx="476250" cy="476250"/>
+          </a:xfrm>
+          <a:prstGeom prst="rect">
+            <a:avLst/>
+          </a:prstGeom>
+        </p:spPr>
+      </p:pic>
+      <p:sp>
+        <p:nvSpPr>
+          <p:cNvPr id="19" name="ZoneTexte 18">
+            <a:extLst>
+              <a:ext uri="{FF2B5EF4-FFF2-40B4-BE49-F238E27FC236}">
+                <a16:creationId xmlns:a16="http://schemas.microsoft.com/office/drawing/2014/main" id="{6D631D5E-D07D-9DAE-EAC3-1A5DD2833A15}"/>
+              </a:ext>
+            </a:extLst>
+          </p:cNvPr>
+          <p:cNvSpPr txBox="1"/>
+          <p:nvPr/>
+        </p:nvSpPr>
+        <p:spPr>
+          <a:xfrm>
+            <a:off x="8085069" y="3225817"/>
+            <a:ext cx="3963324" cy="369332"/>
+          </a:xfrm>
+          <a:prstGeom prst="rect">
+            <a:avLst/>
+          </a:prstGeom>
+          <a:noFill/>
+        </p:spPr>
+        <p:txBody>
+          <a:bodyPr wrap="square">
+            <a:spAutoFit/>
+          </a:bodyPr>
+          <a:lstStyle/>
+          <a:p>
+            <a:r>
+              <a:rPr lang="fr-FR" dirty="0">
+                <a:solidFill>
+                  <a:schemeClr val="bg1">
+                    <a:lumMod val="50000"/>
+                  </a:schemeClr>
+                </a:solidFill>
+                <a:latin typeface="Calibri" panose="020F0502020204030204" pitchFamily="34" charset="0"/>
+                <a:ea typeface="Calibri" panose="020F0502020204030204" pitchFamily="34" charset="0"/>
+                <a:cs typeface="Calibri" panose="020F0502020204030204" pitchFamily="34" charset="0"/>
+              </a:rPr>
+              <a:t>{{cobenefice_2}}</a:t>
+            </a:r>
+          </a:p>
+        </p:txBody>
+      </p:sp>
+      <p:sp>
+        <p:nvSpPr>
+          <p:cNvPr id="20" name="ZoneTexte 19">
+            <a:extLst>
+              <a:ext uri="{FF2B5EF4-FFF2-40B4-BE49-F238E27FC236}">
+                <a16:creationId xmlns:a16="http://schemas.microsoft.com/office/drawing/2014/main" id="{11E5E33C-8CFC-334B-4593-E730FD9EA6B7}"/>
+              </a:ext>
+            </a:extLst>
+          </p:cNvPr>
+          <p:cNvSpPr txBox="1"/>
+          <p:nvPr/>
+        </p:nvSpPr>
+        <p:spPr>
+          <a:xfrm>
+            <a:off x="8082875" y="3804872"/>
+            <a:ext cx="3963324" cy="369332"/>
+          </a:xfrm>
+          <a:prstGeom prst="rect">
+            <a:avLst/>
+          </a:prstGeom>
+          <a:noFill/>
+        </p:spPr>
+        <p:txBody>
+          <a:bodyPr wrap="square">
+            <a:spAutoFit/>
+          </a:bodyPr>
+          <a:lstStyle/>
+          <a:p>
+            <a:r>
+              <a:rPr lang="fr-FR" dirty="0">
+                <a:solidFill>
+                  <a:schemeClr val="bg1">
+                    <a:lumMod val="50000"/>
+                  </a:schemeClr>
+                </a:solidFill>
+                <a:latin typeface="Calibri" panose="020F0502020204030204" pitchFamily="34" charset="0"/>
+                <a:ea typeface="Calibri" panose="020F0502020204030204" pitchFamily="34" charset="0"/>
+                <a:cs typeface="Calibri" panose="020F0502020204030204" pitchFamily="34" charset="0"/>
+              </a:rPr>
+              <a:t>{{cobenefice_3}}</a:t>
+            </a:r>
+          </a:p>
+        </p:txBody>
+      </p:sp>
+      <p:sp>
+        <p:nvSpPr>
+          <p:cNvPr id="21" name="ZoneTexte 20">
+            <a:extLst>
+              <a:ext uri="{FF2B5EF4-FFF2-40B4-BE49-F238E27FC236}">
+                <a16:creationId xmlns:a16="http://schemas.microsoft.com/office/drawing/2014/main" id="{C7B5A477-60D1-C184-143E-F283CFF41D85}"/>
+              </a:ext>
+            </a:extLst>
+          </p:cNvPr>
+          <p:cNvSpPr txBox="1"/>
+          <p:nvPr/>
+        </p:nvSpPr>
+        <p:spPr>
+          <a:xfrm>
+            <a:off x="8090359" y="4383927"/>
+            <a:ext cx="3963324" cy="369332"/>
+          </a:xfrm>
+          <a:prstGeom prst="rect">
+            <a:avLst/>
+          </a:prstGeom>
+          <a:noFill/>
+        </p:spPr>
+        <p:txBody>
+          <a:bodyPr wrap="square">
+            <a:spAutoFit/>
+          </a:bodyPr>
+          <a:lstStyle/>
+          <a:p>
+            <a:r>
+              <a:rPr lang="fr-FR" dirty="0">
+                <a:solidFill>
+                  <a:schemeClr val="bg1">
+                    <a:lumMod val="50000"/>
+                  </a:schemeClr>
+                </a:solidFill>
+                <a:latin typeface="Calibri" panose="020F0502020204030204" pitchFamily="34" charset="0"/>
+                <a:ea typeface="Calibri" panose="020F0502020204030204" pitchFamily="34" charset="0"/>
+                <a:cs typeface="Calibri" panose="020F0502020204030204" pitchFamily="34" charset="0"/>
+              </a:rPr>
+              <a:t>{{cobenefice_4}}</a:t>
+            </a:r>
+          </a:p>
+        </p:txBody>
+      </p:sp>
+      <p:sp>
+        <p:nvSpPr>
+          <p:cNvPr id="22" name="ZoneTexte 21">
+            <a:extLst>
+              <a:ext uri="{FF2B5EF4-FFF2-40B4-BE49-F238E27FC236}">
+                <a16:creationId xmlns:a16="http://schemas.microsoft.com/office/drawing/2014/main" id="{3E0B2B88-CCE4-F3AD-BB3A-53328832BC06}"/>
+              </a:ext>
+            </a:extLst>
+          </p:cNvPr>
+          <p:cNvSpPr txBox="1"/>
+          <p:nvPr/>
+        </p:nvSpPr>
+        <p:spPr>
+          <a:xfrm>
+            <a:off x="8082875" y="4977224"/>
+            <a:ext cx="3963324" cy="369332"/>
+          </a:xfrm>
+          <a:prstGeom prst="rect">
+            <a:avLst/>
+          </a:prstGeom>
+          <a:noFill/>
+        </p:spPr>
+        <p:txBody>
+          <a:bodyPr wrap="square">
+            <a:spAutoFit/>
+          </a:bodyPr>
+          <a:lstStyle/>
+          <a:p>
+            <a:r>
+              <a:rPr lang="fr-FR" dirty="0">
+                <a:solidFill>
+                  <a:schemeClr val="bg1">
+                    <a:lumMod val="50000"/>
+                  </a:schemeClr>
+                </a:solidFill>
+                <a:latin typeface="Calibri" panose="020F0502020204030204" pitchFamily="34" charset="0"/>
+                <a:ea typeface="Calibri" panose="020F0502020204030204" pitchFamily="34" charset="0"/>
+                <a:cs typeface="Calibri" panose="020F0502020204030204" pitchFamily="34" charset="0"/>
+              </a:rPr>
+              <a:t>{{cobenefice_5}}</a:t>
+            </a:r>
+          </a:p>
+        </p:txBody>
+      </p:sp>
     </p:spTree>
     <p:extLst>
       <p:ext uri="{BB962C8B-B14F-4D97-AF65-F5344CB8AC3E}">

</xml_diff>

<commit_message>
feat: fiche solution coût et délai
</commit_message>
<xml_diff>
--- a/public/templates/template_synthese_projet.pptx
+++ b/public/templates/template_synthese_projet.pptx
@@ -4818,66 +4818,6 @@
           </a:fontRef>
         </p:style>
       </p:cxnSp>
-      <p:pic>
-        <p:nvPicPr>
-          <p:cNvPr id="38" name="Image 37" descr="Une image contenant texte, Police, blanc, conception&#10;&#10;Description générée automatiquement">
-            <a:extLst>
-              <a:ext uri="{FF2B5EF4-FFF2-40B4-BE49-F238E27FC236}">
-                <a16:creationId xmlns:a16="http://schemas.microsoft.com/office/drawing/2014/main" id="{AC226DA6-1EF2-CFAB-8908-AEF5C4E4B84A}"/>
-              </a:ext>
-            </a:extLst>
-          </p:cNvPr>
-          <p:cNvPicPr>
-            <a:picLocks noChangeAspect="1"/>
-          </p:cNvPicPr>
-          <p:nvPr/>
-        </p:nvPicPr>
-        <p:blipFill>
-          <a:blip r:embed="rId2"/>
-          <a:stretch>
-            <a:fillRect/>
-          </a:stretch>
-        </p:blipFill>
-        <p:spPr>
-          <a:xfrm>
-            <a:off x="576263" y="5375317"/>
-            <a:ext cx="3975795" cy="830111"/>
-          </a:xfrm>
-          <a:prstGeom prst="rect">
-            <a:avLst/>
-          </a:prstGeom>
-        </p:spPr>
-      </p:pic>
-      <p:pic>
-        <p:nvPicPr>
-          <p:cNvPr id="40" name="Image 39" descr="Une image contenant texte, Police, blanc, capture d’écran&#10;&#10;Description générée automatiquement">
-            <a:extLst>
-              <a:ext uri="{FF2B5EF4-FFF2-40B4-BE49-F238E27FC236}">
-                <a16:creationId xmlns:a16="http://schemas.microsoft.com/office/drawing/2014/main" id="{A0B7D414-A672-70A2-E902-803986BD58AC}"/>
-              </a:ext>
-            </a:extLst>
-          </p:cNvPr>
-          <p:cNvPicPr>
-            <a:picLocks noChangeAspect="1"/>
-          </p:cNvPicPr>
-          <p:nvPr/>
-        </p:nvPicPr>
-        <p:blipFill>
-          <a:blip r:embed="rId3"/>
-          <a:stretch>
-            <a:fillRect/>
-          </a:stretch>
-        </p:blipFill>
-        <p:spPr>
-          <a:xfrm>
-            <a:off x="576263" y="4399297"/>
-            <a:ext cx="4296189" cy="830111"/>
-          </a:xfrm>
-          <a:prstGeom prst="rect">
-            <a:avLst/>
-          </a:prstGeom>
-        </p:spPr>
-      </p:pic>
       <p:sp>
         <p:nvSpPr>
           <p:cNvPr id="43" name="Text 16">
@@ -4909,7 +4849,7 @@
               <a:buNone/>
             </a:pPr>
             <a:r>
-              <a:rPr lang="en-US" b="1" kern="0" spc="150">
+              <a:rPr lang="en-US" b="1" kern="0" spc="150" dirty="0">
                 <a:latin typeface="Calibri" panose="020F0502020204030204" pitchFamily="34" charset="0"/>
                 <a:ea typeface="Calibri" panose="020F0502020204030204" pitchFamily="34" charset="0"/>
                 <a:cs typeface="Calibri" panose="020F0502020204030204" pitchFamily="34" charset="0"/>
@@ -4917,7 +4857,7 @@
               <a:t>Mise </a:t>
             </a:r>
             <a:r>
-              <a:rPr lang="en-US" b="1" kern="0" spc="150" err="1">
+              <a:rPr lang="en-US" b="1" kern="0" spc="150" dirty="0" err="1">
                 <a:latin typeface="Calibri" panose="020F0502020204030204" pitchFamily="34" charset="0"/>
                 <a:ea typeface="Calibri" panose="020F0502020204030204" pitchFamily="34" charset="0"/>
                 <a:cs typeface="Calibri" panose="020F0502020204030204" pitchFamily="34" charset="0"/>
@@ -4925,14 +4865,14 @@
               <a:t>en</a:t>
             </a:r>
             <a:r>
-              <a:rPr lang="en-US" b="1" kern="0" spc="150">
+              <a:rPr lang="en-US" b="1" kern="0" spc="150" dirty="0">
                 <a:latin typeface="Calibri" panose="020F0502020204030204" pitchFamily="34" charset="0"/>
                 <a:ea typeface="Calibri" panose="020F0502020204030204" pitchFamily="34" charset="0"/>
                 <a:cs typeface="Calibri" panose="020F0502020204030204" pitchFamily="34" charset="0"/>
               </a:rPr>
               <a:t> oeuvre</a:t>
             </a:r>
-            <a:endParaRPr lang="en-US">
+            <a:endParaRPr lang="en-US" dirty="0">
               <a:latin typeface="Calibri" panose="020F0502020204030204" pitchFamily="34" charset="0"/>
               <a:ea typeface="Calibri" panose="020F0502020204030204" pitchFamily="34" charset="0"/>
               <a:cs typeface="Calibri" panose="020F0502020204030204" pitchFamily="34" charset="0"/>
@@ -5124,7 +5064,7 @@
               <a:buNone/>
             </a:pPr>
             <a:r>
-              <a:rPr lang="en-US" sz="1000" i="1">
+              <a:rPr lang="en-US" sz="1000" i="1" dirty="0">
                 <a:solidFill>
                   <a:srgbClr val="A0A0A0"/>
                 </a:solidFill>
@@ -5132,9 +5072,53 @@
                 <a:ea typeface="Calibri" panose="020F0502020204030204" pitchFamily="34" charset="0"/>
                 <a:cs typeface="Calibri" panose="020F0502020204030204" pitchFamily="34" charset="0"/>
               </a:rPr>
-              <a:t>Données issues de Plus fraîche ma ville (ADEME)</a:t>
-            </a:r>
-            <a:endParaRPr lang="en-US" sz="1000">
+              <a:t>Données issues de Plus </a:t>
+            </a:r>
+            <a:r>
+              <a:rPr lang="en-US" sz="1000" i="1" dirty="0" err="1">
+                <a:solidFill>
+                  <a:srgbClr val="A0A0A0"/>
+                </a:solidFill>
+                <a:latin typeface="Calibri" panose="020F0502020204030204" pitchFamily="34" charset="0"/>
+                <a:ea typeface="Calibri" panose="020F0502020204030204" pitchFamily="34" charset="0"/>
+                <a:cs typeface="Calibri" panose="020F0502020204030204" pitchFamily="34" charset="0"/>
+              </a:rPr>
+              <a:t>fraîche</a:t>
+            </a:r>
+            <a:r>
+              <a:rPr lang="en-US" sz="1000" i="1" dirty="0">
+                <a:solidFill>
+                  <a:srgbClr val="A0A0A0"/>
+                </a:solidFill>
+                <a:latin typeface="Calibri" panose="020F0502020204030204" pitchFamily="34" charset="0"/>
+                <a:ea typeface="Calibri" panose="020F0502020204030204" pitchFamily="34" charset="0"/>
+                <a:cs typeface="Calibri" panose="020F0502020204030204" pitchFamily="34" charset="0"/>
+              </a:rPr>
+              <a:t> ma </a:t>
+            </a:r>
+            <a:r>
+              <a:rPr lang="en-US" sz="1000" i="1" dirty="0" err="1">
+                <a:solidFill>
+                  <a:srgbClr val="A0A0A0"/>
+                </a:solidFill>
+                <a:latin typeface="Calibri" panose="020F0502020204030204" pitchFamily="34" charset="0"/>
+                <a:ea typeface="Calibri" panose="020F0502020204030204" pitchFamily="34" charset="0"/>
+                <a:cs typeface="Calibri" panose="020F0502020204030204" pitchFamily="34" charset="0"/>
+              </a:rPr>
+              <a:t>ville</a:t>
+            </a:r>
+            <a:r>
+              <a:rPr lang="en-US" sz="1000" i="1" dirty="0">
+                <a:solidFill>
+                  <a:srgbClr val="A0A0A0"/>
+                </a:solidFill>
+                <a:latin typeface="Calibri" panose="020F0502020204030204" pitchFamily="34" charset="0"/>
+                <a:ea typeface="Calibri" panose="020F0502020204030204" pitchFamily="34" charset="0"/>
+                <a:cs typeface="Calibri" panose="020F0502020204030204" pitchFamily="34" charset="0"/>
+              </a:rPr>
+              <a:t> (ADEME)</a:t>
+            </a:r>
+            <a:endParaRPr lang="en-US" sz="1000" dirty="0">
               <a:latin typeface="Calibri" panose="020F0502020204030204" pitchFamily="34" charset="0"/>
               <a:ea typeface="Calibri" panose="020F0502020204030204" pitchFamily="34" charset="0"/>
               <a:cs typeface="Calibri" panose="020F0502020204030204" pitchFamily="34" charset="0"/>
@@ -5157,7 +5141,7 @@
           <p:nvPr/>
         </p:nvPicPr>
         <p:blipFill>
-          <a:blip r:embed="rId4"/>
+          <a:blip r:embed="rId2"/>
           <a:srcRect t="19804" b="18118"/>
           <a:stretch/>
         </p:blipFill>
@@ -5186,7 +5170,7 @@
           <p:nvPr/>
         </p:nvPicPr>
         <p:blipFill>
-          <a:blip r:embed="rId5"/>
+          <a:blip r:embed="rId3"/>
           <a:stretch>
             <a:fillRect/>
           </a:stretch>
@@ -5215,8 +5199,8 @@
         </p:nvSpPr>
         <p:spPr>
           <a:xfrm>
-            <a:off x="609751" y="2322378"/>
-            <a:ext cx="1994034" cy="784830"/>
+            <a:off x="762150" y="4370216"/>
+            <a:ext cx="763315" cy="369332"/>
           </a:xfrm>
           <a:prstGeom prst="rect">
             <a:avLst/>
@@ -5230,7 +5214,7 @@
           <a:lstStyle/>
           <a:p>
             <a:r>
-              <a:rPr lang="fr-FR" sz="1500" dirty="0">
+              <a:rPr lang="fr-FR" b="1" dirty="0">
                 <a:solidFill>
                   <a:schemeClr val="bg1">
                     <a:lumMod val="50000"/>
@@ -5240,37 +5224,9 @@
                 <a:ea typeface="Calibri" panose="020F0502020204030204" pitchFamily="34" charset="0"/>
                 <a:cs typeface="Calibri" panose="020F0502020204030204" pitchFamily="34" charset="0"/>
               </a:rPr>
-              <a:t>{{</a:t>
-            </a:r>
-            <a:r>
-              <a:rPr lang="fr-FR" sz="1500" dirty="0" err="1">
-                <a:solidFill>
-                  <a:schemeClr val="bg1">
-                    <a:lumMod val="50000"/>
-                  </a:schemeClr>
-                </a:solidFill>
-                <a:latin typeface="Calibri" panose="020F0502020204030204" pitchFamily="34" charset="0"/>
-                <a:ea typeface="Calibri" panose="020F0502020204030204" pitchFamily="34" charset="0"/>
-                <a:cs typeface="Calibri" panose="020F0502020204030204" pitchFamily="34" charset="0"/>
-              </a:rPr>
-              <a:t>portee_baisse_temperature</a:t>
-            </a:r>
-            <a:r>
-              <a:rPr lang="fr-FR" sz="1500" dirty="0">
-                <a:solidFill>
-                  <a:schemeClr val="bg1">
-                    <a:lumMod val="50000"/>
-                  </a:schemeClr>
-                </a:solidFill>
-                <a:latin typeface="Calibri" panose="020F0502020204030204" pitchFamily="34" charset="0"/>
-                <a:ea typeface="Calibri" panose="020F0502020204030204" pitchFamily="34" charset="0"/>
-                <a:cs typeface="Calibri" panose="020F0502020204030204" pitchFamily="34" charset="0"/>
-              </a:rPr>
-              <a:t>}}</a:t>
-            </a:r>
-          </a:p>
-          <a:p>
-            <a:endParaRPr lang="fr-FR" sz="1500" dirty="0">
+              <a:t>Coût :</a:t>
+            </a:r>
+            <a:endParaRPr lang="fr-FR" sz="1600" dirty="0">
               <a:solidFill>
                 <a:schemeClr val="bg1">
                   <a:lumMod val="50000"/>
@@ -5362,10 +5318,10 @@
           <p:nvPr/>
         </p:nvPicPr>
         <p:blipFill>
-          <a:blip r:embed="rId6">
+          <a:blip r:embed="rId4">
             <a:extLst>
               <a:ext uri="{96DAC541-7B7A-43D3-8B79-37D633B846F1}">
-                <asvg:svgBlip xmlns:asvg="http://schemas.microsoft.com/office/drawing/2016/SVG/main" r:embed="rId7"/>
+                <asvg:svgBlip xmlns:asvg="http://schemas.microsoft.com/office/drawing/2016/SVG/main" r:embed="rId5"/>
               </a:ext>
             </a:extLst>
           </a:blip>
@@ -5442,10 +5398,10 @@
           <p:nvPr/>
         </p:nvPicPr>
         <p:blipFill>
-          <a:blip r:embed="rId8">
+          <a:blip r:embed="rId6">
             <a:extLst>
               <a:ext uri="{96DAC541-7B7A-43D3-8B79-37D633B846F1}">
-                <asvg:svgBlip xmlns:asvg="http://schemas.microsoft.com/office/drawing/2016/SVG/main" r:embed="rId9"/>
+                <asvg:svgBlip xmlns:asvg="http://schemas.microsoft.com/office/drawing/2016/SVG/main" r:embed="rId7"/>
               </a:ext>
             </a:extLst>
           </a:blip>
@@ -5478,10 +5434,10 @@
           <p:nvPr/>
         </p:nvPicPr>
         <p:blipFill>
-          <a:blip r:embed="rId8">
+          <a:blip r:embed="rId6">
             <a:extLst>
               <a:ext uri="{96DAC541-7B7A-43D3-8B79-37D633B846F1}">
-                <asvg:svgBlip xmlns:asvg="http://schemas.microsoft.com/office/drawing/2016/SVG/main" r:embed="rId9"/>
+                <asvg:svgBlip xmlns:asvg="http://schemas.microsoft.com/office/drawing/2016/SVG/main" r:embed="rId7"/>
               </a:ext>
             </a:extLst>
           </a:blip>
@@ -5514,10 +5470,10 @@
           <p:nvPr/>
         </p:nvPicPr>
         <p:blipFill>
-          <a:blip r:embed="rId8">
+          <a:blip r:embed="rId6">
             <a:extLst>
               <a:ext uri="{96DAC541-7B7A-43D3-8B79-37D633B846F1}">
-                <asvg:svgBlip xmlns:asvg="http://schemas.microsoft.com/office/drawing/2016/SVG/main" r:embed="rId9"/>
+                <asvg:svgBlip xmlns:asvg="http://schemas.microsoft.com/office/drawing/2016/SVG/main" r:embed="rId7"/>
               </a:ext>
             </a:extLst>
           </a:blip>
@@ -5550,10 +5506,10 @@
           <p:nvPr/>
         </p:nvPicPr>
         <p:blipFill>
-          <a:blip r:embed="rId8">
+          <a:blip r:embed="rId6">
             <a:extLst>
               <a:ext uri="{96DAC541-7B7A-43D3-8B79-37D633B846F1}">
-                <asvg:svgBlip xmlns:asvg="http://schemas.microsoft.com/office/drawing/2016/SVG/main" r:embed="rId9"/>
+                <asvg:svgBlip xmlns:asvg="http://schemas.microsoft.com/office/drawing/2016/SVG/main" r:embed="rId7"/>
               </a:ext>
             </a:extLst>
           </a:blip>
@@ -5586,10 +5542,10 @@
           <p:nvPr/>
         </p:nvPicPr>
         <p:blipFill>
-          <a:blip r:embed="rId8">
+          <a:blip r:embed="rId6">
             <a:extLst>
               <a:ext uri="{96DAC541-7B7A-43D3-8B79-37D633B846F1}">
-                <asvg:svgBlip xmlns:asvg="http://schemas.microsoft.com/office/drawing/2016/SVG/main" r:embed="rId9"/>
+                <asvg:svgBlip xmlns:asvg="http://schemas.microsoft.com/office/drawing/2016/SVG/main" r:embed="rId7"/>
               </a:ext>
             </a:extLst>
           </a:blip>
@@ -5779,6 +5735,282 @@
                 <a:cs typeface="Calibri" panose="020F0502020204030204" pitchFamily="34" charset="0"/>
               </a:rPr>
               <a:t>{{cobenefice_5}}</a:t>
+            </a:r>
+          </a:p>
+        </p:txBody>
+      </p:sp>
+      <p:sp>
+        <p:nvSpPr>
+          <p:cNvPr id="23" name="ZoneTexte 22">
+            <a:extLst>
+              <a:ext uri="{FF2B5EF4-FFF2-40B4-BE49-F238E27FC236}">
+                <a16:creationId xmlns:a16="http://schemas.microsoft.com/office/drawing/2014/main" id="{B8474404-E488-86F0-E047-048FC0C9776E}"/>
+              </a:ext>
+            </a:extLst>
+          </p:cNvPr>
+          <p:cNvSpPr txBox="1"/>
+          <p:nvPr/>
+        </p:nvSpPr>
+        <p:spPr>
+          <a:xfrm>
+            <a:off x="762151" y="2395650"/>
+            <a:ext cx="1994034" cy="815608"/>
+          </a:xfrm>
+          <a:prstGeom prst="rect">
+            <a:avLst/>
+          </a:prstGeom>
+          <a:noFill/>
+        </p:spPr>
+        <p:txBody>
+          <a:bodyPr wrap="square">
+            <a:spAutoFit/>
+          </a:bodyPr>
+          <a:lstStyle/>
+          <a:p>
+            <a:r>
+              <a:rPr lang="fr-FR" sz="1600" dirty="0">
+                <a:solidFill>
+                  <a:schemeClr val="bg1">
+                    <a:lumMod val="50000"/>
+                  </a:schemeClr>
+                </a:solidFill>
+                <a:latin typeface="Calibri" panose="020F0502020204030204" pitchFamily="34" charset="0"/>
+                <a:ea typeface="Calibri" panose="020F0502020204030204" pitchFamily="34" charset="0"/>
+                <a:cs typeface="Calibri" panose="020F0502020204030204" pitchFamily="34" charset="0"/>
+              </a:rPr>
+              <a:t>{{</a:t>
+            </a:r>
+            <a:r>
+              <a:rPr lang="fr-FR" sz="1600" dirty="0" err="1">
+                <a:solidFill>
+                  <a:schemeClr val="bg1">
+                    <a:lumMod val="50000"/>
+                  </a:schemeClr>
+                </a:solidFill>
+                <a:latin typeface="Calibri" panose="020F0502020204030204" pitchFamily="34" charset="0"/>
+                <a:ea typeface="Calibri" panose="020F0502020204030204" pitchFamily="34" charset="0"/>
+                <a:cs typeface="Calibri" panose="020F0502020204030204" pitchFamily="34" charset="0"/>
+              </a:rPr>
+              <a:t>portee_baisse_temperature</a:t>
+            </a:r>
+            <a:r>
+              <a:rPr lang="fr-FR" sz="1600" dirty="0">
+                <a:solidFill>
+                  <a:schemeClr val="bg1">
+                    <a:lumMod val="50000"/>
+                  </a:schemeClr>
+                </a:solidFill>
+                <a:latin typeface="Calibri" panose="020F0502020204030204" pitchFamily="34" charset="0"/>
+                <a:ea typeface="Calibri" panose="020F0502020204030204" pitchFamily="34" charset="0"/>
+                <a:cs typeface="Calibri" panose="020F0502020204030204" pitchFamily="34" charset="0"/>
+              </a:rPr>
+              <a:t>}}</a:t>
+            </a:r>
+          </a:p>
+          <a:p>
+            <a:endParaRPr lang="fr-FR" sz="1500" dirty="0">
+              <a:solidFill>
+                <a:schemeClr val="bg1">
+                  <a:lumMod val="50000"/>
+                </a:schemeClr>
+              </a:solidFill>
+              <a:latin typeface="Calibri" panose="020F0502020204030204" pitchFamily="34" charset="0"/>
+              <a:ea typeface="Calibri" panose="020F0502020204030204" pitchFamily="34" charset="0"/>
+              <a:cs typeface="Calibri" panose="020F0502020204030204" pitchFamily="34" charset="0"/>
+            </a:endParaRPr>
+          </a:p>
+        </p:txBody>
+      </p:sp>
+      <p:sp>
+        <p:nvSpPr>
+          <p:cNvPr id="24" name="ZoneTexte 23">
+            <a:extLst>
+              <a:ext uri="{FF2B5EF4-FFF2-40B4-BE49-F238E27FC236}">
+                <a16:creationId xmlns:a16="http://schemas.microsoft.com/office/drawing/2014/main" id="{85DCA6C4-87A6-9194-C19C-D27B78EB3AD6}"/>
+              </a:ext>
+            </a:extLst>
+          </p:cNvPr>
+          <p:cNvSpPr txBox="1"/>
+          <p:nvPr/>
+        </p:nvSpPr>
+        <p:spPr>
+          <a:xfrm>
+            <a:off x="754275" y="4853531"/>
+            <a:ext cx="1944964" cy="369332"/>
+          </a:xfrm>
+          <a:prstGeom prst="rect">
+            <a:avLst/>
+          </a:prstGeom>
+          <a:noFill/>
+        </p:spPr>
+        <p:txBody>
+          <a:bodyPr wrap="square">
+            <a:spAutoFit/>
+          </a:bodyPr>
+          <a:lstStyle/>
+          <a:p>
+            <a:r>
+              <a:rPr lang="fr-FR" b="1" dirty="0">
+                <a:solidFill>
+                  <a:schemeClr val="bg1">
+                    <a:lumMod val="50000"/>
+                  </a:schemeClr>
+                </a:solidFill>
+                <a:latin typeface="Calibri" panose="020F0502020204030204" pitchFamily="34" charset="0"/>
+                <a:ea typeface="Calibri" panose="020F0502020204030204" pitchFamily="34" charset="0"/>
+                <a:cs typeface="Calibri" panose="020F0502020204030204" pitchFamily="34" charset="0"/>
+              </a:rPr>
+              <a:t>Délai des travaux :</a:t>
+            </a:r>
+            <a:endParaRPr lang="fr-FR" sz="1600" dirty="0">
+              <a:solidFill>
+                <a:schemeClr val="bg1">
+                  <a:lumMod val="50000"/>
+                </a:schemeClr>
+              </a:solidFill>
+              <a:latin typeface="Calibri" panose="020F0502020204030204" pitchFamily="34" charset="0"/>
+              <a:ea typeface="Calibri" panose="020F0502020204030204" pitchFamily="34" charset="0"/>
+              <a:cs typeface="Calibri" panose="020F0502020204030204" pitchFamily="34" charset="0"/>
+            </a:endParaRPr>
+          </a:p>
+        </p:txBody>
+      </p:sp>
+      <p:sp>
+        <p:nvSpPr>
+          <p:cNvPr id="25" name="ZoneTexte 24">
+            <a:extLst>
+              <a:ext uri="{FF2B5EF4-FFF2-40B4-BE49-F238E27FC236}">
+                <a16:creationId xmlns:a16="http://schemas.microsoft.com/office/drawing/2014/main" id="{032C04B6-E4A2-36FB-8482-DEAEE2233EC0}"/>
+              </a:ext>
+            </a:extLst>
+          </p:cNvPr>
+          <p:cNvSpPr txBox="1"/>
+          <p:nvPr/>
+        </p:nvSpPr>
+        <p:spPr>
+          <a:xfrm>
+            <a:off x="2581955" y="4877899"/>
+            <a:ext cx="2609903" cy="338554"/>
+          </a:xfrm>
+          <a:prstGeom prst="rect">
+            <a:avLst/>
+          </a:prstGeom>
+          <a:noFill/>
+        </p:spPr>
+        <p:txBody>
+          <a:bodyPr wrap="square">
+            <a:spAutoFit/>
+          </a:bodyPr>
+          <a:lstStyle/>
+          <a:p>
+            <a:r>
+              <a:rPr lang="fr-FR" sz="1600" dirty="0">
+                <a:solidFill>
+                  <a:schemeClr val="bg1">
+                    <a:lumMod val="50000"/>
+                  </a:schemeClr>
+                </a:solidFill>
+                <a:latin typeface="Calibri" panose="020F0502020204030204" pitchFamily="34" charset="0"/>
+                <a:ea typeface="Calibri" panose="020F0502020204030204" pitchFamily="34" charset="0"/>
+                <a:cs typeface="Calibri" panose="020F0502020204030204" pitchFamily="34" charset="0"/>
+              </a:rPr>
+              <a:t>{{</a:t>
+            </a:r>
+            <a:r>
+              <a:rPr lang="fr-FR" sz="1600" dirty="0" err="1">
+                <a:solidFill>
+                  <a:schemeClr val="bg1">
+                    <a:lumMod val="50000"/>
+                  </a:schemeClr>
+                </a:solidFill>
+                <a:latin typeface="Calibri" panose="020F0502020204030204" pitchFamily="34" charset="0"/>
+                <a:ea typeface="Calibri" panose="020F0502020204030204" pitchFamily="34" charset="0"/>
+                <a:cs typeface="Calibri" panose="020F0502020204030204" pitchFamily="34" charset="0"/>
+              </a:rPr>
+              <a:t>delai_fiche_solution</a:t>
+            </a:r>
+            <a:r>
+              <a:rPr lang="fr-FR" sz="1600" dirty="0">
+                <a:solidFill>
+                  <a:schemeClr val="bg1">
+                    <a:lumMod val="50000"/>
+                  </a:schemeClr>
+                </a:solidFill>
+                <a:latin typeface="Calibri" panose="020F0502020204030204" pitchFamily="34" charset="0"/>
+                <a:ea typeface="Calibri" panose="020F0502020204030204" pitchFamily="34" charset="0"/>
+                <a:cs typeface="Calibri" panose="020F0502020204030204" pitchFamily="34" charset="0"/>
+              </a:rPr>
+              <a:t>}}</a:t>
+            </a:r>
+          </a:p>
+        </p:txBody>
+      </p:sp>
+      <p:sp>
+        <p:nvSpPr>
+          <p:cNvPr id="26" name="ZoneTexte 25">
+            <a:extLst>
+              <a:ext uri="{FF2B5EF4-FFF2-40B4-BE49-F238E27FC236}">
+                <a16:creationId xmlns:a16="http://schemas.microsoft.com/office/drawing/2014/main" id="{608F7C5C-B2A7-E255-DC57-2AE0D978AD00}"/>
+              </a:ext>
+            </a:extLst>
+          </p:cNvPr>
+          <p:cNvSpPr txBox="1"/>
+          <p:nvPr/>
+        </p:nvSpPr>
+        <p:spPr>
+          <a:xfrm>
+            <a:off x="1377409" y="4386098"/>
+            <a:ext cx="3814449" cy="338554"/>
+          </a:xfrm>
+          <a:prstGeom prst="rect">
+            <a:avLst/>
+          </a:prstGeom>
+          <a:noFill/>
+        </p:spPr>
+        <p:txBody>
+          <a:bodyPr wrap="square">
+            <a:spAutoFit/>
+          </a:bodyPr>
+          <a:lstStyle/>
+          <a:p>
+            <a:r>
+              <a:rPr lang="fr-FR" sz="1600" dirty="0">
+                <a:solidFill>
+                  <a:schemeClr val="bg1">
+                    <a:lumMod val="50000"/>
+                  </a:schemeClr>
+                </a:solidFill>
+                <a:latin typeface="Calibri" panose="020F0502020204030204" pitchFamily="34" charset="0"/>
+                <a:ea typeface="Calibri" panose="020F0502020204030204" pitchFamily="34" charset="0"/>
+                <a:cs typeface="Calibri" panose="020F0502020204030204" pitchFamily="34" charset="0"/>
+              </a:rPr>
+              <a:t>{{</a:t>
+            </a:r>
+            <a:r>
+              <a:rPr lang="fr-FR" sz="1600" dirty="0" err="1">
+                <a:solidFill>
+                  <a:schemeClr val="bg1">
+                    <a:lumMod val="50000"/>
+                  </a:schemeClr>
+                </a:solidFill>
+                <a:latin typeface="Calibri" panose="020F0502020204030204" pitchFamily="34" charset="0"/>
+                <a:ea typeface="Calibri" panose="020F0502020204030204" pitchFamily="34" charset="0"/>
+                <a:cs typeface="Calibri" panose="020F0502020204030204" pitchFamily="34" charset="0"/>
+              </a:rPr>
+              <a:t>cout_fiche_solution</a:t>
+            </a:r>
+            <a:r>
+              <a:rPr lang="fr-FR" sz="1600" dirty="0">
+                <a:solidFill>
+                  <a:schemeClr val="bg1">
+                    <a:lumMod val="50000"/>
+                  </a:schemeClr>
+                </a:solidFill>
+                <a:latin typeface="Calibri" panose="020F0502020204030204" pitchFamily="34" charset="0"/>
+                <a:ea typeface="Calibri" panose="020F0502020204030204" pitchFamily="34" charset="0"/>
+                <a:cs typeface="Calibri" panose="020F0502020204030204" pitchFamily="34" charset="0"/>
+              </a:rPr>
+              <a:t>}}</a:t>
             </a:r>
           </a:p>
         </p:txBody>

</xml_diff>

<commit_message>
feat: passage de l'estimation id à l'action d'export de la synthèse
</commit_message>
<xml_diff>
--- a/public/templates/template_synthese_projet.pptx
+++ b/public/templates/template_synthese_projet.pptx
@@ -5,14 +5,15 @@
     <p:sldMasterId id="2147483648" r:id="rId1"/>
   </p:sldMasterIdLst>
   <p:notesMasterIdLst>
-    <p:notesMasterId r:id="rId7"/>
+    <p:notesMasterId r:id="rId8"/>
   </p:notesMasterIdLst>
   <p:sldIdLst>
     <p:sldId id="256" r:id="rId2"/>
     <p:sldId id="264" r:id="rId3"/>
     <p:sldId id="266" r:id="rId4"/>
-    <p:sldId id="257" r:id="rId5"/>
-    <p:sldId id="258" r:id="rId6"/>
+    <p:sldId id="270" r:id="rId5"/>
+    <p:sldId id="257" r:id="rId6"/>
+    <p:sldId id="258" r:id="rId7"/>
   </p:sldIdLst>
   <p:sldSz cx="12192000" cy="6858000"/>
   <p:notesSz cx="6858000" cy="9144000"/>
@@ -117,6 +118,15 @@
     </p:ext>
   </p:extLst>
 </p:presentation>
+</file>
+
+<file path=ppt/authors.xml><?xml version="1.0" encoding="utf-8"?>
+<p188:authorLst xmlns:a="http://schemas.openxmlformats.org/drawingml/2006/main" xmlns:r="http://schemas.openxmlformats.org/officeDocument/2006/relationships" xmlns:p188="http://schemas.microsoft.com/office/powerpoint/2018/8/main">
+  <p188:author id="{FD4A22B3-35B8-B2AA-CEF8-1EDEF9AF0C5F}" name="Raphaël TAÏEB (Ext)" initials="R(" userId="S::raphael.taieb.ext@ademe.fr::ff5ea9b3-0b07-480c-87b6-f2a7ce5e8033" providerId="AD"/>
+  <p188:author id="{CDC325DB-9363-7600-73A4-0144C121D599}" name="Bettina LEBLANC (Ext)" initials="B(" userId="S::bettina.leblanc.ext@ademe.fr::3e52b1ca-21aa-44d1-8a76-ff8fdb1085e4" providerId="AD"/>
+  <p188:author id="{6BD453F1-7568-3F9D-7EA7-1C915E9D23ED}" name="Alice BOUR (EXT)" initials="A(" userId="S::alice.bour.ext@ademe.fr::9b10eec9-7284-410c-91d6-e03941a3858e" providerId="AD"/>
+  <p188:author id="{23E434F2-2295-D2AE-2641-3CE0CF4F11B7}" name="Alexia BUCLET (Ext)" initials="A(" userId="S::alexia.buclet.ext@ademe.fr::8ded202f-f929-4eb7-98cb-33adf7b3059b" providerId="AD"/>
+</p188:authorLst>
 </file>
 
 <file path=ppt/notesMasters/notesMaster1.xml><?xml version="1.0" encoding="utf-8"?>
@@ -6033,6 +6043,1083 @@
   <p:cSld>
     <p:spTree>
       <p:nvGrpSpPr>
+        <p:cNvPr id="1" name="">
+          <a:extLst>
+            <a:ext uri="{FF2B5EF4-FFF2-40B4-BE49-F238E27FC236}">
+              <a16:creationId xmlns:a16="http://schemas.microsoft.com/office/drawing/2014/main" id="{6FBD765A-1FEE-159F-96BA-777FDEE395FF}"/>
+            </a:ext>
+          </a:extLst>
+        </p:cNvPr>
+        <p:cNvGrpSpPr/>
+        <p:nvPr/>
+      </p:nvGrpSpPr>
+      <p:grpSpPr>
+        <a:xfrm>
+          <a:off x="0" y="0"/>
+          <a:ext cx="0" cy="0"/>
+          <a:chOff x="0" y="0"/>
+          <a:chExt cx="0" cy="0"/>
+        </a:xfrm>
+      </p:grpSpPr>
+      <p:sp>
+        <p:nvSpPr>
+          <p:cNvPr id="7" name="ZoneTexte 6">
+            <a:extLst>
+              <a:ext uri="{FF2B5EF4-FFF2-40B4-BE49-F238E27FC236}">
+                <a16:creationId xmlns:a16="http://schemas.microsoft.com/office/drawing/2014/main" id="{C0EAF12D-1845-9AB2-8AD7-7633BEE55E07}"/>
+              </a:ext>
+            </a:extLst>
+          </p:cNvPr>
+          <p:cNvSpPr txBox="1"/>
+          <p:nvPr/>
+        </p:nvSpPr>
+        <p:spPr>
+          <a:xfrm>
+            <a:off x="576263" y="1137583"/>
+            <a:ext cx="10187724" cy="369332"/>
+          </a:xfrm>
+          <a:prstGeom prst="rect">
+            <a:avLst/>
+          </a:prstGeom>
+          <a:noFill/>
+        </p:spPr>
+        <p:txBody>
+          <a:bodyPr wrap="square">
+            <a:spAutoFit/>
+          </a:bodyPr>
+          <a:lstStyle/>
+          <a:p>
+            <a:r>
+              <a:rPr lang="fr-FR" b="1" i="0" dirty="0">
+                <a:solidFill>
+                  <a:srgbClr val="161616"/>
+                </a:solidFill>
+                <a:effectLst/>
+                <a:latin typeface="Aptos" panose="020B0004020202020204" pitchFamily="34" charset="0"/>
+              </a:rPr>
+              <a:t>Équipements, matériaux et systèmes retenus pour le projet {{</a:t>
+            </a:r>
+            <a:r>
+              <a:rPr lang="fr-FR" b="1" i="0" dirty="0" err="1">
+                <a:solidFill>
+                  <a:srgbClr val="161616"/>
+                </a:solidFill>
+                <a:effectLst/>
+                <a:latin typeface="Aptos" panose="020B0004020202020204" pitchFamily="34" charset="0"/>
+              </a:rPr>
+              <a:t>pagination_solution_materiaux</a:t>
+            </a:r>
+            <a:r>
+              <a:rPr lang="fr-FR" b="1" i="0" dirty="0">
+                <a:solidFill>
+                  <a:srgbClr val="161616"/>
+                </a:solidFill>
+                <a:effectLst/>
+                <a:latin typeface="Aptos" panose="020B0004020202020204" pitchFamily="34" charset="0"/>
+              </a:rPr>
+              <a:t>}}</a:t>
+            </a:r>
+            <a:endParaRPr lang="fr-FR" dirty="0">
+              <a:latin typeface="Aptos" panose="020B0004020202020204" pitchFamily="34" charset="0"/>
+            </a:endParaRPr>
+          </a:p>
+        </p:txBody>
+      </p:sp>
+      <p:sp>
+        <p:nvSpPr>
+          <p:cNvPr id="8" name="Shape 4">
+            <a:extLst>
+              <a:ext uri="{FF2B5EF4-FFF2-40B4-BE49-F238E27FC236}">
+                <a16:creationId xmlns:a16="http://schemas.microsoft.com/office/drawing/2014/main" id="{2B3E358C-F924-2E78-C7EA-F8D6F4DEC5C3}"/>
+              </a:ext>
+            </a:extLst>
+          </p:cNvPr>
+          <p:cNvSpPr/>
+          <p:nvPr/>
+        </p:nvSpPr>
+        <p:spPr>
+          <a:xfrm>
+            <a:off x="2053652" y="1942449"/>
+            <a:ext cx="8229600" cy="1234440"/>
+          </a:xfrm>
+          <a:prstGeom prst="roundRect">
+            <a:avLst>
+              <a:gd name="adj" fmla="val 5926"/>
+            </a:avLst>
+          </a:prstGeom>
+          <a:solidFill>
+            <a:srgbClr val="FFFFFF"/>
+          </a:solidFill>
+          <a:ln w="8890">
+            <a:solidFill>
+              <a:srgbClr val="DADADA"/>
+            </a:solidFill>
+            <a:prstDash val="solid"/>
+          </a:ln>
+          <a:effectLst>
+            <a:outerShdw blurRad="76200" dist="25400" dir="2700000" algn="bl" rotWithShape="0">
+              <a:srgbClr val="000000">
+                <a:alpha val="8000"/>
+              </a:srgbClr>
+            </a:outerShdw>
+          </a:effectLst>
+        </p:spPr>
+        <p:txBody>
+          <a:bodyPr/>
+          <a:lstStyle/>
+          <a:p>
+            <a:endParaRPr lang="fr-FR"/>
+          </a:p>
+        </p:txBody>
+      </p:sp>
+      <p:sp>
+        <p:nvSpPr>
+          <p:cNvPr id="9" name="ZoneTexte 8">
+            <a:extLst>
+              <a:ext uri="{FF2B5EF4-FFF2-40B4-BE49-F238E27FC236}">
+                <a16:creationId xmlns:a16="http://schemas.microsoft.com/office/drawing/2014/main" id="{A88800C3-C9AC-CC70-2E75-A1BBA164B372}"/>
+              </a:ext>
+            </a:extLst>
+          </p:cNvPr>
+          <p:cNvSpPr txBox="1"/>
+          <p:nvPr/>
+        </p:nvSpPr>
+        <p:spPr>
+          <a:xfrm>
+            <a:off x="3373308" y="2022982"/>
+            <a:ext cx="6078423" cy="307777"/>
+          </a:xfrm>
+          <a:prstGeom prst="rect">
+            <a:avLst/>
+          </a:prstGeom>
+          <a:noFill/>
+        </p:spPr>
+        <p:txBody>
+          <a:bodyPr wrap="square">
+            <a:spAutoFit/>
+          </a:bodyPr>
+          <a:lstStyle/>
+          <a:p>
+            <a:r>
+              <a:rPr lang="fr-FR" sz="1400" b="1" i="0" dirty="0">
+                <a:effectLst/>
+                <a:latin typeface="Aptos" panose="020B0004020202020204" pitchFamily="34" charset="0"/>
+              </a:rPr>
+              <a:t>Enrobés drainants (enrobés poreux)</a:t>
+            </a:r>
+            <a:endParaRPr lang="fr-FR" sz="1400" b="1" dirty="0">
+              <a:latin typeface="Aptos" panose="020B0004020202020204" pitchFamily="34" charset="0"/>
+            </a:endParaRPr>
+          </a:p>
+        </p:txBody>
+      </p:sp>
+      <p:sp>
+        <p:nvSpPr>
+          <p:cNvPr id="10" name="Text 8">
+            <a:extLst>
+              <a:ext uri="{FF2B5EF4-FFF2-40B4-BE49-F238E27FC236}">
+                <a16:creationId xmlns:a16="http://schemas.microsoft.com/office/drawing/2014/main" id="{99178690-04DD-6BBB-B2F6-1E672F23CAA3}"/>
+              </a:ext>
+            </a:extLst>
+          </p:cNvPr>
+          <p:cNvSpPr/>
+          <p:nvPr/>
+        </p:nvSpPr>
+        <p:spPr>
+          <a:xfrm>
+            <a:off x="8657469" y="2003134"/>
+            <a:ext cx="1371600" cy="347472"/>
+          </a:xfrm>
+          <a:prstGeom prst="rect">
+            <a:avLst/>
+          </a:prstGeom>
+          <a:noFill/>
+          <a:ln/>
+        </p:spPr>
+        <p:txBody>
+          <a:bodyPr wrap="square" lIns="0" tIns="0" rIns="0" bIns="0" rtlCol="0" anchor="ctr"/>
+          <a:lstStyle/>
+          <a:p>
+            <a:pPr marL="0" indent="0" algn="r">
+              <a:buNone/>
+            </a:pPr>
+            <a:r>
+              <a:rPr lang="en-US" sz="1300" b="1" dirty="0">
+                <a:solidFill>
+                  <a:srgbClr val="5C5C5C"/>
+                </a:solidFill>
+                <a:latin typeface="Calibri" pitchFamily="34" charset="0"/>
+                <a:ea typeface="Calibri" pitchFamily="34" charset="-122"/>
+                <a:cs typeface="Calibri" pitchFamily="34" charset="-120"/>
+              </a:rPr>
+              <a:t>800 m²</a:t>
+            </a:r>
+            <a:endParaRPr lang="en-US" sz="1300" dirty="0"/>
+          </a:p>
+        </p:txBody>
+      </p:sp>
+      <p:pic>
+        <p:nvPicPr>
+          <p:cNvPr id="15" name="Image 14" descr="Une image contenant sol, plein air, bâtiment, propriété&#10;&#10;Description générée automatiquement">
+            <a:extLst>
+              <a:ext uri="{FF2B5EF4-FFF2-40B4-BE49-F238E27FC236}">
+                <a16:creationId xmlns:a16="http://schemas.microsoft.com/office/drawing/2014/main" id="{6FE81792-B99E-A1A7-6F71-0CC62F608A31}"/>
+              </a:ext>
+            </a:extLst>
+          </p:cNvPr>
+          <p:cNvPicPr>
+            <a:picLocks noChangeAspect="1"/>
+          </p:cNvPicPr>
+          <p:nvPr/>
+        </p:nvPicPr>
+        <p:blipFill>
+          <a:blip r:embed="rId2"/>
+          <a:stretch>
+            <a:fillRect/>
+          </a:stretch>
+        </p:blipFill>
+        <p:spPr>
+          <a:xfrm>
+            <a:off x="2275461" y="2143455"/>
+            <a:ext cx="876038" cy="902585"/>
+          </a:xfrm>
+          <a:prstGeom prst="rect">
+            <a:avLst/>
+          </a:prstGeom>
+        </p:spPr>
+      </p:pic>
+      <p:sp>
+        <p:nvSpPr>
+          <p:cNvPr id="17" name="ZoneTexte 16">
+            <a:extLst>
+              <a:ext uri="{FF2B5EF4-FFF2-40B4-BE49-F238E27FC236}">
+                <a16:creationId xmlns:a16="http://schemas.microsoft.com/office/drawing/2014/main" id="{E402B53A-5129-3D25-265B-DC4D2781533E}"/>
+              </a:ext>
+            </a:extLst>
+          </p:cNvPr>
+          <p:cNvSpPr txBox="1"/>
+          <p:nvPr/>
+        </p:nvSpPr>
+        <p:spPr>
+          <a:xfrm>
+            <a:off x="3373308" y="2309298"/>
+            <a:ext cx="6160956" cy="523220"/>
+          </a:xfrm>
+          <a:prstGeom prst="rect">
+            <a:avLst/>
+          </a:prstGeom>
+          <a:noFill/>
+        </p:spPr>
+        <p:txBody>
+          <a:bodyPr wrap="square" lIns="91440" tIns="45720" rIns="91440" bIns="45720" anchor="t">
+            <a:spAutoFit/>
+          </a:bodyPr>
+          <a:lstStyle/>
+          <a:p>
+            <a:r>
+              <a:rPr lang="fr-FR" sz="1400" dirty="0">
+                <a:latin typeface="Aptos"/>
+              </a:rPr>
+              <a:t>Il s’agit de revêtements de chaussée qui ont l'aspect d'un bitume classique mais leur structure poreuse leur confère une perméabilité bien supérieure.</a:t>
+            </a:r>
+          </a:p>
+        </p:txBody>
+      </p:sp>
+      <p:sp>
+        <p:nvSpPr>
+          <p:cNvPr id="19" name="ZoneTexte 18">
+            <a:extLst>
+              <a:ext uri="{FF2B5EF4-FFF2-40B4-BE49-F238E27FC236}">
+                <a16:creationId xmlns:a16="http://schemas.microsoft.com/office/drawing/2014/main" id="{79E9B9CA-0F08-3137-64D1-50FFF50EA47E}"/>
+              </a:ext>
+            </a:extLst>
+          </p:cNvPr>
+          <p:cNvSpPr txBox="1"/>
+          <p:nvPr/>
+        </p:nvSpPr>
+        <p:spPr>
+          <a:xfrm>
+            <a:off x="3388298" y="2887222"/>
+            <a:ext cx="6160956" cy="276999"/>
+          </a:xfrm>
+          <a:prstGeom prst="rect">
+            <a:avLst/>
+          </a:prstGeom>
+          <a:noFill/>
+        </p:spPr>
+        <p:txBody>
+          <a:bodyPr wrap="square">
+            <a:spAutoFit/>
+          </a:bodyPr>
+          <a:lstStyle/>
+          <a:p>
+            <a:pPr marL="0" indent="0">
+              <a:buNone/>
+            </a:pPr>
+            <a:r>
+              <a:rPr lang="en-US" sz="1200" i="1" dirty="0">
+                <a:solidFill>
+                  <a:srgbClr val="2C2C2C"/>
+                </a:solidFill>
+                <a:latin typeface="Calibri" pitchFamily="34" charset="0"/>
+                <a:ea typeface="Calibri" pitchFamily="34" charset="-122"/>
+                <a:cs typeface="Calibri" pitchFamily="34" charset="-120"/>
+              </a:rPr>
+              <a:t>Inv. 35-52 €  / m2  ·   Ent. 0 – 1 € HT /m2/ an</a:t>
+            </a:r>
+            <a:endParaRPr lang="en-US" sz="1200" dirty="0"/>
+          </a:p>
+        </p:txBody>
+      </p:sp>
+      <p:sp>
+        <p:nvSpPr>
+          <p:cNvPr id="20" name="Shape 4">
+            <a:extLst>
+              <a:ext uri="{FF2B5EF4-FFF2-40B4-BE49-F238E27FC236}">
+                <a16:creationId xmlns:a16="http://schemas.microsoft.com/office/drawing/2014/main" id="{956BD7CE-AAD0-6A66-B37C-7767ADE9543D}"/>
+              </a:ext>
+            </a:extLst>
+          </p:cNvPr>
+          <p:cNvSpPr/>
+          <p:nvPr/>
+        </p:nvSpPr>
+        <p:spPr>
+          <a:xfrm>
+            <a:off x="2053652" y="3413807"/>
+            <a:ext cx="8229600" cy="1234440"/>
+          </a:xfrm>
+          <a:prstGeom prst="roundRect">
+            <a:avLst>
+              <a:gd name="adj" fmla="val 5926"/>
+            </a:avLst>
+          </a:prstGeom>
+          <a:solidFill>
+            <a:srgbClr val="FFFFFF"/>
+          </a:solidFill>
+          <a:ln w="8890">
+            <a:solidFill>
+              <a:srgbClr val="DADADA"/>
+            </a:solidFill>
+            <a:prstDash val="solid"/>
+          </a:ln>
+          <a:effectLst>
+            <a:outerShdw blurRad="76200" dist="25400" dir="2700000" algn="bl" rotWithShape="0">
+              <a:srgbClr val="000000">
+                <a:alpha val="8000"/>
+              </a:srgbClr>
+            </a:outerShdw>
+          </a:effectLst>
+        </p:spPr>
+        <p:txBody>
+          <a:bodyPr/>
+          <a:lstStyle/>
+          <a:p>
+            <a:endParaRPr lang="fr-FR"/>
+          </a:p>
+        </p:txBody>
+      </p:sp>
+      <p:sp>
+        <p:nvSpPr>
+          <p:cNvPr id="21" name="ZoneTexte 20">
+            <a:extLst>
+              <a:ext uri="{FF2B5EF4-FFF2-40B4-BE49-F238E27FC236}">
+                <a16:creationId xmlns:a16="http://schemas.microsoft.com/office/drawing/2014/main" id="{BB1AA7E2-82FD-CEED-FCC5-9DC9A9B60F56}"/>
+              </a:ext>
+            </a:extLst>
+          </p:cNvPr>
+          <p:cNvSpPr txBox="1"/>
+          <p:nvPr/>
+        </p:nvSpPr>
+        <p:spPr>
+          <a:xfrm>
+            <a:off x="3373308" y="3494340"/>
+            <a:ext cx="7515927" cy="307777"/>
+          </a:xfrm>
+          <a:prstGeom prst="rect">
+            <a:avLst/>
+          </a:prstGeom>
+          <a:noFill/>
+        </p:spPr>
+        <p:txBody>
+          <a:bodyPr wrap="square">
+            <a:spAutoFit/>
+          </a:bodyPr>
+          <a:lstStyle/>
+          <a:p>
+            <a:r>
+              <a:rPr lang="fr-FR" sz="1400" b="1" i="0">
+                <a:effectLst/>
+                <a:latin typeface="Aptos" panose="020B0004020202020204" pitchFamily="34" charset="0"/>
+              </a:rPr>
+              <a:t>Jardin de pluie</a:t>
+            </a:r>
+            <a:endParaRPr lang="fr-FR" sz="1400" b="1">
+              <a:latin typeface="Aptos" panose="020B0004020202020204" pitchFamily="34" charset="0"/>
+            </a:endParaRPr>
+          </a:p>
+        </p:txBody>
+      </p:sp>
+      <p:sp>
+        <p:nvSpPr>
+          <p:cNvPr id="22" name="Text 8">
+            <a:extLst>
+              <a:ext uri="{FF2B5EF4-FFF2-40B4-BE49-F238E27FC236}">
+                <a16:creationId xmlns:a16="http://schemas.microsoft.com/office/drawing/2014/main" id="{701D703B-668D-2A5A-1953-4978629011F8}"/>
+              </a:ext>
+            </a:extLst>
+          </p:cNvPr>
+          <p:cNvSpPr/>
+          <p:nvPr/>
+        </p:nvSpPr>
+        <p:spPr>
+          <a:xfrm>
+            <a:off x="8657469" y="3539768"/>
+            <a:ext cx="1371600" cy="347472"/>
+          </a:xfrm>
+          <a:prstGeom prst="rect">
+            <a:avLst/>
+          </a:prstGeom>
+          <a:noFill/>
+          <a:ln/>
+        </p:spPr>
+        <p:txBody>
+          <a:bodyPr wrap="square" lIns="0" tIns="0" rIns="0" bIns="0" rtlCol="0" anchor="ctr"/>
+          <a:lstStyle/>
+          <a:p>
+            <a:pPr marL="0" indent="0" algn="r">
+              <a:buNone/>
+            </a:pPr>
+            <a:r>
+              <a:rPr lang="en-US" sz="1300" b="1">
+                <a:solidFill>
+                  <a:srgbClr val="5C5C5C"/>
+                </a:solidFill>
+                <a:latin typeface="Calibri" pitchFamily="34" charset="0"/>
+                <a:ea typeface="Calibri" pitchFamily="34" charset="-122"/>
+                <a:cs typeface="Calibri" pitchFamily="34" charset="-120"/>
+              </a:rPr>
+              <a:t>30 m²</a:t>
+            </a:r>
+            <a:endParaRPr lang="en-US" sz="1300"/>
+          </a:p>
+        </p:txBody>
+      </p:sp>
+      <p:sp>
+        <p:nvSpPr>
+          <p:cNvPr id="24" name="ZoneTexte 23">
+            <a:extLst>
+              <a:ext uri="{FF2B5EF4-FFF2-40B4-BE49-F238E27FC236}">
+                <a16:creationId xmlns:a16="http://schemas.microsoft.com/office/drawing/2014/main" id="{C106A661-2575-6245-3E6F-94BC562A8A54}"/>
+              </a:ext>
+            </a:extLst>
+          </p:cNvPr>
+          <p:cNvSpPr txBox="1"/>
+          <p:nvPr/>
+        </p:nvSpPr>
+        <p:spPr>
+          <a:xfrm>
+            <a:off x="3373308" y="3780656"/>
+            <a:ext cx="6160956" cy="523220"/>
+          </a:xfrm>
+          <a:prstGeom prst="rect">
+            <a:avLst/>
+          </a:prstGeom>
+          <a:noFill/>
+        </p:spPr>
+        <p:txBody>
+          <a:bodyPr wrap="square">
+            <a:spAutoFit/>
+          </a:bodyPr>
+          <a:lstStyle/>
+          <a:p>
+            <a:r>
+              <a:rPr lang="fr-FR" sz="1400" b="0" i="0">
+                <a:solidFill>
+                  <a:srgbClr val="161616"/>
+                </a:solidFill>
+                <a:effectLst/>
+                <a:latin typeface="Marianne" panose="02000000000000000000" pitchFamily="2" charset="0"/>
+              </a:rPr>
+              <a:t>Un jardin de pluie est une zone peu profonde et végétalisée, intégrée dans la gestion des eaux pluviales pour le traitement et le stockage. </a:t>
+            </a:r>
+            <a:endParaRPr lang="fr-FR" sz="1400">
+              <a:latin typeface="Aptos" panose="020B0004020202020204" pitchFamily="34" charset="0"/>
+            </a:endParaRPr>
+          </a:p>
+        </p:txBody>
+      </p:sp>
+      <p:sp>
+        <p:nvSpPr>
+          <p:cNvPr id="25" name="ZoneTexte 24">
+            <a:extLst>
+              <a:ext uri="{FF2B5EF4-FFF2-40B4-BE49-F238E27FC236}">
+                <a16:creationId xmlns:a16="http://schemas.microsoft.com/office/drawing/2014/main" id="{E1AAF3A9-5B3C-A7E6-56C3-EC75348A43B1}"/>
+              </a:ext>
+            </a:extLst>
+          </p:cNvPr>
+          <p:cNvSpPr txBox="1"/>
+          <p:nvPr/>
+        </p:nvSpPr>
+        <p:spPr>
+          <a:xfrm>
+            <a:off x="3388298" y="4358580"/>
+            <a:ext cx="6160956" cy="276999"/>
+          </a:xfrm>
+          <a:prstGeom prst="rect">
+            <a:avLst/>
+          </a:prstGeom>
+          <a:noFill/>
+        </p:spPr>
+        <p:txBody>
+          <a:bodyPr wrap="square">
+            <a:spAutoFit/>
+          </a:bodyPr>
+          <a:lstStyle/>
+          <a:p>
+            <a:r>
+              <a:rPr lang="en-US" sz="1200" i="1">
+                <a:solidFill>
+                  <a:srgbClr val="2C2C2C"/>
+                </a:solidFill>
+                <a:latin typeface="Calibri" pitchFamily="34" charset="0"/>
+                <a:ea typeface="Calibri" pitchFamily="34" charset="-122"/>
+                <a:cs typeface="Calibri" pitchFamily="34" charset="-120"/>
+              </a:rPr>
+              <a:t>Inv. 80 - 120 € HT / m²·   Ent. 5 - 10 € HT / m² / an</a:t>
+            </a:r>
+          </a:p>
+        </p:txBody>
+      </p:sp>
+      <p:pic>
+        <p:nvPicPr>
+          <p:cNvPr id="27" name="Image 26" descr="Une image contenant personne, habits, plein air, herbe&#10;&#10;Description générée automatiquement">
+            <a:extLst>
+              <a:ext uri="{FF2B5EF4-FFF2-40B4-BE49-F238E27FC236}">
+                <a16:creationId xmlns:a16="http://schemas.microsoft.com/office/drawing/2014/main" id="{473D6B79-E3C3-6616-712C-D2B887C82B30}"/>
+              </a:ext>
+            </a:extLst>
+          </p:cNvPr>
+          <p:cNvPicPr>
+            <a:picLocks noChangeAspect="1"/>
+          </p:cNvPicPr>
+          <p:nvPr/>
+        </p:nvPicPr>
+        <p:blipFill>
+          <a:blip r:embed="rId3"/>
+          <a:stretch>
+            <a:fillRect/>
+          </a:stretch>
+        </p:blipFill>
+        <p:spPr>
+          <a:xfrm>
+            <a:off x="2287458" y="3590701"/>
+            <a:ext cx="864042" cy="881152"/>
+          </a:xfrm>
+          <a:prstGeom prst="rect">
+            <a:avLst/>
+          </a:prstGeom>
+        </p:spPr>
+      </p:pic>
+      <p:sp>
+        <p:nvSpPr>
+          <p:cNvPr id="28" name="Shape 4">
+            <a:extLst>
+              <a:ext uri="{FF2B5EF4-FFF2-40B4-BE49-F238E27FC236}">
+                <a16:creationId xmlns:a16="http://schemas.microsoft.com/office/drawing/2014/main" id="{9400B597-029D-928F-0B3C-403D200A5165}"/>
+              </a:ext>
+            </a:extLst>
+          </p:cNvPr>
+          <p:cNvSpPr/>
+          <p:nvPr/>
+        </p:nvSpPr>
+        <p:spPr>
+          <a:xfrm>
+            <a:off x="2053652" y="4885165"/>
+            <a:ext cx="8229600" cy="1234440"/>
+          </a:xfrm>
+          <a:prstGeom prst="roundRect">
+            <a:avLst>
+              <a:gd name="adj" fmla="val 5926"/>
+            </a:avLst>
+          </a:prstGeom>
+          <a:solidFill>
+            <a:srgbClr val="FFFFFF"/>
+          </a:solidFill>
+          <a:ln w="8890">
+            <a:solidFill>
+              <a:srgbClr val="DADADA"/>
+            </a:solidFill>
+            <a:prstDash val="solid"/>
+          </a:ln>
+          <a:effectLst>
+            <a:outerShdw blurRad="76200" dist="25400" dir="2700000" algn="bl" rotWithShape="0">
+              <a:srgbClr val="000000">
+                <a:alpha val="8000"/>
+              </a:srgbClr>
+            </a:outerShdw>
+          </a:effectLst>
+        </p:spPr>
+        <p:txBody>
+          <a:bodyPr/>
+          <a:lstStyle/>
+          <a:p>
+            <a:endParaRPr lang="fr-FR"/>
+          </a:p>
+        </p:txBody>
+      </p:sp>
+      <p:sp>
+        <p:nvSpPr>
+          <p:cNvPr id="29" name="ZoneTexte 28">
+            <a:extLst>
+              <a:ext uri="{FF2B5EF4-FFF2-40B4-BE49-F238E27FC236}">
+                <a16:creationId xmlns:a16="http://schemas.microsoft.com/office/drawing/2014/main" id="{8B0C4CFA-5BA2-3AF7-FE77-A64AF9904E86}"/>
+              </a:ext>
+            </a:extLst>
+          </p:cNvPr>
+          <p:cNvSpPr txBox="1"/>
+          <p:nvPr/>
+        </p:nvSpPr>
+        <p:spPr>
+          <a:xfrm>
+            <a:off x="3373308" y="4965698"/>
+            <a:ext cx="7515927" cy="307777"/>
+          </a:xfrm>
+          <a:prstGeom prst="rect">
+            <a:avLst/>
+          </a:prstGeom>
+          <a:noFill/>
+        </p:spPr>
+        <p:txBody>
+          <a:bodyPr wrap="square">
+            <a:spAutoFit/>
+          </a:bodyPr>
+          <a:lstStyle/>
+          <a:p>
+            <a:pPr marL="0" indent="0">
+              <a:buNone/>
+            </a:pPr>
+            <a:r>
+              <a:rPr lang="en-US" sz="1400" b="1">
+                <a:solidFill>
+                  <a:srgbClr val="1A1A1A"/>
+                </a:solidFill>
+                <a:latin typeface="Calibri" pitchFamily="34" charset="0"/>
+                <a:ea typeface="Calibri" pitchFamily="34" charset="-122"/>
+                <a:cs typeface="Calibri" pitchFamily="34" charset="-120"/>
+              </a:rPr>
+              <a:t>Arbres de pluie</a:t>
+            </a:r>
+            <a:endParaRPr lang="en-US" sz="1400"/>
+          </a:p>
+        </p:txBody>
+      </p:sp>
+      <p:sp>
+        <p:nvSpPr>
+          <p:cNvPr id="30" name="Text 8">
+            <a:extLst>
+              <a:ext uri="{FF2B5EF4-FFF2-40B4-BE49-F238E27FC236}">
+                <a16:creationId xmlns:a16="http://schemas.microsoft.com/office/drawing/2014/main" id="{E1026DA3-40E9-24B8-EB7F-8F7DCDFD240F}"/>
+              </a:ext>
+            </a:extLst>
+          </p:cNvPr>
+          <p:cNvSpPr/>
+          <p:nvPr/>
+        </p:nvSpPr>
+        <p:spPr>
+          <a:xfrm>
+            <a:off x="8657469" y="5011126"/>
+            <a:ext cx="1371600" cy="347472"/>
+          </a:xfrm>
+          <a:prstGeom prst="rect">
+            <a:avLst/>
+          </a:prstGeom>
+          <a:noFill/>
+          <a:ln/>
+        </p:spPr>
+        <p:txBody>
+          <a:bodyPr wrap="square" lIns="0" tIns="0" rIns="0" bIns="0" rtlCol="0" anchor="ctr"/>
+          <a:lstStyle/>
+          <a:p>
+            <a:pPr marL="0" indent="0" algn="r">
+              <a:buNone/>
+            </a:pPr>
+            <a:r>
+              <a:rPr lang="en-US" sz="1300" b="1">
+                <a:solidFill>
+                  <a:srgbClr val="5C5C5C"/>
+                </a:solidFill>
+                <a:latin typeface="Calibri" pitchFamily="34" charset="0"/>
+                <a:ea typeface="Calibri" pitchFamily="34" charset="-122"/>
+                <a:cs typeface="Calibri" pitchFamily="34" charset="-120"/>
+              </a:rPr>
+              <a:t>4 </a:t>
+            </a:r>
+            <a:r>
+              <a:rPr lang="en-US" sz="1300" b="1" err="1">
+                <a:solidFill>
+                  <a:srgbClr val="5C5C5C"/>
+                </a:solidFill>
+                <a:latin typeface="Calibri" pitchFamily="34" charset="0"/>
+                <a:ea typeface="Calibri" pitchFamily="34" charset="-122"/>
+                <a:cs typeface="Calibri" pitchFamily="34" charset="-120"/>
+              </a:rPr>
+              <a:t>unités</a:t>
+            </a:r>
+            <a:endParaRPr lang="en-US" sz="1300"/>
+          </a:p>
+        </p:txBody>
+      </p:sp>
+      <p:sp>
+        <p:nvSpPr>
+          <p:cNvPr id="31" name="ZoneTexte 30">
+            <a:extLst>
+              <a:ext uri="{FF2B5EF4-FFF2-40B4-BE49-F238E27FC236}">
+                <a16:creationId xmlns:a16="http://schemas.microsoft.com/office/drawing/2014/main" id="{073548CE-0DE5-689F-1B43-4A0C20AF7044}"/>
+              </a:ext>
+            </a:extLst>
+          </p:cNvPr>
+          <p:cNvSpPr txBox="1"/>
+          <p:nvPr/>
+        </p:nvSpPr>
+        <p:spPr>
+          <a:xfrm>
+            <a:off x="3373308" y="5252014"/>
+            <a:ext cx="6160956" cy="523220"/>
+          </a:xfrm>
+          <a:prstGeom prst="rect">
+            <a:avLst/>
+          </a:prstGeom>
+          <a:noFill/>
+        </p:spPr>
+        <p:txBody>
+          <a:bodyPr wrap="square">
+            <a:spAutoFit/>
+          </a:bodyPr>
+          <a:lstStyle/>
+          <a:p>
+            <a:r>
+              <a:rPr lang="fr-FR" sz="1400" b="0" i="0">
+                <a:solidFill>
+                  <a:srgbClr val="161616"/>
+                </a:solidFill>
+                <a:effectLst/>
+                <a:latin typeface="Marianne" panose="02000000000000000000" pitchFamily="2" charset="0"/>
+              </a:rPr>
+              <a:t>La fosse de plantation de ces arbres permet de recevoir, stocker et infiltrer les eaux de ruissellement.</a:t>
+            </a:r>
+            <a:endParaRPr lang="fr-FR" sz="1400">
+              <a:latin typeface="Aptos" panose="020B0004020202020204" pitchFamily="34" charset="0"/>
+            </a:endParaRPr>
+          </a:p>
+        </p:txBody>
+      </p:sp>
+      <p:sp>
+        <p:nvSpPr>
+          <p:cNvPr id="32" name="ZoneTexte 31">
+            <a:extLst>
+              <a:ext uri="{FF2B5EF4-FFF2-40B4-BE49-F238E27FC236}">
+                <a16:creationId xmlns:a16="http://schemas.microsoft.com/office/drawing/2014/main" id="{0102955A-3B6D-C934-F89D-2A875A948A50}"/>
+              </a:ext>
+            </a:extLst>
+          </p:cNvPr>
+          <p:cNvSpPr txBox="1"/>
+          <p:nvPr/>
+        </p:nvSpPr>
+        <p:spPr>
+          <a:xfrm>
+            <a:off x="3388298" y="5829938"/>
+            <a:ext cx="6160956" cy="276999"/>
+          </a:xfrm>
+          <a:prstGeom prst="rect">
+            <a:avLst/>
+          </a:prstGeom>
+          <a:noFill/>
+        </p:spPr>
+        <p:txBody>
+          <a:bodyPr wrap="square">
+            <a:spAutoFit/>
+          </a:bodyPr>
+          <a:lstStyle/>
+          <a:p>
+            <a:r>
+              <a:rPr lang="en-US" sz="1200" i="1">
+                <a:solidFill>
+                  <a:srgbClr val="2C2C2C"/>
+                </a:solidFill>
+                <a:latin typeface="Calibri" pitchFamily="34" charset="0"/>
+                <a:ea typeface="Calibri" pitchFamily="34" charset="-122"/>
+                <a:cs typeface="Calibri" pitchFamily="34" charset="-120"/>
+              </a:rPr>
+              <a:t>Inv. 2500 - 3500 € HT / unite ·   Ent. 40 - 50 € HT / </a:t>
+            </a:r>
+            <a:r>
+              <a:rPr lang="en-US" sz="1200" i="1" err="1">
+                <a:solidFill>
+                  <a:srgbClr val="2C2C2C"/>
+                </a:solidFill>
+                <a:latin typeface="Calibri" pitchFamily="34" charset="0"/>
+                <a:ea typeface="Calibri" pitchFamily="34" charset="-122"/>
+                <a:cs typeface="Calibri" pitchFamily="34" charset="-120"/>
+              </a:rPr>
+              <a:t>unité</a:t>
+            </a:r>
+            <a:r>
+              <a:rPr lang="en-US" sz="1200" i="1">
+                <a:solidFill>
+                  <a:srgbClr val="2C2C2C"/>
+                </a:solidFill>
+                <a:latin typeface="Calibri" pitchFamily="34" charset="0"/>
+                <a:ea typeface="Calibri" pitchFamily="34" charset="-122"/>
+                <a:cs typeface="Calibri" pitchFamily="34" charset="-120"/>
+              </a:rPr>
+              <a:t> / an</a:t>
+            </a:r>
+          </a:p>
+        </p:txBody>
+      </p:sp>
+      <p:pic>
+        <p:nvPicPr>
+          <p:cNvPr id="33" name="Image 32" descr="Une image contenant personne, habits, plein air, herbe&#10;&#10;Description générée automatiquement">
+            <a:extLst>
+              <a:ext uri="{FF2B5EF4-FFF2-40B4-BE49-F238E27FC236}">
+                <a16:creationId xmlns:a16="http://schemas.microsoft.com/office/drawing/2014/main" id="{737FBF9E-1CAD-719F-D7EC-E8FD54594E20}"/>
+              </a:ext>
+            </a:extLst>
+          </p:cNvPr>
+          <p:cNvPicPr>
+            <a:picLocks noChangeAspect="1"/>
+          </p:cNvPicPr>
+          <p:nvPr/>
+        </p:nvPicPr>
+        <p:blipFill>
+          <a:blip r:embed="rId3"/>
+          <a:stretch>
+            <a:fillRect/>
+          </a:stretch>
+        </p:blipFill>
+        <p:spPr>
+          <a:xfrm>
+            <a:off x="2287458" y="5062059"/>
+            <a:ext cx="864042" cy="881152"/>
+          </a:xfrm>
+          <a:prstGeom prst="rect">
+            <a:avLst/>
+          </a:prstGeom>
+        </p:spPr>
+      </p:pic>
+      <p:sp>
+        <p:nvSpPr>
+          <p:cNvPr id="3" name="Titre 1">
+            <a:extLst>
+              <a:ext uri="{FF2B5EF4-FFF2-40B4-BE49-F238E27FC236}">
+                <a16:creationId xmlns:a16="http://schemas.microsoft.com/office/drawing/2014/main" id="{F82418D9-B39F-2905-A2C1-E7CF651F5D36}"/>
+              </a:ext>
+            </a:extLst>
+          </p:cNvPr>
+          <p:cNvSpPr txBox="1">
+            <a:spLocks/>
+          </p:cNvSpPr>
+          <p:nvPr/>
+        </p:nvSpPr>
+        <p:spPr>
+          <a:xfrm>
+            <a:off x="576263" y="345395"/>
+            <a:ext cx="9706989" cy="615294"/>
+          </a:xfrm>
+          <a:prstGeom prst="rect">
+            <a:avLst/>
+          </a:prstGeom>
+        </p:spPr>
+        <p:txBody>
+          <a:bodyPr vert="horz" lIns="91440" tIns="45720" rIns="91440" bIns="45720" rtlCol="0" anchor="ctr">
+            <a:normAutofit/>
+          </a:bodyPr>
+          <a:lstStyle>
+            <a:lvl1pPr algn="l" defTabSz="914400" rtl="0" eaLnBrk="1" latinLnBrk="0" hangingPunct="1">
+              <a:lnSpc>
+                <a:spcPct val="90000"/>
+              </a:lnSpc>
+              <a:spcBef>
+                <a:spcPct val="0"/>
+              </a:spcBef>
+              <a:buNone/>
+              <a:defRPr sz="4400" kern="1200">
+                <a:solidFill>
+                  <a:schemeClr val="tx1"/>
+                </a:solidFill>
+                <a:latin typeface="+mj-lt"/>
+                <a:ea typeface="+mj-ea"/>
+                <a:cs typeface="+mj-cs"/>
+              </a:defRPr>
+            </a:lvl1pPr>
+          </a:lstStyle>
+          <a:p>
+            <a:r>
+              <a:rPr lang="en-US" sz="3200" dirty="0">
+                <a:latin typeface="Calibri" panose="020F0502020204030204" pitchFamily="34" charset="0"/>
+                <a:ea typeface="Calibri" panose="020F0502020204030204" pitchFamily="34" charset="0"/>
+                <a:cs typeface="Calibri" panose="020F0502020204030204" pitchFamily="34" charset="0"/>
+              </a:rPr>
+              <a:t>Solution {{</a:t>
+            </a:r>
+            <a:r>
+              <a:rPr lang="en-US" sz="3200" dirty="0" err="1">
+                <a:latin typeface="Calibri" panose="020F0502020204030204" pitchFamily="34" charset="0"/>
+                <a:ea typeface="Calibri" panose="020F0502020204030204" pitchFamily="34" charset="0"/>
+                <a:cs typeface="Calibri" panose="020F0502020204030204" pitchFamily="34" charset="0"/>
+              </a:rPr>
+              <a:t>n°_solution</a:t>
+            </a:r>
+            <a:r>
+              <a:rPr lang="en-US" sz="3200" dirty="0">
+                <a:latin typeface="Calibri" panose="020F0502020204030204" pitchFamily="34" charset="0"/>
+                <a:ea typeface="Calibri" panose="020F0502020204030204" pitchFamily="34" charset="0"/>
+                <a:cs typeface="Calibri" panose="020F0502020204030204" pitchFamily="34" charset="0"/>
+              </a:rPr>
+              <a:t>}} : {{</a:t>
+            </a:r>
+            <a:r>
+              <a:rPr lang="en-US" sz="3200" dirty="0" err="1">
+                <a:latin typeface="Calibri" panose="020F0502020204030204" pitchFamily="34" charset="0"/>
+                <a:ea typeface="Calibri" panose="020F0502020204030204" pitchFamily="34" charset="0"/>
+                <a:cs typeface="Calibri" panose="020F0502020204030204" pitchFamily="34" charset="0"/>
+              </a:rPr>
+              <a:t>titre_fiche_solution</a:t>
+            </a:r>
+            <a:r>
+              <a:rPr lang="en-US" sz="3200" dirty="0">
+                <a:latin typeface="Calibri" panose="020F0502020204030204" pitchFamily="34" charset="0"/>
+                <a:ea typeface="Calibri" panose="020F0502020204030204" pitchFamily="34" charset="0"/>
+                <a:cs typeface="Calibri" panose="020F0502020204030204" pitchFamily="34" charset="0"/>
+              </a:rPr>
+              <a:t>}}</a:t>
+            </a:r>
+            <a:endParaRPr lang="en-US" sz="3200" dirty="0"/>
+          </a:p>
+        </p:txBody>
+      </p:sp>
+      <p:cxnSp>
+        <p:nvCxnSpPr>
+          <p:cNvPr id="4" name="Connecteur droit 3">
+            <a:extLst>
+              <a:ext uri="{FF2B5EF4-FFF2-40B4-BE49-F238E27FC236}">
+                <a16:creationId xmlns:a16="http://schemas.microsoft.com/office/drawing/2014/main" id="{E6F030A1-1132-C9A1-903C-C717603846E0}"/>
+              </a:ext>
+            </a:extLst>
+          </p:cNvPr>
+          <p:cNvCxnSpPr>
+            <a:cxnSpLocks/>
+          </p:cNvCxnSpPr>
+          <p:nvPr/>
+        </p:nvCxnSpPr>
+        <p:spPr>
+          <a:xfrm>
+            <a:off x="576263" y="960689"/>
+            <a:ext cx="11615737" cy="0"/>
+          </a:xfrm>
+          <a:prstGeom prst="line">
+            <a:avLst/>
+          </a:prstGeom>
+          <a:ln>
+            <a:solidFill>
+              <a:schemeClr val="bg1">
+                <a:lumMod val="85000"/>
+              </a:schemeClr>
+            </a:solidFill>
+          </a:ln>
+        </p:spPr>
+        <p:style>
+          <a:lnRef idx="2">
+            <a:schemeClr val="accent1"/>
+          </a:lnRef>
+          <a:fillRef idx="0">
+            <a:schemeClr val="accent1"/>
+          </a:fillRef>
+          <a:effectRef idx="1">
+            <a:schemeClr val="accent1"/>
+          </a:effectRef>
+          <a:fontRef idx="minor">
+            <a:schemeClr val="tx1"/>
+          </a:fontRef>
+        </p:style>
+      </p:cxnSp>
+      <p:pic>
+        <p:nvPicPr>
+          <p:cNvPr id="14" name="Image 13" descr="Une image contenant Police, Graphique, logo, graphisme&#10;&#10;Description générée automatiquement">
+            <a:extLst>
+              <a:ext uri="{FF2B5EF4-FFF2-40B4-BE49-F238E27FC236}">
+                <a16:creationId xmlns:a16="http://schemas.microsoft.com/office/drawing/2014/main" id="{AD69CEB4-74D5-E3C0-685B-527FC6C4A3EF}"/>
+              </a:ext>
+            </a:extLst>
+          </p:cNvPr>
+          <p:cNvPicPr>
+            <a:picLocks noChangeAspect="1"/>
+          </p:cNvPicPr>
+          <p:nvPr/>
+        </p:nvPicPr>
+        <p:blipFill>
+          <a:blip r:embed="rId4"/>
+          <a:srcRect t="19804" b="18118"/>
+          <a:stretch/>
+        </p:blipFill>
+        <p:spPr>
+          <a:xfrm>
+            <a:off x="10763987" y="98854"/>
+            <a:ext cx="1229053" cy="762977"/>
+          </a:xfrm>
+          <a:prstGeom prst="rect">
+            <a:avLst/>
+          </a:prstGeom>
+        </p:spPr>
+      </p:pic>
+      <p:pic>
+        <p:nvPicPr>
+          <p:cNvPr id="5" name="Picture 4">
+            <a:extLst>
+              <a:ext uri="{FF2B5EF4-FFF2-40B4-BE49-F238E27FC236}">
+                <a16:creationId xmlns:a16="http://schemas.microsoft.com/office/drawing/2014/main" id="{DDFE2676-551D-F9A9-1060-DC00E3F770F9}"/>
+              </a:ext>
+            </a:extLst>
+          </p:cNvPr>
+          <p:cNvPicPr>
+            <a:picLocks noChangeAspect="1"/>
+          </p:cNvPicPr>
+          <p:nvPr/>
+        </p:nvPicPr>
+        <p:blipFill>
+          <a:blip r:embed="rId5"/>
+          <a:stretch>
+            <a:fillRect/>
+          </a:stretch>
+        </p:blipFill>
+        <p:spPr>
+          <a:xfrm>
+            <a:off x="10546452" y="104580"/>
+            <a:ext cx="1552051" cy="758533"/>
+          </a:xfrm>
+          <a:prstGeom prst="rect">
+            <a:avLst/>
+          </a:prstGeom>
+        </p:spPr>
+      </p:pic>
+    </p:spTree>
+    <p:extLst>
+      <p:ext uri="{BB962C8B-B14F-4D97-AF65-F5344CB8AC3E}">
+        <p14:creationId xmlns:p14="http://schemas.microsoft.com/office/powerpoint/2010/main" val="3079700268"/>
+      </p:ext>
+    </p:extLst>
+  </p:cSld>
+  <p:clrMapOvr>
+    <a:masterClrMapping/>
+  </p:clrMapOvr>
+</p:sld>
+</file>
+
+<file path=ppt/slides/slide5.xml><?xml version="1.0" encoding="utf-8"?>
+<p:sld xmlns:a="http://schemas.openxmlformats.org/drawingml/2006/main" xmlns:r="http://schemas.openxmlformats.org/officeDocument/2006/relationships" xmlns:p="http://schemas.openxmlformats.org/presentationml/2006/main">
+  <p:cSld>
+    <p:spTree>
+      <p:nvGrpSpPr>
         <p:cNvPr id="1" name=""/>
         <p:cNvGrpSpPr/>
         <p:nvPr/>
@@ -6454,7 +7541,7 @@
 </p:sld>
 </file>
 
-<file path=ppt/slides/slide5.xml><?xml version="1.0" encoding="utf-8"?>
+<file path=ppt/slides/slide6.xml><?xml version="1.0" encoding="utf-8"?>
 <p:sld xmlns:a="http://schemas.openxmlformats.org/drawingml/2006/main" xmlns:r="http://schemas.openxmlformats.org/officeDocument/2006/relationships" xmlns:p="http://schemas.openxmlformats.org/presentationml/2006/main">
   <p:cSld>
     <p:spTree>

</xml_diff>

<commit_message>
feat: export des slide d'estimation pour une fiche solution
</commit_message>
<xml_diff>
--- a/public/templates/template_synthese_projet.pptx
+++ b/public/templates/template_synthese_projet.pptx
@@ -211,7 +211,7 @@
           <a:p>
             <a:fld id="{4C638A9C-6ED0-4718-B5E7-9D405962C144}" type="datetimeFigureOut">
               <a:rPr lang="fr-FR" smtClean="0"/>
-              <a:t>29/08/2026</a:t>
+              <a:t>04/09/2026</a:t>
             </a:fld>
             <a:endParaRPr lang="fr-FR"/>
           </a:p>
@@ -733,7 +733,7 @@
           <a:p>
             <a:fld id="{82E7F8B9-DFDB-4965-877D-C04A580740C9}" type="datetimeFigureOut">
               <a:rPr lang="fr-FR" smtClean="0"/>
-              <a:t>29/08/2026</a:t>
+              <a:t>04/09/2026</a:t>
             </a:fld>
             <a:endParaRPr lang="fr-FR"/>
           </a:p>
@@ -931,7 +931,7 @@
           <a:p>
             <a:fld id="{82E7F8B9-DFDB-4965-877D-C04A580740C9}" type="datetimeFigureOut">
               <a:rPr lang="fr-FR" smtClean="0"/>
-              <a:t>29/08/2026</a:t>
+              <a:t>04/09/2026</a:t>
             </a:fld>
             <a:endParaRPr lang="fr-FR"/>
           </a:p>
@@ -1139,7 +1139,7 @@
           <a:p>
             <a:fld id="{82E7F8B9-DFDB-4965-877D-C04A580740C9}" type="datetimeFigureOut">
               <a:rPr lang="fr-FR" smtClean="0"/>
-              <a:t>29/08/2026</a:t>
+              <a:t>04/09/2026</a:t>
             </a:fld>
             <a:endParaRPr lang="fr-FR"/>
           </a:p>
@@ -1372,7 +1372,7 @@
           <a:p>
             <a:fld id="{82E7F8B9-DFDB-4965-877D-C04A580740C9}" type="datetimeFigureOut">
               <a:rPr lang="fr-FR" smtClean="0"/>
-              <a:t>29/08/2026</a:t>
+              <a:t>04/09/2026</a:t>
             </a:fld>
             <a:endParaRPr lang="fr-FR"/>
           </a:p>
@@ -1647,7 +1647,7 @@
           <a:p>
             <a:fld id="{82E7F8B9-DFDB-4965-877D-C04A580740C9}" type="datetimeFigureOut">
               <a:rPr lang="fr-FR" smtClean="0"/>
-              <a:t>29/08/2026</a:t>
+              <a:t>04/09/2026</a:t>
             </a:fld>
             <a:endParaRPr lang="fr-FR"/>
           </a:p>
@@ -1912,7 +1912,7 @@
           <a:p>
             <a:fld id="{82E7F8B9-DFDB-4965-877D-C04A580740C9}" type="datetimeFigureOut">
               <a:rPr lang="fr-FR" smtClean="0"/>
-              <a:t>29/08/2026</a:t>
+              <a:t>04/09/2026</a:t>
             </a:fld>
             <a:endParaRPr lang="fr-FR"/>
           </a:p>
@@ -2324,7 +2324,7 @@
           <a:p>
             <a:fld id="{82E7F8B9-DFDB-4965-877D-C04A580740C9}" type="datetimeFigureOut">
               <a:rPr lang="fr-FR" smtClean="0"/>
-              <a:t>29/08/2026</a:t>
+              <a:t>04/09/2026</a:t>
             </a:fld>
             <a:endParaRPr lang="fr-FR"/>
           </a:p>
@@ -2465,7 +2465,7 @@
           <a:p>
             <a:fld id="{82E7F8B9-DFDB-4965-877D-C04A580740C9}" type="datetimeFigureOut">
               <a:rPr lang="fr-FR" smtClean="0"/>
-              <a:t>29/08/2026</a:t>
+              <a:t>04/09/2026</a:t>
             </a:fld>
             <a:endParaRPr lang="fr-FR"/>
           </a:p>
@@ -2578,7 +2578,7 @@
           <a:p>
             <a:fld id="{82E7F8B9-DFDB-4965-877D-C04A580740C9}" type="datetimeFigureOut">
               <a:rPr lang="fr-FR" smtClean="0"/>
-              <a:t>29/08/2026</a:t>
+              <a:t>04/09/2026</a:t>
             </a:fld>
             <a:endParaRPr lang="fr-FR"/>
           </a:p>
@@ -2889,7 +2889,7 @@
           <a:p>
             <a:fld id="{82E7F8B9-DFDB-4965-877D-C04A580740C9}" type="datetimeFigureOut">
               <a:rPr lang="fr-FR" smtClean="0"/>
-              <a:t>29/08/2026</a:t>
+              <a:t>04/09/2026</a:t>
             </a:fld>
             <a:endParaRPr lang="fr-FR"/>
           </a:p>
@@ -3177,7 +3177,7 @@
           <a:p>
             <a:fld id="{82E7F8B9-DFDB-4965-877D-C04A580740C9}" type="datetimeFigureOut">
               <a:rPr lang="fr-FR" smtClean="0"/>
-              <a:t>29/08/2026</a:t>
+              <a:t>04/09/2026</a:t>
             </a:fld>
             <a:endParaRPr lang="fr-FR"/>
           </a:p>
@@ -3418,7 +3418,7 @@
           <a:p>
             <a:fld id="{82E7F8B9-DFDB-4965-877D-C04A580740C9}" type="datetimeFigureOut">
               <a:rPr lang="fr-FR" smtClean="0"/>
-              <a:t>29/08/2026</a:t>
+              <a:t>04/09/2026</a:t>
             </a:fld>
             <a:endParaRPr lang="fr-FR"/>
           </a:p>
@@ -5263,7 +5263,7 @@
         </p:nvSpPr>
         <p:spPr>
           <a:xfrm>
-            <a:off x="2908452" y="2243993"/>
+            <a:off x="2860182" y="2347002"/>
             <a:ext cx="1861606" cy="1938992"/>
           </a:xfrm>
           <a:prstGeom prst="rect">
@@ -5341,7 +5341,7 @@
         </p:blipFill>
         <p:spPr>
           <a:xfrm>
-            <a:off x="2990772" y="2261585"/>
+            <a:off x="3047922" y="2349530"/>
             <a:ext cx="705591" cy="705591"/>
           </a:xfrm>
           <a:prstGeom prst="rect">
@@ -6127,7 +6127,7 @@
       </p:sp>
       <p:sp>
         <p:nvSpPr>
-          <p:cNvPr id="8" name="Shape 4">
+          <p:cNvPr id="8" name="contour_materiau">
             <a:extLst>
               <a:ext uri="{FF2B5EF4-FFF2-40B4-BE49-F238E27FC236}">
                 <a16:creationId xmlns:a16="http://schemas.microsoft.com/office/drawing/2014/main" id="{2B3E358C-F924-2E78-C7EA-F8D6F4DEC5C3}"/>
@@ -6139,8 +6139,8 @@
         </p:nvSpPr>
         <p:spPr>
           <a:xfrm>
-            <a:off x="2053652" y="1942449"/>
-            <a:ext cx="8229600" cy="1234440"/>
+            <a:off x="958362" y="1914130"/>
+            <a:ext cx="9324890" cy="1234440"/>
           </a:xfrm>
           <a:prstGeom prst="roundRect">
             <a:avLst>
@@ -6186,8 +6186,8 @@
         </p:nvSpPr>
         <p:spPr>
           <a:xfrm>
-            <a:off x="3373308" y="2022982"/>
-            <a:ext cx="6078423" cy="307777"/>
+            <a:off x="2360736" y="1974626"/>
+            <a:ext cx="6059347" cy="307777"/>
           </a:xfrm>
           <a:prstGeom prst="rect">
             <a:avLst/>
@@ -6205,7 +6205,21 @@
                 <a:effectLst/>
                 <a:latin typeface="Aptos" panose="020B0004020202020204" pitchFamily="34" charset="0"/>
               </a:rPr>
-              <a:t>Enrobés drainants (enrobés poreux)</a:t>
+              <a:t>{{</a:t>
+            </a:r>
+            <a:r>
+              <a:rPr lang="fr-FR" sz="1400" b="1" i="0" dirty="0" err="1">
+                <a:effectLst/>
+                <a:latin typeface="Aptos" panose="020B0004020202020204" pitchFamily="34" charset="0"/>
+              </a:rPr>
+              <a:t>titre_materiau</a:t>
+            </a:r>
+            <a:r>
+              <a:rPr lang="fr-FR" sz="1400" b="1" i="0" dirty="0">
+                <a:effectLst/>
+                <a:latin typeface="Aptos" panose="020B0004020202020204" pitchFamily="34" charset="0"/>
+              </a:rPr>
+              <a:t>}}</a:t>
             </a:r>
             <a:endParaRPr lang="fr-FR" sz="1400" b="1" dirty="0">
               <a:latin typeface="Aptos" panose="020B0004020202020204" pitchFamily="34" charset="0"/>
@@ -6227,8 +6241,8 @@
         </p:nvSpPr>
         <p:spPr>
           <a:xfrm>
-            <a:off x="8657469" y="2003134"/>
-            <a:ext cx="1371600" cy="347472"/>
+            <a:off x="8538776" y="1974626"/>
+            <a:ext cx="1625783" cy="307777"/>
           </a:xfrm>
           <a:prstGeom prst="rect">
             <a:avLst/>
@@ -6252,7 +6266,29 @@
                 <a:ea typeface="Calibri" pitchFamily="34" charset="-122"/>
                 <a:cs typeface="Calibri" pitchFamily="34" charset="-120"/>
               </a:rPr>
-              <a:t>800 m²</a:t>
+              <a:t>{{</a:t>
+            </a:r>
+            <a:r>
+              <a:rPr lang="en-US" sz="1300" b="1" dirty="0" err="1">
+                <a:solidFill>
+                  <a:srgbClr val="5C5C5C"/>
+                </a:solidFill>
+                <a:latin typeface="Calibri" pitchFamily="34" charset="0"/>
+                <a:ea typeface="Calibri" pitchFamily="34" charset="-122"/>
+                <a:cs typeface="Calibri" pitchFamily="34" charset="-120"/>
+              </a:rPr>
+              <a:t>quantite_materiau</a:t>
+            </a:r>
+            <a:r>
+              <a:rPr lang="en-US" sz="1300" b="1" dirty="0">
+                <a:solidFill>
+                  <a:srgbClr val="5C5C5C"/>
+                </a:solidFill>
+                <a:latin typeface="Calibri" pitchFamily="34" charset="0"/>
+                <a:ea typeface="Calibri" pitchFamily="34" charset="-122"/>
+                <a:cs typeface="Calibri" pitchFamily="34" charset="-120"/>
+              </a:rPr>
+              <a:t>}}</a:t>
             </a:r>
             <a:endParaRPr lang="en-US" sz="1300" dirty="0"/>
           </a:p>
@@ -6260,7 +6296,7 @@
       </p:sp>
       <p:pic>
         <p:nvPicPr>
-          <p:cNvPr id="15" name="Image 14" descr="Une image contenant sol, plein air, bâtiment, propriété&#10;&#10;Description générée automatiquement">
+          <p:cNvPr id="15" name="image_materiau" descr="Une image contenant sol, plein air, bâtiment, propriété&#10;&#10;Description générée automatiquement">
             <a:extLst>
               <a:ext uri="{FF2B5EF4-FFF2-40B4-BE49-F238E27FC236}">
                 <a16:creationId xmlns:a16="http://schemas.microsoft.com/office/drawing/2014/main" id="{6FE81792-B99E-A1A7-6F71-0CC62F608A31}"/>
@@ -6280,7 +6316,7 @@
         </p:blipFill>
         <p:spPr>
           <a:xfrm>
-            <a:off x="2275461" y="2143455"/>
+            <a:off x="1255554" y="2108376"/>
             <a:ext cx="876038" cy="902585"/>
           </a:xfrm>
           <a:prstGeom prst="rect">
@@ -6302,8 +6338,8 @@
         </p:nvSpPr>
         <p:spPr>
           <a:xfrm>
-            <a:off x="3373308" y="2309298"/>
-            <a:ext cx="6160956" cy="523220"/>
+            <a:off x="2360736" y="2238962"/>
+            <a:ext cx="7173528" cy="292388"/>
           </a:xfrm>
           <a:prstGeom prst="rect">
             <a:avLst/>
@@ -6317,10 +6353,22 @@
           <a:lstStyle/>
           <a:p>
             <a:r>
-              <a:rPr lang="fr-FR" sz="1400" dirty="0">
+              <a:rPr lang="fr-FR" sz="1300" dirty="0">
                 <a:latin typeface="Aptos"/>
               </a:rPr>
-              <a:t>Il s’agit de revêtements de chaussée qui ont l'aspect d'un bitume classique mais leur structure poreuse leur confère une perméabilité bien supérieure.</a:t>
+              <a:t>{{</a:t>
+            </a:r>
+            <a:r>
+              <a:rPr lang="fr-FR" sz="1300" dirty="0" err="1">
+                <a:latin typeface="Aptos"/>
+              </a:rPr>
+              <a:t>description_materiau</a:t>
+            </a:r>
+            <a:r>
+              <a:rPr lang="fr-FR" sz="1300" dirty="0">
+                <a:latin typeface="Aptos"/>
+              </a:rPr>
+              <a:t>}}</a:t>
             </a:r>
           </a:p>
         </p:txBody>
@@ -6339,8 +6387,8 @@
         </p:nvSpPr>
         <p:spPr>
           <a:xfrm>
-            <a:off x="3388298" y="2887222"/>
-            <a:ext cx="6160956" cy="276999"/>
+            <a:off x="2360736" y="2874034"/>
+            <a:ext cx="7188518" cy="276999"/>
           </a:xfrm>
           <a:prstGeom prst="rect">
             <a:avLst/>
@@ -6356,6 +6404,17 @@
             <a:pPr marL="0" indent="0">
               <a:buNone/>
             </a:pPr>
+            <a:r>
+              <a:rPr lang="en-US" sz="1200" i="1" dirty="0" err="1">
+                <a:solidFill>
+                  <a:srgbClr val="2C2C2C"/>
+                </a:solidFill>
+                <a:latin typeface="Calibri" pitchFamily="34" charset="0"/>
+                <a:ea typeface="Calibri" pitchFamily="34" charset="-122"/>
+                <a:cs typeface="Calibri" pitchFamily="34" charset="-120"/>
+              </a:rPr>
+              <a:t>Investissement</a:t>
+            </a:r>
             <a:r>
               <a:rPr lang="en-US" sz="1200" i="1" dirty="0">
                 <a:solidFill>
@@ -6365,219 +6424,10 @@
                 <a:ea typeface="Calibri" pitchFamily="34" charset="-122"/>
                 <a:cs typeface="Calibri" pitchFamily="34" charset="-120"/>
               </a:rPr>
-              <a:t>Inv. 35-52 €  / m2  ·   Ent. 0 – 1 € HT /m2/ an</a:t>
-            </a:r>
-            <a:endParaRPr lang="en-US" sz="1200" dirty="0"/>
-          </a:p>
-        </p:txBody>
-      </p:sp>
-      <p:sp>
-        <p:nvSpPr>
-          <p:cNvPr id="20" name="Shape 4">
-            <a:extLst>
-              <a:ext uri="{FF2B5EF4-FFF2-40B4-BE49-F238E27FC236}">
-                <a16:creationId xmlns:a16="http://schemas.microsoft.com/office/drawing/2014/main" id="{956BD7CE-AAD0-6A66-B37C-7767ADE9543D}"/>
-              </a:ext>
-            </a:extLst>
-          </p:cNvPr>
-          <p:cNvSpPr/>
-          <p:nvPr/>
-        </p:nvSpPr>
-        <p:spPr>
-          <a:xfrm>
-            <a:off x="2053652" y="3413807"/>
-            <a:ext cx="8229600" cy="1234440"/>
-          </a:xfrm>
-          <a:prstGeom prst="roundRect">
-            <a:avLst>
-              <a:gd name="adj" fmla="val 5926"/>
-            </a:avLst>
-          </a:prstGeom>
-          <a:solidFill>
-            <a:srgbClr val="FFFFFF"/>
-          </a:solidFill>
-          <a:ln w="8890">
-            <a:solidFill>
-              <a:srgbClr val="DADADA"/>
-            </a:solidFill>
-            <a:prstDash val="solid"/>
-          </a:ln>
-          <a:effectLst>
-            <a:outerShdw blurRad="76200" dist="25400" dir="2700000" algn="bl" rotWithShape="0">
-              <a:srgbClr val="000000">
-                <a:alpha val="8000"/>
-              </a:srgbClr>
-            </a:outerShdw>
-          </a:effectLst>
-        </p:spPr>
-        <p:txBody>
-          <a:bodyPr/>
-          <a:lstStyle/>
-          <a:p>
-            <a:endParaRPr lang="fr-FR"/>
-          </a:p>
-        </p:txBody>
-      </p:sp>
-      <p:sp>
-        <p:nvSpPr>
-          <p:cNvPr id="21" name="ZoneTexte 20">
-            <a:extLst>
-              <a:ext uri="{FF2B5EF4-FFF2-40B4-BE49-F238E27FC236}">
-                <a16:creationId xmlns:a16="http://schemas.microsoft.com/office/drawing/2014/main" id="{BB1AA7E2-82FD-CEED-FCC5-9DC9A9B60F56}"/>
-              </a:ext>
-            </a:extLst>
-          </p:cNvPr>
-          <p:cNvSpPr txBox="1"/>
-          <p:nvPr/>
-        </p:nvSpPr>
-        <p:spPr>
-          <a:xfrm>
-            <a:off x="3373308" y="3494340"/>
-            <a:ext cx="7515927" cy="307777"/>
-          </a:xfrm>
-          <a:prstGeom prst="rect">
-            <a:avLst/>
-          </a:prstGeom>
-          <a:noFill/>
-        </p:spPr>
-        <p:txBody>
-          <a:bodyPr wrap="square">
-            <a:spAutoFit/>
-          </a:bodyPr>
-          <a:lstStyle/>
-          <a:p>
-            <a:r>
-              <a:rPr lang="fr-FR" sz="1400" b="1" i="0">
-                <a:effectLst/>
-                <a:latin typeface="Aptos" panose="020B0004020202020204" pitchFamily="34" charset="0"/>
-              </a:rPr>
-              <a:t>Jardin de pluie</a:t>
-            </a:r>
-            <a:endParaRPr lang="fr-FR" sz="1400" b="1">
-              <a:latin typeface="Aptos" panose="020B0004020202020204" pitchFamily="34" charset="0"/>
-            </a:endParaRPr>
-          </a:p>
-        </p:txBody>
-      </p:sp>
-      <p:sp>
-        <p:nvSpPr>
-          <p:cNvPr id="22" name="Text 8">
-            <a:extLst>
-              <a:ext uri="{FF2B5EF4-FFF2-40B4-BE49-F238E27FC236}">
-                <a16:creationId xmlns:a16="http://schemas.microsoft.com/office/drawing/2014/main" id="{701D703B-668D-2A5A-1953-4978629011F8}"/>
-              </a:ext>
-            </a:extLst>
-          </p:cNvPr>
-          <p:cNvSpPr/>
-          <p:nvPr/>
-        </p:nvSpPr>
-        <p:spPr>
-          <a:xfrm>
-            <a:off x="8657469" y="3539768"/>
-            <a:ext cx="1371600" cy="347472"/>
-          </a:xfrm>
-          <a:prstGeom prst="rect">
-            <a:avLst/>
-          </a:prstGeom>
-          <a:noFill/>
-          <a:ln/>
-        </p:spPr>
-        <p:txBody>
-          <a:bodyPr wrap="square" lIns="0" tIns="0" rIns="0" bIns="0" rtlCol="0" anchor="ctr"/>
-          <a:lstStyle/>
-          <a:p>
-            <a:pPr marL="0" indent="0" algn="r">
-              <a:buNone/>
-            </a:pPr>
-            <a:r>
-              <a:rPr lang="en-US" sz="1300" b="1">
-                <a:solidFill>
-                  <a:srgbClr val="5C5C5C"/>
-                </a:solidFill>
-                <a:latin typeface="Calibri" pitchFamily="34" charset="0"/>
-                <a:ea typeface="Calibri" pitchFamily="34" charset="-122"/>
-                <a:cs typeface="Calibri" pitchFamily="34" charset="-120"/>
-              </a:rPr>
-              <a:t>30 m²</a:t>
-            </a:r>
-            <a:endParaRPr lang="en-US" sz="1300"/>
-          </a:p>
-        </p:txBody>
-      </p:sp>
-      <p:sp>
-        <p:nvSpPr>
-          <p:cNvPr id="24" name="ZoneTexte 23">
-            <a:extLst>
-              <a:ext uri="{FF2B5EF4-FFF2-40B4-BE49-F238E27FC236}">
-                <a16:creationId xmlns:a16="http://schemas.microsoft.com/office/drawing/2014/main" id="{C106A661-2575-6245-3E6F-94BC562A8A54}"/>
-              </a:ext>
-            </a:extLst>
-          </p:cNvPr>
-          <p:cNvSpPr txBox="1"/>
-          <p:nvPr/>
-        </p:nvSpPr>
-        <p:spPr>
-          <a:xfrm>
-            <a:off x="3373308" y="3780656"/>
-            <a:ext cx="6160956" cy="523220"/>
-          </a:xfrm>
-          <a:prstGeom prst="rect">
-            <a:avLst/>
-          </a:prstGeom>
-          <a:noFill/>
-        </p:spPr>
-        <p:txBody>
-          <a:bodyPr wrap="square">
-            <a:spAutoFit/>
-          </a:bodyPr>
-          <a:lstStyle/>
-          <a:p>
-            <a:r>
-              <a:rPr lang="fr-FR" sz="1400" b="0" i="0">
-                <a:solidFill>
-                  <a:srgbClr val="161616"/>
-                </a:solidFill>
-                <a:effectLst/>
-                <a:latin typeface="Marianne" panose="02000000000000000000" pitchFamily="2" charset="0"/>
-              </a:rPr>
-              <a:t>Un jardin de pluie est une zone peu profonde et végétalisée, intégrée dans la gestion des eaux pluviales pour le traitement et le stockage. </a:t>
-            </a:r>
-            <a:endParaRPr lang="fr-FR" sz="1400">
-              <a:latin typeface="Aptos" panose="020B0004020202020204" pitchFamily="34" charset="0"/>
-            </a:endParaRPr>
-          </a:p>
-        </p:txBody>
-      </p:sp>
-      <p:sp>
-        <p:nvSpPr>
-          <p:cNvPr id="25" name="ZoneTexte 24">
-            <a:extLst>
-              <a:ext uri="{FF2B5EF4-FFF2-40B4-BE49-F238E27FC236}">
-                <a16:creationId xmlns:a16="http://schemas.microsoft.com/office/drawing/2014/main" id="{E1AAF3A9-5B3C-A7E6-56C3-EC75348A43B1}"/>
-              </a:ext>
-            </a:extLst>
-          </p:cNvPr>
-          <p:cNvSpPr txBox="1"/>
-          <p:nvPr/>
-        </p:nvSpPr>
-        <p:spPr>
-          <a:xfrm>
-            <a:off x="3388298" y="4358580"/>
-            <a:ext cx="6160956" cy="276999"/>
-          </a:xfrm>
-          <a:prstGeom prst="rect">
-            <a:avLst/>
-          </a:prstGeom>
-          <a:noFill/>
-        </p:spPr>
-        <p:txBody>
-          <a:bodyPr wrap="square">
-            <a:spAutoFit/>
-          </a:bodyPr>
-          <a:lstStyle/>
-          <a:p>
-            <a:r>
-              <a:rPr lang="en-US" sz="1200" i="1">
+              <a:t> : {{</a:t>
+            </a:r>
+            <a:r>
+              <a:rPr lang="en-US" sz="1200" i="1" dirty="0" err="1">
                 <a:solidFill>
                   <a:srgbClr val="2C2C2C"/>
                 </a:solidFill>
@@ -6585,264 +6435,10 @@
                 <a:ea typeface="Calibri" pitchFamily="34" charset="-122"/>
                 <a:cs typeface="Calibri" pitchFamily="34" charset="-120"/>
               </a:rPr>
-              <a:t>Inv. 80 - 120 € HT / m²·   Ent. 5 - 10 € HT / m² / an</a:t>
-            </a:r>
-          </a:p>
-        </p:txBody>
-      </p:sp>
-      <p:pic>
-        <p:nvPicPr>
-          <p:cNvPr id="27" name="Image 26" descr="Une image contenant personne, habits, plein air, herbe&#10;&#10;Description générée automatiquement">
-            <a:extLst>
-              <a:ext uri="{FF2B5EF4-FFF2-40B4-BE49-F238E27FC236}">
-                <a16:creationId xmlns:a16="http://schemas.microsoft.com/office/drawing/2014/main" id="{473D6B79-E3C3-6616-712C-D2B887C82B30}"/>
-              </a:ext>
-            </a:extLst>
-          </p:cNvPr>
-          <p:cNvPicPr>
-            <a:picLocks noChangeAspect="1"/>
-          </p:cNvPicPr>
-          <p:nvPr/>
-        </p:nvPicPr>
-        <p:blipFill>
-          <a:blip r:embed="rId3"/>
-          <a:stretch>
-            <a:fillRect/>
-          </a:stretch>
-        </p:blipFill>
-        <p:spPr>
-          <a:xfrm>
-            <a:off x="2287458" y="3590701"/>
-            <a:ext cx="864042" cy="881152"/>
-          </a:xfrm>
-          <a:prstGeom prst="rect">
-            <a:avLst/>
-          </a:prstGeom>
-        </p:spPr>
-      </p:pic>
-      <p:sp>
-        <p:nvSpPr>
-          <p:cNvPr id="28" name="Shape 4">
-            <a:extLst>
-              <a:ext uri="{FF2B5EF4-FFF2-40B4-BE49-F238E27FC236}">
-                <a16:creationId xmlns:a16="http://schemas.microsoft.com/office/drawing/2014/main" id="{9400B597-029D-928F-0B3C-403D200A5165}"/>
-              </a:ext>
-            </a:extLst>
-          </p:cNvPr>
-          <p:cNvSpPr/>
-          <p:nvPr/>
-        </p:nvSpPr>
-        <p:spPr>
-          <a:xfrm>
-            <a:off x="2053652" y="4885165"/>
-            <a:ext cx="8229600" cy="1234440"/>
-          </a:xfrm>
-          <a:prstGeom prst="roundRect">
-            <a:avLst>
-              <a:gd name="adj" fmla="val 5926"/>
-            </a:avLst>
-          </a:prstGeom>
-          <a:solidFill>
-            <a:srgbClr val="FFFFFF"/>
-          </a:solidFill>
-          <a:ln w="8890">
-            <a:solidFill>
-              <a:srgbClr val="DADADA"/>
-            </a:solidFill>
-            <a:prstDash val="solid"/>
-          </a:ln>
-          <a:effectLst>
-            <a:outerShdw blurRad="76200" dist="25400" dir="2700000" algn="bl" rotWithShape="0">
-              <a:srgbClr val="000000">
-                <a:alpha val="8000"/>
-              </a:srgbClr>
-            </a:outerShdw>
-          </a:effectLst>
-        </p:spPr>
-        <p:txBody>
-          <a:bodyPr/>
-          <a:lstStyle/>
-          <a:p>
-            <a:endParaRPr lang="fr-FR"/>
-          </a:p>
-        </p:txBody>
-      </p:sp>
-      <p:sp>
-        <p:nvSpPr>
-          <p:cNvPr id="29" name="ZoneTexte 28">
-            <a:extLst>
-              <a:ext uri="{FF2B5EF4-FFF2-40B4-BE49-F238E27FC236}">
-                <a16:creationId xmlns:a16="http://schemas.microsoft.com/office/drawing/2014/main" id="{8B0C4CFA-5BA2-3AF7-FE77-A64AF9904E86}"/>
-              </a:ext>
-            </a:extLst>
-          </p:cNvPr>
-          <p:cNvSpPr txBox="1"/>
-          <p:nvPr/>
-        </p:nvSpPr>
-        <p:spPr>
-          <a:xfrm>
-            <a:off x="3373308" y="4965698"/>
-            <a:ext cx="7515927" cy="307777"/>
-          </a:xfrm>
-          <a:prstGeom prst="rect">
-            <a:avLst/>
-          </a:prstGeom>
-          <a:noFill/>
-        </p:spPr>
-        <p:txBody>
-          <a:bodyPr wrap="square">
-            <a:spAutoFit/>
-          </a:bodyPr>
-          <a:lstStyle/>
-          <a:p>
-            <a:pPr marL="0" indent="0">
-              <a:buNone/>
-            </a:pPr>
-            <a:r>
-              <a:rPr lang="en-US" sz="1400" b="1">
-                <a:solidFill>
-                  <a:srgbClr val="1A1A1A"/>
-                </a:solidFill>
-                <a:latin typeface="Calibri" pitchFamily="34" charset="0"/>
-                <a:ea typeface="Calibri" pitchFamily="34" charset="-122"/>
-                <a:cs typeface="Calibri" pitchFamily="34" charset="-120"/>
-              </a:rPr>
-              <a:t>Arbres de pluie</a:t>
-            </a:r>
-            <a:endParaRPr lang="en-US" sz="1400"/>
-          </a:p>
-        </p:txBody>
-      </p:sp>
-      <p:sp>
-        <p:nvSpPr>
-          <p:cNvPr id="30" name="Text 8">
-            <a:extLst>
-              <a:ext uri="{FF2B5EF4-FFF2-40B4-BE49-F238E27FC236}">
-                <a16:creationId xmlns:a16="http://schemas.microsoft.com/office/drawing/2014/main" id="{E1026DA3-40E9-24B8-EB7F-8F7DCDFD240F}"/>
-              </a:ext>
-            </a:extLst>
-          </p:cNvPr>
-          <p:cNvSpPr/>
-          <p:nvPr/>
-        </p:nvSpPr>
-        <p:spPr>
-          <a:xfrm>
-            <a:off x="8657469" y="5011126"/>
-            <a:ext cx="1371600" cy="347472"/>
-          </a:xfrm>
-          <a:prstGeom prst="rect">
-            <a:avLst/>
-          </a:prstGeom>
-          <a:noFill/>
-          <a:ln/>
-        </p:spPr>
-        <p:txBody>
-          <a:bodyPr wrap="square" lIns="0" tIns="0" rIns="0" bIns="0" rtlCol="0" anchor="ctr"/>
-          <a:lstStyle/>
-          <a:p>
-            <a:pPr marL="0" indent="0" algn="r">
-              <a:buNone/>
-            </a:pPr>
-            <a:r>
-              <a:rPr lang="en-US" sz="1300" b="1">
-                <a:solidFill>
-                  <a:srgbClr val="5C5C5C"/>
-                </a:solidFill>
-                <a:latin typeface="Calibri" pitchFamily="34" charset="0"/>
-                <a:ea typeface="Calibri" pitchFamily="34" charset="-122"/>
-                <a:cs typeface="Calibri" pitchFamily="34" charset="-120"/>
-              </a:rPr>
-              <a:t>4 </a:t>
-            </a:r>
-            <a:r>
-              <a:rPr lang="en-US" sz="1300" b="1" err="1">
-                <a:solidFill>
-                  <a:srgbClr val="5C5C5C"/>
-                </a:solidFill>
-                <a:latin typeface="Calibri" pitchFamily="34" charset="0"/>
-                <a:ea typeface="Calibri" pitchFamily="34" charset="-122"/>
-                <a:cs typeface="Calibri" pitchFamily="34" charset="-120"/>
-              </a:rPr>
-              <a:t>unités</a:t>
-            </a:r>
-            <a:endParaRPr lang="en-US" sz="1300"/>
-          </a:p>
-        </p:txBody>
-      </p:sp>
-      <p:sp>
-        <p:nvSpPr>
-          <p:cNvPr id="31" name="ZoneTexte 30">
-            <a:extLst>
-              <a:ext uri="{FF2B5EF4-FFF2-40B4-BE49-F238E27FC236}">
-                <a16:creationId xmlns:a16="http://schemas.microsoft.com/office/drawing/2014/main" id="{073548CE-0DE5-689F-1B43-4A0C20AF7044}"/>
-              </a:ext>
-            </a:extLst>
-          </p:cNvPr>
-          <p:cNvSpPr txBox="1"/>
-          <p:nvPr/>
-        </p:nvSpPr>
-        <p:spPr>
-          <a:xfrm>
-            <a:off x="3373308" y="5252014"/>
-            <a:ext cx="6160956" cy="523220"/>
-          </a:xfrm>
-          <a:prstGeom prst="rect">
-            <a:avLst/>
-          </a:prstGeom>
-          <a:noFill/>
-        </p:spPr>
-        <p:txBody>
-          <a:bodyPr wrap="square">
-            <a:spAutoFit/>
-          </a:bodyPr>
-          <a:lstStyle/>
-          <a:p>
-            <a:r>
-              <a:rPr lang="fr-FR" sz="1400" b="0" i="0">
-                <a:solidFill>
-                  <a:srgbClr val="161616"/>
-                </a:solidFill>
-                <a:effectLst/>
-                <a:latin typeface="Marianne" panose="02000000000000000000" pitchFamily="2" charset="0"/>
-              </a:rPr>
-              <a:t>La fosse de plantation de ces arbres permet de recevoir, stocker et infiltrer les eaux de ruissellement.</a:t>
-            </a:r>
-            <a:endParaRPr lang="fr-FR" sz="1400">
-              <a:latin typeface="Aptos" panose="020B0004020202020204" pitchFamily="34" charset="0"/>
-            </a:endParaRPr>
-          </a:p>
-        </p:txBody>
-      </p:sp>
-      <p:sp>
-        <p:nvSpPr>
-          <p:cNvPr id="32" name="ZoneTexte 31">
-            <a:extLst>
-              <a:ext uri="{FF2B5EF4-FFF2-40B4-BE49-F238E27FC236}">
-                <a16:creationId xmlns:a16="http://schemas.microsoft.com/office/drawing/2014/main" id="{0102955A-3B6D-C934-F89D-2A875A948A50}"/>
-              </a:ext>
-            </a:extLst>
-          </p:cNvPr>
-          <p:cNvSpPr txBox="1"/>
-          <p:nvPr/>
-        </p:nvSpPr>
-        <p:spPr>
-          <a:xfrm>
-            <a:off x="3388298" y="5829938"/>
-            <a:ext cx="6160956" cy="276999"/>
-          </a:xfrm>
-          <a:prstGeom prst="rect">
-            <a:avLst/>
-          </a:prstGeom>
-          <a:noFill/>
-        </p:spPr>
-        <p:txBody>
-          <a:bodyPr wrap="square">
-            <a:spAutoFit/>
-          </a:bodyPr>
-          <a:lstStyle/>
-          <a:p>
-            <a:r>
-              <a:rPr lang="en-US" sz="1200" i="1">
+              <a:t>cout_investissement_materiau</a:t>
+            </a:r>
+            <a:r>
+              <a:rPr lang="en-US" sz="1200" i="1" dirty="0">
                 <a:solidFill>
                   <a:srgbClr val="2C2C2C"/>
                 </a:solidFill>
@@ -6850,10 +6446,10 @@
                 <a:ea typeface="Calibri" pitchFamily="34" charset="-122"/>
                 <a:cs typeface="Calibri" pitchFamily="34" charset="-120"/>
               </a:rPr>
-              <a:t>Inv. 2500 - 3500 € HT / unite ·   Ent. 40 - 50 € HT / </a:t>
-            </a:r>
-            <a:r>
-              <a:rPr lang="en-US" sz="1200" i="1" err="1">
+              <a:t>}} · Entretien : {{</a:t>
+            </a:r>
+            <a:r>
+              <a:rPr lang="en-US" sz="1200" i="1" dirty="0" err="1">
                 <a:solidFill>
                   <a:srgbClr val="2C2C2C"/>
                 </a:solidFill>
@@ -6861,10 +6457,10 @@
                 <a:ea typeface="Calibri" pitchFamily="34" charset="-122"/>
                 <a:cs typeface="Calibri" pitchFamily="34" charset="-120"/>
               </a:rPr>
-              <a:t>unité</a:t>
-            </a:r>
-            <a:r>
-              <a:rPr lang="en-US" sz="1200" i="1">
+              <a:t>cout_entretien_materiau</a:t>
+            </a:r>
+            <a:r>
+              <a:rPr lang="en-US" sz="1200" i="1" dirty="0">
                 <a:solidFill>
                   <a:srgbClr val="2C2C2C"/>
                 </a:solidFill>
@@ -6872,41 +6468,12 @@
                 <a:ea typeface="Calibri" pitchFamily="34" charset="-122"/>
                 <a:cs typeface="Calibri" pitchFamily="34" charset="-120"/>
               </a:rPr>
-              <a:t> / an</a:t>
-            </a:r>
-          </a:p>
-        </p:txBody>
-      </p:sp>
-      <p:pic>
-        <p:nvPicPr>
-          <p:cNvPr id="33" name="Image 32" descr="Une image contenant personne, habits, plein air, herbe&#10;&#10;Description générée automatiquement">
-            <a:extLst>
-              <a:ext uri="{FF2B5EF4-FFF2-40B4-BE49-F238E27FC236}">
-                <a16:creationId xmlns:a16="http://schemas.microsoft.com/office/drawing/2014/main" id="{737FBF9E-1CAD-719F-D7EC-E8FD54594E20}"/>
-              </a:ext>
-            </a:extLst>
-          </p:cNvPr>
-          <p:cNvPicPr>
-            <a:picLocks noChangeAspect="1"/>
-          </p:cNvPicPr>
-          <p:nvPr/>
-        </p:nvPicPr>
-        <p:blipFill>
-          <a:blip r:embed="rId3"/>
-          <a:stretch>
-            <a:fillRect/>
-          </a:stretch>
-        </p:blipFill>
-        <p:spPr>
-          <a:xfrm>
-            <a:off x="2287458" y="5062059"/>
-            <a:ext cx="864042" cy="881152"/>
-          </a:xfrm>
-          <a:prstGeom prst="rect">
-            <a:avLst/>
-          </a:prstGeom>
-        </p:spPr>
-      </p:pic>
+              <a:t>}}</a:t>
+            </a:r>
+            <a:endParaRPr lang="en-US" sz="1200" dirty="0"/>
+          </a:p>
+        </p:txBody>
+      </p:sp>
       <p:sp>
         <p:nvSpPr>
           <p:cNvPr id="3" name="Titre 1">
@@ -7058,7 +6625,7 @@
           <p:nvPr/>
         </p:nvPicPr>
         <p:blipFill>
-          <a:blip r:embed="rId4"/>
+          <a:blip r:embed="rId3"/>
           <a:srcRect t="19804" b="18118"/>
           <a:stretch/>
         </p:blipFill>
@@ -7087,7 +6654,7 @@
           <p:nvPr/>
         </p:nvPicPr>
         <p:blipFill>
-          <a:blip r:embed="rId5"/>
+          <a:blip r:embed="rId4"/>
           <a:stretch>
             <a:fillRect/>
           </a:stretch>

</xml_diff>